<commit_message>
Fix chart XML for Google Slides compatibility (slides 7+)
Co-Authored-By: Claude Sonnet 5.5 <noreply@anthropic.com>
Claude-Session: https://claude.ai/code/session_01C8esidZTnz37pFUEU5sMqP
</commit_message>
<xml_diff>
--- a/MorningHands_Business_Analysis.pptx
+++ b/MorningHands_Business_Analysis.pptx
@@ -184,7 +184,7 @@
 <file path=ppt/charts/chart1.xml><?xml version="1.0" encoding="utf-8"?>
 <c:chartSpace xmlns:c="http://schemas.openxmlformats.org/drawingml/2006/chart" xmlns:a="http://schemas.openxmlformats.org/drawingml/2006/main" xmlns:r="http://schemas.openxmlformats.org/officeDocument/2006/relationships">
   <c:date1904 val="0"/>
-  <c:roundedCorners val="1"/>
+  <c:roundedCorners val="0"/>
   <c:chart>
     <c:title>
       <c:tx>
@@ -197,7 +197,7 @@
                 <a:solidFill>
                   <a:srgbClr val="1B1F3B"/>
                 </a:solidFill>
-                <a:latin typeface="+mn-lt"/>
+                <a:latin typeface="Malgun Gothic"/>
               </a:defRPr>
             </a:pPr>
             <a:r>
@@ -205,7 +205,7 @@
                 <a:solidFill>
                   <a:srgbClr val="1B1F3B"/>
                 </a:solidFill>
-                <a:latin typeface="+mn-lt"/>
+                <a:latin typeface="Malgun Gothic"/>
               </a:rPr>
               <a:t>1년 매출 추정 (백만 달러)</a:t>
             </a:r>
@@ -243,30 +243,6 @@
             <a:effectLst/>
           </c:spPr>
           <c:invertIfNegative val="0"/>
-          <c:dLbls>
-            <c:numFmt formatCode="$0.0&quot;M&quot;" sourceLinked="0"/>
-            <c:txPr>
-              <a:bodyPr/>
-              <a:lstStyle/>
-              <a:p>
-                <a:pPr>
-                  <a:defRPr b="1" i="0" strike="noStrike" sz="1200" u="none">
-                    <a:solidFill>
-                      <a:srgbClr val="1B1F3B"/>
-                    </a:solidFill>
-                    <a:latin typeface="+mn-lt"/>
-                  </a:defRPr>
-                </a:pPr>
-              </a:p>
-            </c:txPr>
-            <c:showLegendKey val="0"/>
-            <c:showVal val="1"/>
-            <c:showCatName val="0"/>
-            <c:showSerName val="0"/>
-            <c:showPercent val="0"/>
-            <c:showBubbleSize val="0"/>
-            <c:showLeaderLines val="0"/>
-          </c:dLbls>
           <c:dPt>
             <c:idx val="0"/>
             <c:invertIfNegative val="0"/>
@@ -289,21 +265,43 @@
               <a:effectLst/>
             </c:spPr>
           </c:dPt>
+          <c:dLbls>
+            <c:numFmt formatCode="$0.0&quot;M&quot;" sourceLinked="0"/>
+            <c:txPr>
+              <a:bodyPr/>
+              <a:lstStyle/>
+              <a:p>
+                <a:pPr>
+                  <a:defRPr b="1" i="0" strike="noStrike" sz="1200" u="none">
+                    <a:solidFill>
+                      <a:srgbClr val="1B1F3B"/>
+                    </a:solidFill>
+                    <a:latin typeface="Malgun Gothic"/>
+                  </a:defRPr>
+                </a:pPr>
+              </a:p>
+            </c:txPr>
+            <c:showLegendKey val="0"/>
+            <c:showVal val="1"/>
+            <c:showCatName val="0"/>
+            <c:showSerName val="0"/>
+            <c:showPercent val="0"/>
+            <c:showBubbleSize val="0"/>
+            <c:showLeaderLines val="0"/>
+          </c:dLbls>
           <c:cat>
-            <c:multiLvlStrRef>
+            <c:strRef>
               <c:f>Sheet1!$A$2:$A$3</c:f>
-              <c:multiLvlStrCache>
+              <c:strCache>
                 <c:ptCount val="2"/>
-                <c:lvl>
-                  <c:pt idx="0">
-                    <c:v>Clocky형</c:v>
-                  </c:pt>
-                  <c:pt idx="1">
-                    <c:v>Hatch형</c:v>
-                  </c:pt>
-                </c:lvl>
-              </c:multiLvlStrCache>
-            </c:multiLvlStrRef>
+                <c:pt idx="0">
+                  <c:v>Clocky형</c:v>
+                </c:pt>
+                <c:pt idx="1">
+                  <c:v>Hatch형</c:v>
+                </c:pt>
+              </c:strCache>
+            </c:strRef>
           </c:cat>
           <c:val>
             <c:numRef>
@@ -332,7 +330,7 @@
                   <a:solidFill>
                     <a:srgbClr val="1B1F3B"/>
                   </a:solidFill>
-                  <a:latin typeface="+mn-lt"/>
+                  <a:latin typeface="Malgun Gothic"/>
                 </a:defRPr>
               </a:pPr>
             </a:p>
@@ -380,7 +378,7 @@
                 <a:solidFill>
                   <a:srgbClr val="2E3566"/>
                 </a:solidFill>
-                <a:latin typeface="+mn-lt"/>
+                <a:latin typeface="Malgun Gothic"/>
               </a:defRPr>
             </a:pPr>
             <a:endParaRPr lang="en-US"/>
@@ -423,7 +421,7 @@
                 <a:solidFill>
                   <a:srgbClr val="2E3566"/>
                 </a:solidFill>
-                <a:latin typeface="+mn-lt"/>
+                <a:latin typeface="Malgun Gothic"/>
               </a:defRPr>
             </a:pPr>
             <a:endParaRPr lang="en-US"/>
@@ -460,7 +458,7 @@
 <file path=ppt/charts/chart2.xml><?xml version="1.0" encoding="utf-8"?>
 <c:chartSpace xmlns:c="http://schemas.openxmlformats.org/drawingml/2006/chart" xmlns:a="http://schemas.openxmlformats.org/drawingml/2006/main" xmlns:r="http://schemas.openxmlformats.org/officeDocument/2006/relationships">
   <c:date1904 val="0"/>
-  <c:roundedCorners val="1"/>
+  <c:roundedCorners val="0"/>
   <c:chart>
     <c:title>
       <c:tx>
@@ -473,7 +471,7 @@
                 <a:solidFill>
                   <a:srgbClr val="1B1F3B"/>
                 </a:solidFill>
-                <a:latin typeface="+mn-lt"/>
+                <a:latin typeface="Malgun Gothic"/>
               </a:defRPr>
             </a:pPr>
             <a:r>
@@ -481,7 +479,7 @@
                 <a:solidFill>
                   <a:srgbClr val="1B1F3B"/>
                 </a:solidFill>
-                <a:latin typeface="+mn-lt"/>
+                <a:latin typeface="Malgun Gothic"/>
               </a:rPr>
               <a:t>비용·이익 구성 (매출 100%)</a:t>
             </a:r>
@@ -530,7 +528,7 @@
                     <a:solidFill>
                       <a:srgbClr val="1B1F3B"/>
                     </a:solidFill>
-                    <a:latin typeface="+mn-lt"/>
+                    <a:latin typeface="Malgun Gothic"/>
                   </a:defRPr>
                 </a:pPr>
               </a:p>
@@ -544,20 +542,18 @@
             <c:showLeaderLines val="0"/>
           </c:dLbls>
           <c:cat>
-            <c:multiLvlStrRef>
+            <c:strRef>
               <c:f>Sheet1!$A$2:$A$3</c:f>
-              <c:multiLvlStrCache>
+              <c:strCache>
                 <c:ptCount val="2"/>
-                <c:lvl>
-                  <c:pt idx="0">
-                    <c:v>Clocky형</c:v>
-                  </c:pt>
-                  <c:pt idx="1">
-                    <c:v>Hatch형</c:v>
-                  </c:pt>
-                </c:lvl>
-              </c:multiLvlStrCache>
-            </c:multiLvlStrRef>
+                <c:pt idx="0">
+                  <c:v>Clocky형</c:v>
+                </c:pt>
+                <c:pt idx="1">
+                  <c:v>Hatch형</c:v>
+                </c:pt>
+              </c:strCache>
+            </c:strRef>
           </c:cat>
           <c:val>
             <c:numRef>
@@ -607,7 +603,7 @@
                     <a:solidFill>
                       <a:srgbClr val="1B1F3B"/>
                     </a:solidFill>
-                    <a:latin typeface="+mn-lt"/>
+                    <a:latin typeface="Malgun Gothic"/>
                   </a:defRPr>
                 </a:pPr>
               </a:p>
@@ -621,20 +617,18 @@
             <c:showLeaderLines val="0"/>
           </c:dLbls>
           <c:cat>
-            <c:multiLvlStrRef>
+            <c:strRef>
               <c:f>Sheet1!$A$2:$A$3</c:f>
-              <c:multiLvlStrCache>
+              <c:strCache>
                 <c:ptCount val="2"/>
-                <c:lvl>
-                  <c:pt idx="0">
-                    <c:v>Clocky형</c:v>
-                  </c:pt>
-                  <c:pt idx="1">
-                    <c:v>Hatch형</c:v>
-                  </c:pt>
-                </c:lvl>
-              </c:multiLvlStrCache>
-            </c:multiLvlStrRef>
+                <c:pt idx="0">
+                  <c:v>Clocky형</c:v>
+                </c:pt>
+                <c:pt idx="1">
+                  <c:v>Hatch형</c:v>
+                </c:pt>
+              </c:strCache>
+            </c:strRef>
           </c:cat>
           <c:val>
             <c:numRef>
@@ -684,7 +678,7 @@
                     <a:solidFill>
                       <a:srgbClr val="1B1F3B"/>
                     </a:solidFill>
-                    <a:latin typeface="+mn-lt"/>
+                    <a:latin typeface="Malgun Gothic"/>
                   </a:defRPr>
                 </a:pPr>
               </a:p>
@@ -698,20 +692,18 @@
             <c:showLeaderLines val="0"/>
           </c:dLbls>
           <c:cat>
-            <c:multiLvlStrRef>
+            <c:strRef>
               <c:f>Sheet1!$A$2:$A$3</c:f>
-              <c:multiLvlStrCache>
+              <c:strCache>
                 <c:ptCount val="2"/>
-                <c:lvl>
-                  <c:pt idx="0">
-                    <c:v>Clocky형</c:v>
-                  </c:pt>
-                  <c:pt idx="1">
-                    <c:v>Hatch형</c:v>
-                  </c:pt>
-                </c:lvl>
-              </c:multiLvlStrCache>
-            </c:multiLvlStrRef>
+                <c:pt idx="0">
+                  <c:v>Clocky형</c:v>
+                </c:pt>
+                <c:pt idx="1">
+                  <c:v>Hatch형</c:v>
+                </c:pt>
+              </c:strCache>
+            </c:strRef>
           </c:cat>
           <c:val>
             <c:numRef>
@@ -761,7 +753,7 @@
                     <a:solidFill>
                       <a:srgbClr val="1B1F3B"/>
                     </a:solidFill>
-                    <a:latin typeface="+mn-lt"/>
+                    <a:latin typeface="Malgun Gothic"/>
                   </a:defRPr>
                 </a:pPr>
               </a:p>
@@ -775,20 +767,18 @@
             <c:showLeaderLines val="0"/>
           </c:dLbls>
           <c:cat>
-            <c:multiLvlStrRef>
+            <c:strRef>
               <c:f>Sheet1!$A$2:$A$3</c:f>
-              <c:multiLvlStrCache>
+              <c:strCache>
                 <c:ptCount val="2"/>
-                <c:lvl>
-                  <c:pt idx="0">
-                    <c:v>Clocky형</c:v>
-                  </c:pt>
-                  <c:pt idx="1">
-                    <c:v>Hatch형</c:v>
-                  </c:pt>
-                </c:lvl>
-              </c:multiLvlStrCache>
-            </c:multiLvlStrRef>
+                <c:pt idx="0">
+                  <c:v>Clocky형</c:v>
+                </c:pt>
+                <c:pt idx="1">
+                  <c:v>Hatch형</c:v>
+                </c:pt>
+              </c:strCache>
+            </c:strRef>
           </c:cat>
           <c:val>
             <c:numRef>
@@ -838,7 +828,7 @@
                     <a:solidFill>
                       <a:srgbClr val="1B1F3B"/>
                     </a:solidFill>
-                    <a:latin typeface="+mn-lt"/>
+                    <a:latin typeface="Malgun Gothic"/>
                   </a:defRPr>
                 </a:pPr>
               </a:p>
@@ -852,20 +842,18 @@
             <c:showLeaderLines val="0"/>
           </c:dLbls>
           <c:cat>
-            <c:multiLvlStrRef>
+            <c:strRef>
               <c:f>Sheet1!$A$2:$A$3</c:f>
-              <c:multiLvlStrCache>
+              <c:strCache>
                 <c:ptCount val="2"/>
-                <c:lvl>
-                  <c:pt idx="0">
-                    <c:v>Clocky형</c:v>
-                  </c:pt>
-                  <c:pt idx="1">
-                    <c:v>Hatch형</c:v>
-                  </c:pt>
-                </c:lvl>
-              </c:multiLvlStrCache>
-            </c:multiLvlStrRef>
+                <c:pt idx="0">
+                  <c:v>Clocky형</c:v>
+                </c:pt>
+                <c:pt idx="1">
+                  <c:v>Hatch형</c:v>
+                </c:pt>
+              </c:strCache>
+            </c:strRef>
           </c:cat>
           <c:val>
             <c:numRef>
@@ -915,7 +903,7 @@
                     <a:solidFill>
                       <a:srgbClr val="1B1F3B"/>
                     </a:solidFill>
-                    <a:latin typeface="+mn-lt"/>
+                    <a:latin typeface="Malgun Gothic"/>
                   </a:defRPr>
                 </a:pPr>
               </a:p>
@@ -929,20 +917,18 @@
             <c:showLeaderLines val="0"/>
           </c:dLbls>
           <c:cat>
-            <c:multiLvlStrRef>
+            <c:strRef>
               <c:f>Sheet1!$A$2:$A$3</c:f>
-              <c:multiLvlStrCache>
+              <c:strCache>
                 <c:ptCount val="2"/>
-                <c:lvl>
-                  <c:pt idx="0">
-                    <c:v>Clocky형</c:v>
-                  </c:pt>
-                  <c:pt idx="1">
-                    <c:v>Hatch형</c:v>
-                  </c:pt>
-                </c:lvl>
-              </c:multiLvlStrCache>
-            </c:multiLvlStrRef>
+                <c:pt idx="0">
+                  <c:v>Clocky형</c:v>
+                </c:pt>
+                <c:pt idx="1">
+                  <c:v>Hatch형</c:v>
+                </c:pt>
+              </c:strCache>
+            </c:strRef>
           </c:cat>
           <c:val>
             <c:numRef>
@@ -992,7 +978,7 @@
                     <a:solidFill>
                       <a:srgbClr val="1B1F3B"/>
                     </a:solidFill>
-                    <a:latin typeface="+mn-lt"/>
+                    <a:latin typeface="Malgun Gothic"/>
                   </a:defRPr>
                 </a:pPr>
               </a:p>
@@ -1006,20 +992,18 @@
             <c:showLeaderLines val="0"/>
           </c:dLbls>
           <c:cat>
-            <c:multiLvlStrRef>
+            <c:strRef>
               <c:f>Sheet1!$A$2:$A$3</c:f>
-              <c:multiLvlStrCache>
+              <c:strCache>
                 <c:ptCount val="2"/>
-                <c:lvl>
-                  <c:pt idx="0">
-                    <c:v>Clocky형</c:v>
-                  </c:pt>
-                  <c:pt idx="1">
-                    <c:v>Hatch형</c:v>
-                  </c:pt>
-                </c:lvl>
-              </c:multiLvlStrCache>
-            </c:multiLvlStrRef>
+                <c:pt idx="0">
+                  <c:v>Clocky형</c:v>
+                </c:pt>
+                <c:pt idx="1">
+                  <c:v>Hatch형</c:v>
+                </c:pt>
+              </c:strCache>
+            </c:strRef>
           </c:cat>
           <c:val>
             <c:numRef>
@@ -1048,7 +1032,7 @@
                   <a:solidFill>
                     <a:srgbClr val="1B1F3B"/>
                   </a:solidFill>
-                  <a:latin typeface="+mn-lt"/>
+                  <a:latin typeface="Malgun Gothic"/>
                 </a:defRPr>
               </a:pPr>
             </a:p>
@@ -1096,7 +1080,7 @@
                 <a:solidFill>
                   <a:srgbClr val="2E3566"/>
                 </a:solidFill>
-                <a:latin typeface="+mn-lt"/>
+                <a:latin typeface="Malgun Gothic"/>
               </a:defRPr>
             </a:pPr>
             <a:endParaRPr lang="en-US"/>
@@ -1148,7 +1132,7 @@
                 <a:solidFill>
                   <a:srgbClr val="2E3566"/>
                 </a:solidFill>
-                <a:latin typeface="+mn-lt"/>
+                <a:latin typeface="Malgun Gothic"/>
               </a:defRPr>
             </a:pPr>
             <a:endParaRPr lang="en-US"/>
@@ -1178,8 +1162,8 @@
               <a:solidFill>
                 <a:srgbClr val="2E3566"/>
               </a:solidFill>
-              <a:latin typeface="+mn-lt"/>
-              <a:cs typeface="+mn-lt"/>
+              <a:latin typeface="Malgun Gothic"/>
+              <a:cs typeface="Malgun Gothic"/>
             </a:defRPr>
           </a:pPr>
           <a:endParaRPr lang="en-US"/>
@@ -1205,7 +1189,7 @@
 <file path=ppt/charts/chart3.xml><?xml version="1.0" encoding="utf-8"?>
 <c:chartSpace xmlns:c="http://schemas.openxmlformats.org/drawingml/2006/chart" xmlns:a="http://schemas.openxmlformats.org/drawingml/2006/main" xmlns:r="http://schemas.openxmlformats.org/officeDocument/2006/relationships">
   <c:date1904 val="0"/>
-  <c:roundedCorners val="1"/>
+  <c:roundedCorners val="0"/>
   <c:chart>
     <c:title>
       <c:tx>
@@ -1218,7 +1202,7 @@
                 <a:solidFill>
                   <a:srgbClr val="1B1F3B"/>
                 </a:solidFill>
-                <a:latin typeface="+mn-lt"/>
+                <a:latin typeface="Malgun Gothic"/>
               </a:defRPr>
             </a:pPr>
             <a:r>
@@ -1226,7 +1210,7 @@
                 <a:solidFill>
                   <a:srgbClr val="1B1F3B"/>
                 </a:solidFill>
-                <a:latin typeface="+mn-lt"/>
+                <a:latin typeface="Malgun Gothic"/>
               </a:rPr>
               <a:t>가격 포지션 (달러)</a:t>
             </a:r>
@@ -1264,30 +1248,6 @@
             <a:effectLst/>
           </c:spPr>
           <c:invertIfNegative val="0"/>
-          <c:dLbls>
-            <c:numFmt formatCode="$0" sourceLinked="0"/>
-            <c:txPr>
-              <a:bodyPr/>
-              <a:lstStyle/>
-              <a:p>
-                <a:pPr>
-                  <a:defRPr b="1" i="0" strike="noStrike" sz="1200" u="none">
-                    <a:solidFill>
-                      <a:srgbClr val="1B1F3B"/>
-                    </a:solidFill>
-                    <a:latin typeface="+mn-lt"/>
-                  </a:defRPr>
-                </a:pPr>
-              </a:p>
-            </c:txPr>
-            <c:showLegendKey val="0"/>
-            <c:showVal val="1"/>
-            <c:showCatName val="0"/>
-            <c:showSerName val="0"/>
-            <c:showPercent val="0"/>
-            <c:showBubbleSize val="0"/>
-            <c:showLeaderLines val="0"/>
-          </c:dLbls>
           <c:dPt>
             <c:idx val="0"/>
             <c:invertIfNegative val="0"/>
@@ -1332,27 +1292,49 @@
               <a:effectLst/>
             </c:spPr>
           </c:dPt>
+          <c:dLbls>
+            <c:numFmt formatCode="$0" sourceLinked="0"/>
+            <c:txPr>
+              <a:bodyPr/>
+              <a:lstStyle/>
+              <a:p>
+                <a:pPr>
+                  <a:defRPr b="1" i="0" strike="noStrike" sz="1200" u="none">
+                    <a:solidFill>
+                      <a:srgbClr val="1B1F3B"/>
+                    </a:solidFill>
+                    <a:latin typeface="Malgun Gothic"/>
+                  </a:defRPr>
+                </a:pPr>
+              </a:p>
+            </c:txPr>
+            <c:showLegendKey val="0"/>
+            <c:showVal val="1"/>
+            <c:showCatName val="0"/>
+            <c:showSerName val="0"/>
+            <c:showPercent val="0"/>
+            <c:showBubbleSize val="0"/>
+            <c:showLeaderLines val="0"/>
+          </c:dLbls>
           <c:cat>
-            <c:multiLvlStrRef>
+            <c:strRef>
               <c:f>Sheet1!$A$2:$A$5</c:f>
-              <c:multiLvlStrCache>
+              <c:strCache>
                 <c:ptCount val="4"/>
-                <c:lvl>
-                  <c:pt idx="0">
-                    <c:v>Sonic Bomb 세트</c:v>
-                  </c:pt>
-                  <c:pt idx="1">
-                    <c:v>Clocky</c:v>
-                  </c:pt>
-                  <c:pt idx="2">
-                    <c:v>우리 제품</c:v>
-                  </c:pt>
-                  <c:pt idx="3">
-                    <c:v>Hatch Restore 3</c:v>
-                  </c:pt>
-                </c:lvl>
-              </c:multiLvlStrCache>
-            </c:multiLvlStrRef>
+                <c:pt idx="0">
+                  <c:v>Sonic Bomb 세트</c:v>
+                </c:pt>
+                <c:pt idx="1">
+                  <c:v>Clocky</c:v>
+                </c:pt>
+                <c:pt idx="2">
+                  <c:v>우리 제품</c:v>
+                </c:pt>
+                <c:pt idx="3">
+                  <c:v>Hatch Restore 3</c:v>
+                </c:pt>
+              </c:strCache>
+            </c:strRef>
           </c:cat>
           <c:val>
             <c:numRef>
@@ -1387,7 +1369,7 @@
                   <a:solidFill>
                     <a:srgbClr val="1B1F3B"/>
                   </a:solidFill>
-                  <a:latin typeface="+mn-lt"/>
+                  <a:latin typeface="Malgun Gothic"/>
                 </a:defRPr>
               </a:pPr>
             </a:p>
@@ -1435,7 +1417,7 @@
                 <a:solidFill>
                   <a:srgbClr val="2E3566"/>
                 </a:solidFill>
-                <a:latin typeface="+mn-lt"/>
+                <a:latin typeface="Malgun Gothic"/>
               </a:defRPr>
             </a:pPr>
             <a:endParaRPr lang="en-US"/>
@@ -1478,7 +1460,7 @@
                 <a:solidFill>
                   <a:srgbClr val="2E3566"/>
                 </a:solidFill>
-                <a:latin typeface="+mn-lt"/>
+                <a:latin typeface="Malgun Gothic"/>
               </a:defRPr>
             </a:pPr>
             <a:endParaRPr lang="en-US"/>
@@ -1515,7 +1497,7 @@
 <file path=ppt/charts/chart4.xml><?xml version="1.0" encoding="utf-8"?>
 <c:chartSpace xmlns:c="http://schemas.openxmlformats.org/drawingml/2006/chart" xmlns:a="http://schemas.openxmlformats.org/drawingml/2006/main" xmlns:r="http://schemas.openxmlformats.org/officeDocument/2006/relationships">
   <c:date1904 val="0"/>
-  <c:roundedCorners val="1"/>
+  <c:roundedCorners val="0"/>
   <c:chart>
     <c:autoTitleDeleted val="1"/>
     <c:plotArea>
@@ -1997,8 +1979,8 @@
               <a:solidFill>
                 <a:srgbClr val="2E3566"/>
               </a:solidFill>
-              <a:latin typeface="+mn-lt"/>
-              <a:cs typeface="+mn-lt"/>
+              <a:latin typeface="Malgun Gothic"/>
+              <a:cs typeface="Malgun Gothic"/>
             </a:defRPr>
           </a:pPr>
           <a:endParaRPr lang="en-US"/>
@@ -2024,7 +2006,7 @@
 <file path=ppt/charts/chart5.xml><?xml version="1.0" encoding="utf-8"?>
 <c:chartSpace xmlns:c="http://schemas.openxmlformats.org/drawingml/2006/chart" xmlns:a="http://schemas.openxmlformats.org/drawingml/2006/main" xmlns:r="http://schemas.openxmlformats.org/officeDocument/2006/relationships">
   <c:date1904 val="0"/>
-  <c:roundedCorners val="1"/>
+  <c:roundedCorners val="0"/>
   <c:chart>
     <c:title>
       <c:tx>
@@ -2037,7 +2019,7 @@
                 <a:solidFill>
                   <a:srgbClr val="1B1F3B"/>
                 </a:solidFill>
-                <a:latin typeface="+mn-lt"/>
+                <a:latin typeface="Malgun Gothic"/>
               </a:defRPr>
             </a:pPr>
             <a:r>
@@ -2045,7 +2027,7 @@
                 <a:solidFill>
                   <a:srgbClr val="1B1F3B"/>
                 </a:solidFill>
-                <a:latin typeface="+mn-lt"/>
+                <a:latin typeface="Malgun Gothic"/>
               </a:rPr>
               <a:t>월별 판매 대수 (기본안, 합계 10,000대)</a:t>
             </a:r>
@@ -2094,7 +2076,7 @@
                     <a:solidFill>
                       <a:srgbClr val="1B1F3B"/>
                     </a:solidFill>
-                    <a:latin typeface="+mn-lt"/>
+                    <a:latin typeface="Malgun Gothic"/>
                   </a:defRPr>
                 </a:pPr>
               </a:p>
@@ -2108,50 +2090,48 @@
             <c:showLeaderLines val="0"/>
           </c:dLbls>
           <c:cat>
-            <c:multiLvlStrRef>
+            <c:strRef>
               <c:f>Sheet1!$A$2:$A$13</c:f>
-              <c:multiLvlStrCache>
+              <c:strCache>
                 <c:ptCount val="12"/>
-                <c:lvl>
-                  <c:pt idx="0">
-                    <c:v>1월</c:v>
-                  </c:pt>
-                  <c:pt idx="1">
-                    <c:v>2월</c:v>
-                  </c:pt>
-                  <c:pt idx="2">
-                    <c:v>3월</c:v>
-                  </c:pt>
-                  <c:pt idx="3">
-                    <c:v>4월</c:v>
-                  </c:pt>
-                  <c:pt idx="4">
-                    <c:v>5월</c:v>
-                  </c:pt>
-                  <c:pt idx="5">
-                    <c:v>6월</c:v>
-                  </c:pt>
-                  <c:pt idx="6">
-                    <c:v>7월</c:v>
-                  </c:pt>
-                  <c:pt idx="7">
-                    <c:v>8월</c:v>
-                  </c:pt>
-                  <c:pt idx="8">
-                    <c:v>9월</c:v>
-                  </c:pt>
-                  <c:pt idx="9">
-                    <c:v>10월</c:v>
-                  </c:pt>
-                  <c:pt idx="10">
-                    <c:v>11월</c:v>
-                  </c:pt>
-                  <c:pt idx="11">
-                    <c:v>12월</c:v>
-                  </c:pt>
-                </c:lvl>
-              </c:multiLvlStrCache>
-            </c:multiLvlStrRef>
+                <c:pt idx="0">
+                  <c:v>1월</c:v>
+                </c:pt>
+                <c:pt idx="1">
+                  <c:v>2월</c:v>
+                </c:pt>
+                <c:pt idx="2">
+                  <c:v>3월</c:v>
+                </c:pt>
+                <c:pt idx="3">
+                  <c:v>4월</c:v>
+                </c:pt>
+                <c:pt idx="4">
+                  <c:v>5월</c:v>
+                </c:pt>
+                <c:pt idx="5">
+                  <c:v>6월</c:v>
+                </c:pt>
+                <c:pt idx="6">
+                  <c:v>7월</c:v>
+                </c:pt>
+                <c:pt idx="7">
+                  <c:v>8월</c:v>
+                </c:pt>
+                <c:pt idx="8">
+                  <c:v>9월</c:v>
+                </c:pt>
+                <c:pt idx="9">
+                  <c:v>10월</c:v>
+                </c:pt>
+                <c:pt idx="10">
+                  <c:v>11월</c:v>
+                </c:pt>
+                <c:pt idx="11">
+                  <c:v>12월</c:v>
+                </c:pt>
+              </c:strCache>
+            </c:strRef>
           </c:cat>
           <c:val>
             <c:numRef>
@@ -2210,7 +2190,7 @@
                   <a:solidFill>
                     <a:srgbClr val="1B1F3B"/>
                   </a:solidFill>
-                  <a:latin typeface="+mn-lt"/>
+                  <a:latin typeface="Malgun Gothic"/>
                 </a:defRPr>
               </a:pPr>
             </a:p>
@@ -2258,7 +2238,7 @@
                 <a:solidFill>
                   <a:srgbClr val="2E3566"/>
                 </a:solidFill>
-                <a:latin typeface="+mn-lt"/>
+                <a:latin typeface="Malgun Gothic"/>
               </a:defRPr>
             </a:pPr>
             <a:endParaRPr lang="en-US"/>
@@ -2301,7 +2281,7 @@
                 <a:solidFill>
                   <a:srgbClr val="2E3566"/>
                 </a:solidFill>
-                <a:latin typeface="+mn-lt"/>
+                <a:latin typeface="Malgun Gothic"/>
               </a:defRPr>
             </a:pPr>
             <a:endParaRPr lang="en-US"/>
@@ -2338,7 +2318,7 @@
 <file path=ppt/charts/chart6.xml><?xml version="1.0" encoding="utf-8"?>
 <c:chartSpace xmlns:c="http://schemas.openxmlformats.org/drawingml/2006/chart" xmlns:a="http://schemas.openxmlformats.org/drawingml/2006/main" xmlns:r="http://schemas.openxmlformats.org/officeDocument/2006/relationships">
   <c:date1904 val="0"/>
-  <c:roundedCorners val="1"/>
+  <c:roundedCorners val="0"/>
   <c:chart>
     <c:title>
       <c:tx>
@@ -2351,7 +2331,7 @@
                 <a:solidFill>
                   <a:srgbClr val="1B1F3B"/>
                 </a:solidFill>
-                <a:latin typeface="+mn-lt"/>
+                <a:latin typeface="Malgun Gothic"/>
               </a:defRPr>
             </a:pPr>
             <a:r>
@@ -2359,7 +2339,7 @@
                 <a:solidFill>
                   <a:srgbClr val="1B1F3B"/>
                 </a:solidFill>
-                <a:latin typeface="+mn-lt"/>
+                <a:latin typeface="Malgun Gothic"/>
               </a:rPr>
               <a:t>매출액과 영업이익 (억원)</a:t>
             </a:r>
@@ -2408,7 +2388,7 @@
                     <a:solidFill>
                       <a:srgbClr val="1B1F3B"/>
                     </a:solidFill>
-                    <a:latin typeface="+mn-lt"/>
+                    <a:latin typeface="Malgun Gothic"/>
                   </a:defRPr>
                 </a:pPr>
               </a:p>
@@ -2422,23 +2402,21 @@
             <c:showLeaderLines val="0"/>
           </c:dLbls>
           <c:cat>
-            <c:multiLvlStrRef>
+            <c:strRef>
               <c:f>Sheet1!$A$2:$A$4</c:f>
-              <c:multiLvlStrCache>
+              <c:strCache>
                 <c:ptCount val="3"/>
-                <c:lvl>
-                  <c:pt idx="0">
-                    <c:v>1년차</c:v>
-                  </c:pt>
-                  <c:pt idx="1">
-                    <c:v>2년차</c:v>
-                  </c:pt>
-                  <c:pt idx="2">
-                    <c:v>3년차</c:v>
-                  </c:pt>
-                </c:lvl>
-              </c:multiLvlStrCache>
-            </c:multiLvlStrRef>
+                <c:pt idx="0">
+                  <c:v>1년차</c:v>
+                </c:pt>
+                <c:pt idx="1">
+                  <c:v>2년차</c:v>
+                </c:pt>
+                <c:pt idx="2">
+                  <c:v>3년차</c:v>
+                </c:pt>
+              </c:strCache>
+            </c:strRef>
           </c:cat>
           <c:val>
             <c:numRef>
@@ -2491,7 +2469,7 @@
                     <a:solidFill>
                       <a:srgbClr val="1B1F3B"/>
                     </a:solidFill>
-                    <a:latin typeface="+mn-lt"/>
+                    <a:latin typeface="Malgun Gothic"/>
                   </a:defRPr>
                 </a:pPr>
               </a:p>
@@ -2505,23 +2483,21 @@
             <c:showLeaderLines val="0"/>
           </c:dLbls>
           <c:cat>
-            <c:multiLvlStrRef>
+            <c:strRef>
               <c:f>Sheet1!$A$2:$A$4</c:f>
-              <c:multiLvlStrCache>
+              <c:strCache>
                 <c:ptCount val="3"/>
-                <c:lvl>
-                  <c:pt idx="0">
-                    <c:v>1년차</c:v>
-                  </c:pt>
-                  <c:pt idx="1">
-                    <c:v>2년차</c:v>
-                  </c:pt>
-                  <c:pt idx="2">
-                    <c:v>3년차</c:v>
-                  </c:pt>
-                </c:lvl>
-              </c:multiLvlStrCache>
-            </c:multiLvlStrRef>
+                <c:pt idx="0">
+                  <c:v>1년차</c:v>
+                </c:pt>
+                <c:pt idx="1">
+                  <c:v>2년차</c:v>
+                </c:pt>
+                <c:pt idx="2">
+                  <c:v>3년차</c:v>
+                </c:pt>
+              </c:strCache>
+            </c:strRef>
           </c:cat>
           <c:val>
             <c:numRef>
@@ -2553,7 +2529,7 @@
                   <a:solidFill>
                     <a:srgbClr val="1B1F3B"/>
                   </a:solidFill>
-                  <a:latin typeface="+mn-lt"/>
+                  <a:latin typeface="Malgun Gothic"/>
                 </a:defRPr>
               </a:pPr>
             </a:p>
@@ -2601,7 +2577,7 @@
                 <a:solidFill>
                   <a:srgbClr val="2E3566"/>
                 </a:solidFill>
-                <a:latin typeface="+mn-lt"/>
+                <a:latin typeface="Malgun Gothic"/>
               </a:defRPr>
             </a:pPr>
             <a:endParaRPr lang="en-US"/>
@@ -2644,7 +2620,7 @@
                 <a:solidFill>
                   <a:srgbClr val="2E3566"/>
                 </a:solidFill>
-                <a:latin typeface="+mn-lt"/>
+                <a:latin typeface="Malgun Gothic"/>
               </a:defRPr>
             </a:pPr>
             <a:endParaRPr lang="en-US"/>
@@ -2674,8 +2650,8 @@
               <a:solidFill>
                 <a:srgbClr val="2E3566"/>
               </a:solidFill>
-              <a:latin typeface="+mn-lt"/>
-              <a:cs typeface="+mn-lt"/>
+              <a:latin typeface="Malgun Gothic"/>
+              <a:cs typeface="Malgun Gothic"/>
             </a:defRPr>
           </a:pPr>
           <a:endParaRPr lang="en-US"/>
@@ -2701,7 +2677,7 @@
 <file path=ppt/charts/chart7.xml><?xml version="1.0" encoding="utf-8"?>
 <c:chartSpace xmlns:c="http://schemas.openxmlformats.org/drawingml/2006/chart" xmlns:a="http://schemas.openxmlformats.org/drawingml/2006/main" xmlns:r="http://schemas.openxmlformats.org/officeDocument/2006/relationships">
   <c:date1904 val="0"/>
-  <c:roundedCorners val="1"/>
+  <c:roundedCorners val="0"/>
   <c:chart>
     <c:title>
       <c:tx>
@@ -2714,7 +2690,7 @@
                 <a:solidFill>
                   <a:srgbClr val="1B1F3B"/>
                 </a:solidFill>
-                <a:latin typeface="+mn-lt"/>
+                <a:latin typeface="Malgun Gothic"/>
               </a:defRPr>
             </a:pPr>
             <a:r>
@@ -2722,7 +2698,7 @@
                 <a:solidFill>
                   <a:srgbClr val="1B1F3B"/>
                 </a:solidFill>
-                <a:latin typeface="+mn-lt"/>
+                <a:latin typeface="Malgun Gothic"/>
               </a:rPr>
               <a:t>매출 대비 기부 비율</a:t>
             </a:r>
@@ -2760,30 +2736,6 @@
             <a:effectLst/>
           </c:spPr>
           <c:invertIfNegative val="0"/>
-          <c:dLbls>
-            <c:numFmt formatCode="0.0&quot;%&quot;" sourceLinked="0"/>
-            <c:txPr>
-              <a:bodyPr/>
-              <a:lstStyle/>
-              <a:p>
-                <a:pPr>
-                  <a:defRPr b="1" i="0" strike="noStrike" sz="1200" u="none">
-                    <a:solidFill>
-                      <a:srgbClr val="1B1F3B"/>
-                    </a:solidFill>
-                    <a:latin typeface="+mn-lt"/>
-                  </a:defRPr>
-                </a:pPr>
-              </a:p>
-            </c:txPr>
-            <c:showLegendKey val="0"/>
-            <c:showVal val="1"/>
-            <c:showCatName val="0"/>
-            <c:showSerName val="0"/>
-            <c:showPercent val="0"/>
-            <c:showBubbleSize val="0"/>
-            <c:showLeaderLines val="0"/>
-          </c:dLbls>
           <c:dPt>
             <c:idx val="0"/>
             <c:invertIfNegative val="0"/>
@@ -2817,24 +2769,46 @@
               <a:effectLst/>
             </c:spPr>
           </c:dPt>
+          <c:dLbls>
+            <c:numFmt formatCode="0.0&quot;%&quot;" sourceLinked="0"/>
+            <c:txPr>
+              <a:bodyPr/>
+              <a:lstStyle/>
+              <a:p>
+                <a:pPr>
+                  <a:defRPr b="1" i="0" strike="noStrike" sz="1200" u="none">
+                    <a:solidFill>
+                      <a:srgbClr val="1B1F3B"/>
+                    </a:solidFill>
+                    <a:latin typeface="Malgun Gothic"/>
+                  </a:defRPr>
+                </a:pPr>
+              </a:p>
+            </c:txPr>
+            <c:showLegendKey val="0"/>
+            <c:showVal val="1"/>
+            <c:showCatName val="0"/>
+            <c:showSerName val="0"/>
+            <c:showPercent val="0"/>
+            <c:showBubbleSize val="0"/>
+            <c:showLeaderLines val="0"/>
+          </c:dLbls>
           <c:cat>
-            <c:multiLvlStrRef>
+            <c:strRef>
               <c:f>Sheet1!$A$2:$A$4</c:f>
-              <c:multiLvlStrCache>
+              <c:strCache>
                 <c:ptCount val="3"/>
-                <c:lvl>
-                  <c:pt idx="0">
-                    <c:v>국내 대기업 평균</c:v>
-                  </c:pt>
-                  <c:pt idx="1">
-                    <c:v>우리 제안</c:v>
-                  </c:pt>
-                  <c:pt idx="2">
-                    <c:v>Patagonia</c:v>
-                  </c:pt>
-                </c:lvl>
-              </c:multiLvlStrCache>
-            </c:multiLvlStrRef>
+                <c:pt idx="0">
+                  <c:v>국내 대기업 평균</c:v>
+                </c:pt>
+                <c:pt idx="1">
+                  <c:v>우리 제안</c:v>
+                </c:pt>
+                <c:pt idx="2">
+                  <c:v>Patagonia</c:v>
+                </c:pt>
+              </c:strCache>
+            </c:strRef>
           </c:cat>
           <c:val>
             <c:numRef>
@@ -2866,7 +2840,7 @@
                   <a:solidFill>
                     <a:srgbClr val="1B1F3B"/>
                   </a:solidFill>
-                  <a:latin typeface="+mn-lt"/>
+                  <a:latin typeface="Malgun Gothic"/>
                 </a:defRPr>
               </a:pPr>
             </a:p>
@@ -2914,7 +2888,7 @@
                 <a:solidFill>
                   <a:srgbClr val="2E3566"/>
                 </a:solidFill>
-                <a:latin typeface="+mn-lt"/>
+                <a:latin typeface="Malgun Gothic"/>
               </a:defRPr>
             </a:pPr>
             <a:endParaRPr lang="en-US"/>
@@ -2957,7 +2931,7 @@
                 <a:solidFill>
                   <a:srgbClr val="2E3566"/>
                 </a:solidFill>
-                <a:latin typeface="+mn-lt"/>
+                <a:latin typeface="Malgun Gothic"/>
               </a:defRPr>
             </a:pPr>
             <a:endParaRPr lang="en-US"/>
@@ -2994,7 +2968,7 @@
 <file path=ppt/charts/chart8.xml><?xml version="1.0" encoding="utf-8"?>
 <c:chartSpace xmlns:c="http://schemas.openxmlformats.org/drawingml/2006/chart" xmlns:a="http://schemas.openxmlformats.org/drawingml/2006/main" xmlns:r="http://schemas.openxmlformats.org/officeDocument/2006/relationships">
   <c:date1904 val="0"/>
-  <c:roundedCorners val="1"/>
+  <c:roundedCorners val="0"/>
   <c:chart>
     <c:autoTitleDeleted val="1"/>
     <c:plotArea>
@@ -3284,8 +3258,8 @@
               <a:solidFill>
                 <a:srgbClr val="2E3566"/>
               </a:solidFill>
-              <a:latin typeface="+mn-lt"/>
-              <a:cs typeface="+mn-lt"/>
+              <a:latin typeface="Malgun Gothic"/>
+              <a:cs typeface="Malgun Gothic"/>
             </a:defRPr>
           </a:pPr>
           <a:endParaRPr lang="en-US"/>

</xml_diff>

<commit_message>
Replace native charts with images for viewer compatibility
Co-Authored-By: Claude Sonnet 5.5 <noreply@anthropic.com>
Claude-Session: https://claude.ai/code/session_01C8esidZTnz37pFUEU5sMqP
</commit_message>
<xml_diff>
--- a/MorningHands_Business_Analysis.pptx
+++ b/MorningHands_Business_Analysis.pptx
@@ -127,17 +127,17 @@
   <p:extLst>
     <p:ext uri="{521415D9-36F7-43E2-AB2F-B90AF26B5E84}">
       <p14:sectionLst xmlns:p14="http://schemas.microsoft.com/office/powerpoint/2010/main">
-        <p14:section name="표지" id="{cd97e8ef-4728-9d57-6e9a-499fbde6eea9}">
+        <p14:section name="표지" id="{1c57769f-9ede-6a44-0401-7862c4896ca6}">
           <p14:sldIdLst>
             <p14:sldId id="256"/>
           </p14:sldIdLst>
         </p14:section>
-        <p14:section name="요약" id="{05d3161f-6a10-7f59-5e53-a7de6cc20a7e}">
+        <p14:section name="요약" id="{882a3736-207c-5051-e2f2-f67660a3d933}">
           <p14:sldIdLst>
             <p14:sldId id="257"/>
           </p14:sldIdLst>
         </p14:section>
-        <p14:section name="1부 경쟁 제품 조사" id="{aa09a8f5-7b45-0323-7ca1-2040e4716b5d}">
+        <p14:section name="1부 경쟁 제품 조사" id="{9aabe024-ab8a-465d-8f14-cac52adc17cb}">
           <p14:sldIdLst>
             <p14:sldId id="258"/>
             <p14:sldId id="259"/>
@@ -148,7 +148,7 @@
             <p14:sldId id="264"/>
           </p14:sldIdLst>
         </p14:section>
-        <p14:section name="2부 우리 제품 매출 예상" id="{0277d8f8-f9f4-382c-8b72-d2f41db83d8b}">
+        <p14:section name="2부 우리 제품 매출 예상" id="{bd1823f2-70d6-33c8-8e34-9bbc3399eca7}">
           <p14:sldIdLst>
             <p14:sldId id="265"/>
             <p14:sldId id="266"/>
@@ -158,7 +158,7 @@
             <p14:sldId id="270"/>
           </p14:sldIdLst>
         </p14:section>
-        <p14:section name="3부 사회 환원" id="{47e0f15f-0314-bf7e-c62d-cc7e3ac573b6}">
+        <p14:section name="3부 사회 환원" id="{e2479ea1-0c3f-80a6-8048-aa9bfe9c824c}">
           <p14:sldIdLst>
             <p14:sldId id="271"/>
             <p14:sldId id="272"/>
@@ -166,7 +166,7 @@
             <p14:sldId id="274"/>
           </p14:sldIdLst>
         </p14:section>
-        <p14:section name="실행 계획" id="{0af0c10b-c46d-ba73-8d5b-ab332950fbb8}">
+        <p14:section name="실행 계획" id="{79671dc0-b96f-2019-e822-96eeec1d7eb2}">
           <p14:sldIdLst>
             <p14:sldId id="275"/>
             <p14:sldId id="276"/>
@@ -179,3107 +179,6 @@
     </p:ext>
   </p:extLst>
 </p:presentation>
-</file>
-
-<file path=ppt/charts/chart1.xml><?xml version="1.0" encoding="utf-8"?>
-<c:chartSpace xmlns:c="http://schemas.openxmlformats.org/drawingml/2006/chart" xmlns:a="http://schemas.openxmlformats.org/drawingml/2006/main" xmlns:r="http://schemas.openxmlformats.org/officeDocument/2006/relationships">
-  <c:date1904 val="0"/>
-  <c:roundedCorners val="0"/>
-  <c:chart>
-    <c:title>
-      <c:tx>
-        <c:rich>
-          <a:bodyPr/>
-          <a:lstStyle/>
-          <a:p>
-            <a:pPr>
-              <a:defRPr sz="1400" b="0" i="0" u="none" strike="noStrike">
-                <a:solidFill>
-                  <a:srgbClr val="1B1F3B"/>
-                </a:solidFill>
-                <a:latin typeface="Malgun Gothic"/>
-              </a:defRPr>
-            </a:pPr>
-            <a:r>
-              <a:rPr sz="1400" b="0" i="0" u="none" strike="noStrike">
-                <a:solidFill>
-                  <a:srgbClr val="1B1F3B"/>
-                </a:solidFill>
-                <a:latin typeface="Malgun Gothic"/>
-              </a:rPr>
-              <a:t>1년 매출 추정 (백만 달러)</a:t>
-            </a:r>
-          </a:p>
-        </c:rich>
-      </c:tx>
-      <c:layout/>
-      <c:overlay val="0"/>
-    </c:title>
-    <c:autoTitleDeleted val="0"/>
-    <c:plotArea>
-      <c:layout/>
-      <c:barChart>
-        <c:barDir val="col"/>
-        <c:grouping val="clustered"/>
-        <c:varyColors val="0"/>
-        <c:ser>
-          <c:idx val="0"/>
-          <c:order val="0"/>
-          <c:tx>
-            <c:strRef>
-              <c:f>Sheet1!$B$1</c:f>
-              <c:strCache>
-                <c:ptCount val="1"/>
-                <c:pt idx="0">
-                  <c:v>연 매출 추정($M)</c:v>
-                </c:pt>
-              </c:strCache>
-            </c:strRef>
-          </c:tx>
-          <c:spPr>
-            <a:solidFill>
-              <a:srgbClr val="5B6ABF"/>
-            </a:solidFill>
-            <a:effectLst/>
-          </c:spPr>
-          <c:invertIfNegative val="0"/>
-          <c:dPt>
-            <c:idx val="0"/>
-            <c:invertIfNegative val="0"/>
-            <c:bubble3D val="0"/>
-            <c:spPr>
-              <a:solidFill>
-                <a:srgbClr val="5B6ABF"/>
-              </a:solidFill>
-              <a:effectLst/>
-            </c:spPr>
-          </c:dPt>
-          <c:dPt>
-            <c:idx val="1"/>
-            <c:invertIfNegative val="0"/>
-            <c:bubble3D val="0"/>
-            <c:spPr>
-              <a:solidFill>
-                <a:srgbClr val="F4A259"/>
-              </a:solidFill>
-              <a:effectLst/>
-            </c:spPr>
-          </c:dPt>
-          <c:dLbls>
-            <c:numFmt formatCode="$0.0&quot;M&quot;" sourceLinked="0"/>
-            <c:txPr>
-              <a:bodyPr/>
-              <a:lstStyle/>
-              <a:p>
-                <a:pPr>
-                  <a:defRPr b="1" i="0" strike="noStrike" sz="1200" u="none">
-                    <a:solidFill>
-                      <a:srgbClr val="1B1F3B"/>
-                    </a:solidFill>
-                    <a:latin typeface="Malgun Gothic"/>
-                  </a:defRPr>
-                </a:pPr>
-              </a:p>
-            </c:txPr>
-            <c:showLegendKey val="0"/>
-            <c:showVal val="1"/>
-            <c:showCatName val="0"/>
-            <c:showSerName val="0"/>
-            <c:showPercent val="0"/>
-            <c:showBubbleSize val="0"/>
-            <c:showLeaderLines val="0"/>
-          </c:dLbls>
-          <c:cat>
-            <c:strRef>
-              <c:f>Sheet1!$A$2:$A$3</c:f>
-              <c:strCache>
-                <c:ptCount val="2"/>
-                <c:pt idx="0">
-                  <c:v>Clocky형</c:v>
-                </c:pt>
-                <c:pt idx="1">
-                  <c:v>Hatch형</c:v>
-                </c:pt>
-              </c:strCache>
-            </c:strRef>
-          </c:cat>
-          <c:val>
-            <c:numRef>
-              <c:f>Sheet1!$B$2:$B$3</c:f>
-              <c:numCache>
-                <c:formatCode>General</c:formatCode>
-                <c:ptCount val="2"/>
-                <c:pt idx="0">
-                  <c:v>4</c:v>
-                </c:pt>
-                <c:pt idx="1">
-                  <c:v>10.2</c:v>
-                </c:pt>
-              </c:numCache>
-            </c:numRef>
-          </c:val>
-        </c:ser>
-        <c:dLbls>
-          <c:numFmt formatCode="$0.0&quot;M&quot;" sourceLinked="0"/>
-          <c:txPr>
-            <a:bodyPr/>
-            <a:lstStyle/>
-            <a:p>
-              <a:pPr>
-                <a:defRPr b="1" i="0" strike="noStrike" sz="1200" u="none">
-                  <a:solidFill>
-                    <a:srgbClr val="1B1F3B"/>
-                  </a:solidFill>
-                  <a:latin typeface="Malgun Gothic"/>
-                </a:defRPr>
-              </a:pPr>
-            </a:p>
-          </c:txPr>
-          <c:showLegendKey val="0"/>
-          <c:showVal val="1"/>
-          <c:showCatName val="0"/>
-          <c:showSerName val="0"/>
-          <c:showPercent val="0"/>
-          <c:showBubbleSize val="0"/>
-          <c:showLeaderLines val="0"/>
-        </c:dLbls>
-        <c:gapWidth val="60"/>
-        <c:overlap val="0"/>
-        <c:axId val="2094734554"/>
-        <c:axId val="2094734552"/>
-        <c:axId val="2094734556"/>
-      </c:barChart>
-      <c:catAx>
-        <c:axId val="2094734554"/>
-        <c:scaling>
-          <c:orientation val="minMax"/>
-        </c:scaling>
-        <c:delete val="0"/>
-        <c:axPos val="b"/>
-        <c:numFmt formatCode="General" sourceLinked="1"/>
-        <c:majorTickMark val="out"/>
-        <c:minorTickMark val="none"/>
-        <c:tickLblPos val="low"/>
-        <c:spPr>
-          <a:ln w="12700" cap="flat">
-            <a:solidFill>
-              <a:srgbClr val="888888"/>
-            </a:solidFill>
-            <a:prstDash val="solid"/>
-            <a:round/>
-          </a:ln>
-        </c:spPr>
-        <c:txPr>
-          <a:bodyPr/>
-          <a:lstStyle/>
-          <a:p>
-            <a:pPr>
-              <a:defRPr sz="1200" b="0" i="0" u="none" strike="noStrike">
-                <a:solidFill>
-                  <a:srgbClr val="2E3566"/>
-                </a:solidFill>
-                <a:latin typeface="Malgun Gothic"/>
-              </a:defRPr>
-            </a:pPr>
-            <a:endParaRPr lang="en-US"/>
-          </a:p>
-        </c:txPr>
-        <c:crossAx val="2094734552"/>
-        <c:crosses val="autoZero"/>
-        <c:auto val="1"/>
-        <c:lblAlgn val="ctr"/>
-        <c:noMultiLvlLbl val="1"/>
-      </c:catAx>
-      <c:valAx>
-        <c:axId val="2094734552"/>
-        <c:scaling>
-          <c:orientation val="minMax"/>
-          <c:max val="12"/>
-          <c:min val="0"/>
-        </c:scaling>
-        <c:delete val="1"/>
-        <c:axPos val="l"/>
-        <c:numFmt formatCode="General" sourceLinked="0"/>
-        <c:majorTickMark val="out"/>
-        <c:minorTickMark val="none"/>
-        <c:tickLblPos val="nextTo"/>
-        <c:spPr>
-          <a:ln w="12700" cap="flat">
-            <a:solidFill>
-              <a:srgbClr val="888888"/>
-            </a:solidFill>
-            <a:prstDash val="solid"/>
-            <a:round/>
-          </a:ln>
-        </c:spPr>
-        <c:txPr>
-          <a:bodyPr/>
-          <a:lstStyle/>
-          <a:p>
-            <a:pPr>
-              <a:defRPr sz="1200" b="0" i="0" u="none" strike="noStrike">
-                <a:solidFill>
-                  <a:srgbClr val="2E3566"/>
-                </a:solidFill>
-                <a:latin typeface="Malgun Gothic"/>
-              </a:defRPr>
-            </a:pPr>
-            <a:endParaRPr lang="en-US"/>
-          </a:p>
-        </c:txPr>
-        <c:crossAx val="2094734554"/>
-        <c:crosses val="autoZero"/>
-        <c:crossBetween val="between"/>
-      </c:valAx>
-      <c:spPr>
-        <a:noFill/>
-        <a:ln>
-          <a:noFill/>
-        </a:ln>
-        <a:effectLst/>
-      </c:spPr>
-    </c:plotArea>
-    <c:plotVisOnly val="1"/>
-    <c:dispBlanksAs val="span"/>
-  </c:chart>
-  <c:spPr>
-    <a:noFill/>
-    <a:ln>
-      <a:noFill/>
-    </a:ln>
-    <a:effectLst/>
-  </c:spPr>
-  <c:externalData r:id="rId1">
-    <c:autoUpdate val="0"/>
-  </c:externalData>
-</c:chartSpace>
-</file>
-
-<file path=ppt/charts/chart2.xml><?xml version="1.0" encoding="utf-8"?>
-<c:chartSpace xmlns:c="http://schemas.openxmlformats.org/drawingml/2006/chart" xmlns:a="http://schemas.openxmlformats.org/drawingml/2006/main" xmlns:r="http://schemas.openxmlformats.org/officeDocument/2006/relationships">
-  <c:date1904 val="0"/>
-  <c:roundedCorners val="0"/>
-  <c:chart>
-    <c:title>
-      <c:tx>
-        <c:rich>
-          <a:bodyPr/>
-          <a:lstStyle/>
-          <a:p>
-            <a:pPr>
-              <a:defRPr sz="1400" b="0" i="0" u="none" strike="noStrike">
-                <a:solidFill>
-                  <a:srgbClr val="1B1F3B"/>
-                </a:solidFill>
-                <a:latin typeface="Malgun Gothic"/>
-              </a:defRPr>
-            </a:pPr>
-            <a:r>
-              <a:rPr sz="1400" b="0" i="0" u="none" strike="noStrike">
-                <a:solidFill>
-                  <a:srgbClr val="1B1F3B"/>
-                </a:solidFill>
-                <a:latin typeface="Malgun Gothic"/>
-              </a:rPr>
-              <a:t>비용·이익 구성 (매출 100%)</a:t>
-            </a:r>
-          </a:p>
-        </c:rich>
-      </c:tx>
-      <c:layout/>
-      <c:overlay val="0"/>
-    </c:title>
-    <c:autoTitleDeleted val="0"/>
-    <c:plotArea>
-      <c:layout/>
-      <c:barChart>
-        <c:barDir val="col"/>
-        <c:grouping val="percentStacked"/>
-        <c:varyColors val="0"/>
-        <c:ser>
-          <c:idx val="0"/>
-          <c:order val="0"/>
-          <c:tx>
-            <c:strRef>
-              <c:f>Sheet1!$B$1</c:f>
-              <c:strCache>
-                <c:ptCount val="1"/>
-                <c:pt idx="0">
-                  <c:v>재료비</c:v>
-                </c:pt>
-              </c:strCache>
-            </c:strRef>
-          </c:tx>
-          <c:spPr>
-            <a:solidFill>
-              <a:srgbClr val="5B6ABF"/>
-            </a:solidFill>
-            <a:effectLst/>
-          </c:spPr>
-          <c:invertIfNegative val="0"/>
-          <c:dLbls>
-            <c:numFmt formatCode="#,##0" sourceLinked="0"/>
-            <c:txPr>
-              <a:bodyPr/>
-              <a:lstStyle/>
-              <a:p>
-                <a:pPr>
-                  <a:defRPr b="0" i="0" strike="noStrike" sz="1200" u="none">
-                    <a:solidFill>
-                      <a:srgbClr val="1B1F3B"/>
-                    </a:solidFill>
-                    <a:latin typeface="Malgun Gothic"/>
-                  </a:defRPr>
-                </a:pPr>
-              </a:p>
-            </c:txPr>
-            <c:showLegendKey val="0"/>
-            <c:showVal val="0"/>
-            <c:showCatName val="0"/>
-            <c:showSerName val="0"/>
-            <c:showPercent val="0"/>
-            <c:showBubbleSize val="0"/>
-            <c:showLeaderLines val="0"/>
-          </c:dLbls>
-          <c:cat>
-            <c:strRef>
-              <c:f>Sheet1!$A$2:$A$3</c:f>
-              <c:strCache>
-                <c:ptCount val="2"/>
-                <c:pt idx="0">
-                  <c:v>Clocky형</c:v>
-                </c:pt>
-                <c:pt idx="1">
-                  <c:v>Hatch형</c:v>
-                </c:pt>
-              </c:strCache>
-            </c:strRef>
-          </c:cat>
-          <c:val>
-            <c:numRef>
-              <c:f>Sheet1!$B$2:$B$3</c:f>
-              <c:numCache>
-                <c:formatCode>General</c:formatCode>
-                <c:ptCount val="2"/>
-                <c:pt idx="0">
-                  <c:v>24</c:v>
-                </c:pt>
-                <c:pt idx="1">
-                  <c:v>22</c:v>
-                </c:pt>
-              </c:numCache>
-            </c:numRef>
-          </c:val>
-        </c:ser>
-        <c:ser>
-          <c:idx val="1"/>
-          <c:order val="1"/>
-          <c:tx>
-            <c:strRef>
-              <c:f>Sheet1!$C$1</c:f>
-              <c:strCache>
-                <c:ptCount val="1"/>
-                <c:pt idx="0">
-                  <c:v>제작 인건비</c:v>
-                </c:pt>
-              </c:strCache>
-            </c:strRef>
-          </c:tx>
-          <c:spPr>
-            <a:solidFill>
-              <a:srgbClr val="B8C0E0"/>
-            </a:solidFill>
-            <a:effectLst/>
-          </c:spPr>
-          <c:invertIfNegative val="0"/>
-          <c:dLbls>
-            <c:numFmt formatCode="#,##0" sourceLinked="0"/>
-            <c:txPr>
-              <a:bodyPr/>
-              <a:lstStyle/>
-              <a:p>
-                <a:pPr>
-                  <a:defRPr b="0" i="0" strike="noStrike" sz="1200" u="none">
-                    <a:solidFill>
-                      <a:srgbClr val="1B1F3B"/>
-                    </a:solidFill>
-                    <a:latin typeface="Malgun Gothic"/>
-                  </a:defRPr>
-                </a:pPr>
-              </a:p>
-            </c:txPr>
-            <c:showLegendKey val="0"/>
-            <c:showVal val="0"/>
-            <c:showCatName val="0"/>
-            <c:showSerName val="0"/>
-            <c:showPercent val="0"/>
-            <c:showBubbleSize val="0"/>
-            <c:showLeaderLines val="0"/>
-          </c:dLbls>
-          <c:cat>
-            <c:strRef>
-              <c:f>Sheet1!$A$2:$A$3</c:f>
-              <c:strCache>
-                <c:ptCount val="2"/>
-                <c:pt idx="0">
-                  <c:v>Clocky형</c:v>
-                </c:pt>
-                <c:pt idx="1">
-                  <c:v>Hatch형</c:v>
-                </c:pt>
-              </c:strCache>
-            </c:strRef>
-          </c:cat>
-          <c:val>
-            <c:numRef>
-              <c:f>Sheet1!$C$2:$C$3</c:f>
-              <c:numCache>
-                <c:formatCode>General</c:formatCode>
-                <c:ptCount val="2"/>
-                <c:pt idx="0">
-                  <c:v>6</c:v>
-                </c:pt>
-                <c:pt idx="1">
-                  <c:v>4</c:v>
-                </c:pt>
-              </c:numCache>
-            </c:numRef>
-          </c:val>
-        </c:ser>
-        <c:ser>
-          <c:idx val="2"/>
-          <c:order val="2"/>
-          <c:tx>
-            <c:strRef>
-              <c:f>Sheet1!$D$1</c:f>
-              <c:strCache>
-                <c:ptCount val="1"/>
-                <c:pt idx="0">
-                  <c:v>물류·포장</c:v>
-                </c:pt>
-              </c:strCache>
-            </c:strRef>
-          </c:tx>
-          <c:spPr>
-            <a:solidFill>
-              <a:srgbClr val="8E9AAF"/>
-            </a:solidFill>
-            <a:effectLst/>
-          </c:spPr>
-          <c:invertIfNegative val="0"/>
-          <c:dLbls>
-            <c:numFmt formatCode="#,##0" sourceLinked="0"/>
-            <c:txPr>
-              <a:bodyPr/>
-              <a:lstStyle/>
-              <a:p>
-                <a:pPr>
-                  <a:defRPr b="0" i="0" strike="noStrike" sz="1200" u="none">
-                    <a:solidFill>
-                      <a:srgbClr val="1B1F3B"/>
-                    </a:solidFill>
-                    <a:latin typeface="Malgun Gothic"/>
-                  </a:defRPr>
-                </a:pPr>
-              </a:p>
-            </c:txPr>
-            <c:showLegendKey val="0"/>
-            <c:showVal val="0"/>
-            <c:showCatName val="0"/>
-            <c:showSerName val="0"/>
-            <c:showPercent val="0"/>
-            <c:showBubbleSize val="0"/>
-            <c:showLeaderLines val="0"/>
-          </c:dLbls>
-          <c:cat>
-            <c:strRef>
-              <c:f>Sheet1!$A$2:$A$3</c:f>
-              <c:strCache>
-                <c:ptCount val="2"/>
-                <c:pt idx="0">
-                  <c:v>Clocky형</c:v>
-                </c:pt>
-                <c:pt idx="1">
-                  <c:v>Hatch형</c:v>
-                </c:pt>
-              </c:strCache>
-            </c:strRef>
-          </c:cat>
-          <c:val>
-            <c:numRef>
-              <c:f>Sheet1!$D$2:$D$3</c:f>
-              <c:numCache>
-                <c:formatCode>General</c:formatCode>
-                <c:ptCount val="2"/>
-                <c:pt idx="0">
-                  <c:v>7</c:v>
-                </c:pt>
-                <c:pt idx="1">
-                  <c:v>5</c:v>
-                </c:pt>
-              </c:numCache>
-            </c:numRef>
-          </c:val>
-        </c:ser>
-        <c:ser>
-          <c:idx val="3"/>
-          <c:order val="3"/>
-          <c:tx>
-            <c:strRef>
-              <c:f>Sheet1!$E$1</c:f>
-              <c:strCache>
-                <c:ptCount val="1"/>
-                <c:pt idx="0">
-                  <c:v>판매 수수료·유통</c:v>
-                </c:pt>
-              </c:strCache>
-            </c:strRef>
-          </c:tx>
-          <c:spPr>
-            <a:solidFill>
-              <a:srgbClr val="E76F51"/>
-            </a:solidFill>
-            <a:effectLst/>
-          </c:spPr>
-          <c:invertIfNegative val="0"/>
-          <c:dLbls>
-            <c:numFmt formatCode="#,##0" sourceLinked="0"/>
-            <c:txPr>
-              <a:bodyPr/>
-              <a:lstStyle/>
-              <a:p>
-                <a:pPr>
-                  <a:defRPr b="0" i="0" strike="noStrike" sz="1200" u="none">
-                    <a:solidFill>
-                      <a:srgbClr val="1B1F3B"/>
-                    </a:solidFill>
-                    <a:latin typeface="Malgun Gothic"/>
-                  </a:defRPr>
-                </a:pPr>
-              </a:p>
-            </c:txPr>
-            <c:showLegendKey val="0"/>
-            <c:showVal val="0"/>
-            <c:showCatName val="0"/>
-            <c:showSerName val="0"/>
-            <c:showPercent val="0"/>
-            <c:showBubbleSize val="0"/>
-            <c:showLeaderLines val="0"/>
-          </c:dLbls>
-          <c:cat>
-            <c:strRef>
-              <c:f>Sheet1!$A$2:$A$3</c:f>
-              <c:strCache>
-                <c:ptCount val="2"/>
-                <c:pt idx="0">
-                  <c:v>Clocky형</c:v>
-                </c:pt>
-                <c:pt idx="1">
-                  <c:v>Hatch형</c:v>
-                </c:pt>
-              </c:strCache>
-            </c:strRef>
-          </c:cat>
-          <c:val>
-            <c:numRef>
-              <c:f>Sheet1!$E$2:$E$3</c:f>
-              <c:numCache>
-                <c:formatCode>General</c:formatCode>
-                <c:ptCount val="2"/>
-                <c:pt idx="0">
-                  <c:v>25</c:v>
-                </c:pt>
-                <c:pt idx="1">
-                  <c:v>15</c:v>
-                </c:pt>
-              </c:numCache>
-            </c:numRef>
-          </c:val>
-        </c:ser>
-        <c:ser>
-          <c:idx val="4"/>
-          <c:order val="4"/>
-          <c:tx>
-            <c:strRef>
-              <c:f>Sheet1!$F$1</c:f>
-              <c:strCache>
-                <c:ptCount val="1"/>
-                <c:pt idx="0">
-                  <c:v>마케팅</c:v>
-                </c:pt>
-              </c:strCache>
-            </c:strRef>
-          </c:tx>
-          <c:spPr>
-            <a:solidFill>
-              <a:srgbClr val="F4A259"/>
-            </a:solidFill>
-            <a:effectLst/>
-          </c:spPr>
-          <c:invertIfNegative val="0"/>
-          <c:dLbls>
-            <c:numFmt formatCode="#,##0" sourceLinked="0"/>
-            <c:txPr>
-              <a:bodyPr/>
-              <a:lstStyle/>
-              <a:p>
-                <a:pPr>
-                  <a:defRPr b="0" i="0" strike="noStrike" sz="1200" u="none">
-                    <a:solidFill>
-                      <a:srgbClr val="1B1F3B"/>
-                    </a:solidFill>
-                    <a:latin typeface="Malgun Gothic"/>
-                  </a:defRPr>
-                </a:pPr>
-              </a:p>
-            </c:txPr>
-            <c:showLegendKey val="0"/>
-            <c:showVal val="0"/>
-            <c:showCatName val="0"/>
-            <c:showSerName val="0"/>
-            <c:showPercent val="0"/>
-            <c:showBubbleSize val="0"/>
-            <c:showLeaderLines val="0"/>
-          </c:dLbls>
-          <c:cat>
-            <c:strRef>
-              <c:f>Sheet1!$A$2:$A$3</c:f>
-              <c:strCache>
-                <c:ptCount val="2"/>
-                <c:pt idx="0">
-                  <c:v>Clocky형</c:v>
-                </c:pt>
-                <c:pt idx="1">
-                  <c:v>Hatch형</c:v>
-                </c:pt>
-              </c:strCache>
-            </c:strRef>
-          </c:cat>
-          <c:val>
-            <c:numRef>
-              <c:f>Sheet1!$F$2:$F$3</c:f>
-              <c:numCache>
-                <c:formatCode>General</c:formatCode>
-                <c:ptCount val="2"/>
-                <c:pt idx="0">
-                  <c:v>12</c:v>
-                </c:pt>
-                <c:pt idx="1">
-                  <c:v>20</c:v>
-                </c:pt>
-              </c:numCache>
-            </c:numRef>
-          </c:val>
-        </c:ser>
-        <c:ser>
-          <c:idx val="5"/>
-          <c:order val="5"/>
-          <c:tx>
-            <c:strRef>
-              <c:f>Sheet1!$G$1</c:f>
-              <c:strCache>
-                <c:ptCount val="1"/>
-                <c:pt idx="0">
-                  <c:v>연구개발·관리</c:v>
-                </c:pt>
-              </c:strCache>
-            </c:strRef>
-          </c:tx>
-          <c:spPr>
-            <a:solidFill>
-              <a:srgbClr val="2E3566"/>
-            </a:solidFill>
-            <a:effectLst/>
-          </c:spPr>
-          <c:invertIfNegative val="0"/>
-          <c:dLbls>
-            <c:numFmt formatCode="#,##0" sourceLinked="0"/>
-            <c:txPr>
-              <a:bodyPr/>
-              <a:lstStyle/>
-              <a:p>
-                <a:pPr>
-                  <a:defRPr b="0" i="0" strike="noStrike" sz="1200" u="none">
-                    <a:solidFill>
-                      <a:srgbClr val="1B1F3B"/>
-                    </a:solidFill>
-                    <a:latin typeface="Malgun Gothic"/>
-                  </a:defRPr>
-                </a:pPr>
-              </a:p>
-            </c:txPr>
-            <c:showLegendKey val="0"/>
-            <c:showVal val="0"/>
-            <c:showCatName val="0"/>
-            <c:showSerName val="0"/>
-            <c:showPercent val="0"/>
-            <c:showBubbleSize val="0"/>
-            <c:showLeaderLines val="0"/>
-          </c:dLbls>
-          <c:cat>
-            <c:strRef>
-              <c:f>Sheet1!$A$2:$A$3</c:f>
-              <c:strCache>
-                <c:ptCount val="2"/>
-                <c:pt idx="0">
-                  <c:v>Clocky형</c:v>
-                </c:pt>
-                <c:pt idx="1">
-                  <c:v>Hatch형</c:v>
-                </c:pt>
-              </c:strCache>
-            </c:strRef>
-          </c:cat>
-          <c:val>
-            <c:numRef>
-              <c:f>Sheet1!$G$2:$G$3</c:f>
-              <c:numCache>
-                <c:formatCode>General</c:formatCode>
-                <c:ptCount val="2"/>
-                <c:pt idx="0">
-                  <c:v>16</c:v>
-                </c:pt>
-                <c:pt idx="1">
-                  <c:v>24</c:v>
-                </c:pt>
-              </c:numCache>
-            </c:numRef>
-          </c:val>
-        </c:ser>
-        <c:ser>
-          <c:idx val="6"/>
-          <c:order val="6"/>
-          <c:tx>
-            <c:strRef>
-              <c:f>Sheet1!$H$1</c:f>
-              <c:strCache>
-                <c:ptCount val="1"/>
-                <c:pt idx="0">
-                  <c:v>영업이익</c:v>
-                </c:pt>
-              </c:strCache>
-            </c:strRef>
-          </c:tx>
-          <c:spPr>
-            <a:solidFill>
-              <a:srgbClr val="3E8E7E"/>
-            </a:solidFill>
-            <a:effectLst/>
-          </c:spPr>
-          <c:invertIfNegative val="0"/>
-          <c:dLbls>
-            <c:numFmt formatCode="#,##0" sourceLinked="0"/>
-            <c:txPr>
-              <a:bodyPr/>
-              <a:lstStyle/>
-              <a:p>
-                <a:pPr>
-                  <a:defRPr b="0" i="0" strike="noStrike" sz="1200" u="none">
-                    <a:solidFill>
-                      <a:srgbClr val="1B1F3B"/>
-                    </a:solidFill>
-                    <a:latin typeface="Malgun Gothic"/>
-                  </a:defRPr>
-                </a:pPr>
-              </a:p>
-            </c:txPr>
-            <c:showLegendKey val="0"/>
-            <c:showVal val="0"/>
-            <c:showCatName val="0"/>
-            <c:showSerName val="0"/>
-            <c:showPercent val="0"/>
-            <c:showBubbleSize val="0"/>
-            <c:showLeaderLines val="0"/>
-          </c:dLbls>
-          <c:cat>
-            <c:strRef>
-              <c:f>Sheet1!$A$2:$A$3</c:f>
-              <c:strCache>
-                <c:ptCount val="2"/>
-                <c:pt idx="0">
-                  <c:v>Clocky형</c:v>
-                </c:pt>
-                <c:pt idx="1">
-                  <c:v>Hatch형</c:v>
-                </c:pt>
-              </c:strCache>
-            </c:strRef>
-          </c:cat>
-          <c:val>
-            <c:numRef>
-              <c:f>Sheet1!$H$2:$H$3</c:f>
-              <c:numCache>
-                <c:formatCode>General</c:formatCode>
-                <c:ptCount val="2"/>
-                <c:pt idx="0">
-                  <c:v>10</c:v>
-                </c:pt>
-                <c:pt idx="1">
-                  <c:v>10</c:v>
-                </c:pt>
-              </c:numCache>
-            </c:numRef>
-          </c:val>
-        </c:ser>
-        <c:dLbls>
-          <c:numFmt formatCode="#,##0" sourceLinked="0"/>
-          <c:txPr>
-            <a:bodyPr/>
-            <a:lstStyle/>
-            <a:p>
-              <a:pPr>
-                <a:defRPr b="0" i="0" strike="noStrike" sz="1200" u="none">
-                  <a:solidFill>
-                    <a:srgbClr val="1B1F3B"/>
-                  </a:solidFill>
-                  <a:latin typeface="Malgun Gothic"/>
-                </a:defRPr>
-              </a:pPr>
-            </a:p>
-          </c:txPr>
-          <c:showLegendKey val="0"/>
-          <c:showVal val="0"/>
-          <c:showCatName val="0"/>
-          <c:showSerName val="0"/>
-          <c:showPercent val="0"/>
-          <c:showBubbleSize val="0"/>
-          <c:showLeaderLines val="0"/>
-        </c:dLbls>
-        <c:gapWidth val="50"/>
-        <c:overlap val="100"/>
-        <c:axId val="2094734554"/>
-        <c:axId val="2094734552"/>
-        <c:axId val="2094734556"/>
-      </c:barChart>
-      <c:catAx>
-        <c:axId val="2094734554"/>
-        <c:scaling>
-          <c:orientation val="minMax"/>
-        </c:scaling>
-        <c:delete val="0"/>
-        <c:axPos val="b"/>
-        <c:numFmt formatCode="General" sourceLinked="1"/>
-        <c:majorTickMark val="out"/>
-        <c:minorTickMark val="none"/>
-        <c:tickLblPos val="low"/>
-        <c:spPr>
-          <a:ln w="12700" cap="flat">
-            <a:solidFill>
-              <a:srgbClr val="888888"/>
-            </a:solidFill>
-            <a:prstDash val="solid"/>
-            <a:round/>
-          </a:ln>
-        </c:spPr>
-        <c:txPr>
-          <a:bodyPr/>
-          <a:lstStyle/>
-          <a:p>
-            <a:pPr>
-              <a:defRPr sz="1200" b="0" i="0" u="none" strike="noStrike">
-                <a:solidFill>
-                  <a:srgbClr val="2E3566"/>
-                </a:solidFill>
-                <a:latin typeface="Malgun Gothic"/>
-              </a:defRPr>
-            </a:pPr>
-            <a:endParaRPr lang="en-US"/>
-          </a:p>
-        </c:txPr>
-        <c:crossAx val="2094734552"/>
-        <c:crosses val="autoZero"/>
-        <c:auto val="1"/>
-        <c:lblAlgn val="ctr"/>
-        <c:noMultiLvlLbl val="1"/>
-      </c:catAx>
-      <c:valAx>
-        <c:axId val="2094734552"/>
-        <c:scaling>
-          <c:orientation val="minMax"/>
-        </c:scaling>
-        <c:delete val="0"/>
-        <c:axPos val="l"/>
-        <c:majorGridlines>
-          <c:spPr>
-            <a:ln w="9525" cap="flat">
-              <a:solidFill>
-                <a:srgbClr val="DDE1EE"/>
-              </a:solidFill>
-              <a:prstDash val="solid"/>
-              <a:round/>
-            </a:ln>
-          </c:spPr>
-        </c:majorGridlines>
-        <c:numFmt formatCode="0%" sourceLinked="0"/>
-        <c:majorTickMark val="out"/>
-        <c:minorTickMark val="none"/>
-        <c:tickLblPos val="nextTo"/>
-        <c:spPr>
-          <a:ln w="12700" cap="flat">
-            <a:solidFill>
-              <a:srgbClr val="888888"/>
-            </a:solidFill>
-            <a:prstDash val="solid"/>
-            <a:round/>
-          </a:ln>
-        </c:spPr>
-        <c:txPr>
-          <a:bodyPr/>
-          <a:lstStyle/>
-          <a:p>
-            <a:pPr>
-              <a:defRPr sz="1200" b="0" i="0" u="none" strike="noStrike">
-                <a:solidFill>
-                  <a:srgbClr val="2E3566"/>
-                </a:solidFill>
-                <a:latin typeface="Malgun Gothic"/>
-              </a:defRPr>
-            </a:pPr>
-            <a:endParaRPr lang="en-US"/>
-          </a:p>
-        </c:txPr>
-        <c:crossAx val="2094734554"/>
-        <c:crosses val="autoZero"/>
-        <c:crossBetween val="between"/>
-      </c:valAx>
-      <c:spPr>
-        <a:noFill/>
-        <a:ln>
-          <a:noFill/>
-        </a:ln>
-        <a:effectLst/>
-      </c:spPr>
-    </c:plotArea>
-    <c:legend>
-      <c:legendPos val="b"/>
-      <c:overlay val="0"/>
-      <c:txPr>
-        <a:bodyPr/>
-        <a:lstStyle/>
-        <a:p>
-          <a:pPr>
-            <a:defRPr sz="1200">
-              <a:solidFill>
-                <a:srgbClr val="2E3566"/>
-              </a:solidFill>
-              <a:latin typeface="Malgun Gothic"/>
-              <a:cs typeface="Malgun Gothic"/>
-            </a:defRPr>
-          </a:pPr>
-          <a:endParaRPr lang="en-US"/>
-        </a:p>
-      </c:txPr>
-    </c:legend>
-    <c:plotVisOnly val="1"/>
-    <c:dispBlanksAs val="span"/>
-  </c:chart>
-  <c:spPr>
-    <a:noFill/>
-    <a:ln>
-      <a:noFill/>
-    </a:ln>
-    <a:effectLst/>
-  </c:spPr>
-  <c:externalData r:id="rId1">
-    <c:autoUpdate val="0"/>
-  </c:externalData>
-</c:chartSpace>
-</file>
-
-<file path=ppt/charts/chart3.xml><?xml version="1.0" encoding="utf-8"?>
-<c:chartSpace xmlns:c="http://schemas.openxmlformats.org/drawingml/2006/chart" xmlns:a="http://schemas.openxmlformats.org/drawingml/2006/main" xmlns:r="http://schemas.openxmlformats.org/officeDocument/2006/relationships">
-  <c:date1904 val="0"/>
-  <c:roundedCorners val="0"/>
-  <c:chart>
-    <c:title>
-      <c:tx>
-        <c:rich>
-          <a:bodyPr/>
-          <a:lstStyle/>
-          <a:p>
-            <a:pPr>
-              <a:defRPr sz="1400" b="0" i="0" u="none" strike="noStrike">
-                <a:solidFill>
-                  <a:srgbClr val="1B1F3B"/>
-                </a:solidFill>
-                <a:latin typeface="Malgun Gothic"/>
-              </a:defRPr>
-            </a:pPr>
-            <a:r>
-              <a:rPr sz="1400" b="0" i="0" u="none" strike="noStrike">
-                <a:solidFill>
-                  <a:srgbClr val="1B1F3B"/>
-                </a:solidFill>
-                <a:latin typeface="Malgun Gothic"/>
-              </a:rPr>
-              <a:t>가격 포지션 (달러)</a:t>
-            </a:r>
-          </a:p>
-        </c:rich>
-      </c:tx>
-      <c:layout/>
-      <c:overlay val="0"/>
-    </c:title>
-    <c:autoTitleDeleted val="0"/>
-    <c:plotArea>
-      <c:layout/>
-      <c:barChart>
-        <c:barDir val="bar"/>
-        <c:grouping val="clustered"/>
-        <c:varyColors val="0"/>
-        <c:ser>
-          <c:idx val="0"/>
-          <c:order val="0"/>
-          <c:tx>
-            <c:strRef>
-              <c:f>Sheet1!$B$1</c:f>
-              <c:strCache>
-                <c:ptCount val="1"/>
-                <c:pt idx="0">
-                  <c:v>가격($)</c:v>
-                </c:pt>
-              </c:strCache>
-            </c:strRef>
-          </c:tx>
-          <c:spPr>
-            <a:solidFill>
-              <a:srgbClr val="8E9AAF"/>
-            </a:solidFill>
-            <a:effectLst/>
-          </c:spPr>
-          <c:invertIfNegative val="0"/>
-          <c:dPt>
-            <c:idx val="0"/>
-            <c:invertIfNegative val="0"/>
-            <c:bubble3D val="0"/>
-            <c:spPr>
-              <a:solidFill>
-                <a:srgbClr val="8E9AAF"/>
-              </a:solidFill>
-              <a:effectLst/>
-            </c:spPr>
-          </c:dPt>
-          <c:dPt>
-            <c:idx val="1"/>
-            <c:invertIfNegative val="0"/>
-            <c:bubble3D val="0"/>
-            <c:spPr>
-              <a:solidFill>
-                <a:srgbClr val="8E9AAF"/>
-              </a:solidFill>
-              <a:effectLst/>
-            </c:spPr>
-          </c:dPt>
-          <c:dPt>
-            <c:idx val="2"/>
-            <c:invertIfNegative val="0"/>
-            <c:bubble3D val="0"/>
-            <c:spPr>
-              <a:solidFill>
-                <a:srgbClr val="F4A259"/>
-              </a:solidFill>
-              <a:effectLst/>
-            </c:spPr>
-          </c:dPt>
-          <c:dPt>
-            <c:idx val="3"/>
-            <c:invertIfNegative val="0"/>
-            <c:bubble3D val="0"/>
-            <c:spPr>
-              <a:solidFill>
-                <a:srgbClr val="8E9AAF"/>
-              </a:solidFill>
-              <a:effectLst/>
-            </c:spPr>
-          </c:dPt>
-          <c:dLbls>
-            <c:numFmt formatCode="$0" sourceLinked="0"/>
-            <c:txPr>
-              <a:bodyPr/>
-              <a:lstStyle/>
-              <a:p>
-                <a:pPr>
-                  <a:defRPr b="1" i="0" strike="noStrike" sz="1200" u="none">
-                    <a:solidFill>
-                      <a:srgbClr val="1B1F3B"/>
-                    </a:solidFill>
-                    <a:latin typeface="Malgun Gothic"/>
-                  </a:defRPr>
-                </a:pPr>
-              </a:p>
-            </c:txPr>
-            <c:showLegendKey val="0"/>
-            <c:showVal val="1"/>
-            <c:showCatName val="0"/>
-            <c:showSerName val="0"/>
-            <c:showPercent val="0"/>
-            <c:showBubbleSize val="0"/>
-            <c:showLeaderLines val="0"/>
-          </c:dLbls>
-          <c:cat>
-            <c:strRef>
-              <c:f>Sheet1!$A$2:$A$5</c:f>
-              <c:strCache>
-                <c:ptCount val="4"/>
-                <c:pt idx="0">
-                  <c:v>Sonic Bomb 세트</c:v>
-                </c:pt>
-                <c:pt idx="1">
-                  <c:v>Clocky</c:v>
-                </c:pt>
-                <c:pt idx="2">
-                  <c:v>우리 제품</c:v>
-                </c:pt>
-                <c:pt idx="3">
-                  <c:v>Hatch Restore 3</c:v>
-                </c:pt>
-              </c:strCache>
-            </c:strRef>
-          </c:cat>
-          <c:val>
-            <c:numRef>
-              <c:f>Sheet1!$B$2:$B$5</c:f>
-              <c:numCache>
-                <c:formatCode>General</c:formatCode>
-                <c:ptCount val="4"/>
-                <c:pt idx="0">
-                  <c:v>44.99</c:v>
-                </c:pt>
-                <c:pt idx="1">
-                  <c:v>50</c:v>
-                </c:pt>
-                <c:pt idx="2">
-                  <c:v>70.7</c:v>
-                </c:pt>
-                <c:pt idx="3">
-                  <c:v>169.99</c:v>
-                </c:pt>
-              </c:numCache>
-            </c:numRef>
-          </c:val>
-        </c:ser>
-        <c:dLbls>
-          <c:numFmt formatCode="$0" sourceLinked="0"/>
-          <c:txPr>
-            <a:bodyPr/>
-            <a:lstStyle/>
-            <a:p>
-              <a:pPr>
-                <a:defRPr b="1" i="0" strike="noStrike" sz="1200" u="none">
-                  <a:solidFill>
-                    <a:srgbClr val="1B1F3B"/>
-                  </a:solidFill>
-                  <a:latin typeface="Malgun Gothic"/>
-                </a:defRPr>
-              </a:pPr>
-            </a:p>
-          </c:txPr>
-          <c:showLegendKey val="0"/>
-          <c:showVal val="1"/>
-          <c:showCatName val="0"/>
-          <c:showSerName val="0"/>
-          <c:showPercent val="0"/>
-          <c:showBubbleSize val="0"/>
-          <c:showLeaderLines val="0"/>
-        </c:dLbls>
-        <c:gapWidth val="50"/>
-        <c:overlap val="0"/>
-        <c:axId val="2094734554"/>
-        <c:axId val="2094734552"/>
-        <c:axId val="2094734556"/>
-      </c:barChart>
-      <c:catAx>
-        <c:axId val="2094734554"/>
-        <c:scaling>
-          <c:orientation val="maxMin"/>
-        </c:scaling>
-        <c:delete val="0"/>
-        <c:axPos val="l"/>
-        <c:numFmt formatCode="General" sourceLinked="1"/>
-        <c:majorTickMark val="out"/>
-        <c:minorTickMark val="none"/>
-        <c:tickLblPos val="nextTo"/>
-        <c:spPr>
-          <a:ln w="12700" cap="flat">
-            <a:solidFill>
-              <a:srgbClr val="888888"/>
-            </a:solidFill>
-            <a:prstDash val="solid"/>
-            <a:round/>
-          </a:ln>
-        </c:spPr>
-        <c:txPr>
-          <a:bodyPr/>
-          <a:lstStyle/>
-          <a:p>
-            <a:pPr>
-              <a:defRPr sz="1200" b="0" i="0" u="none" strike="noStrike">
-                <a:solidFill>
-                  <a:srgbClr val="2E3566"/>
-                </a:solidFill>
-                <a:latin typeface="Malgun Gothic"/>
-              </a:defRPr>
-            </a:pPr>
-            <a:endParaRPr lang="en-US"/>
-          </a:p>
-        </c:txPr>
-        <c:crossAx val="2094734552"/>
-        <c:crosses val="autoZero"/>
-        <c:auto val="1"/>
-        <c:lblAlgn val="ctr"/>
-        <c:noMultiLvlLbl val="1"/>
-      </c:catAx>
-      <c:valAx>
-        <c:axId val="2094734552"/>
-        <c:scaling>
-          <c:orientation val="minMax"/>
-          <c:max val="200"/>
-          <c:min val="0"/>
-        </c:scaling>
-        <c:delete val="1"/>
-        <c:axPos val="b"/>
-        <c:numFmt formatCode="General" sourceLinked="0"/>
-        <c:majorTickMark val="out"/>
-        <c:minorTickMark val="none"/>
-        <c:tickLblPos val="low"/>
-        <c:spPr>
-          <a:ln w="12700" cap="flat">
-            <a:solidFill>
-              <a:srgbClr val="888888"/>
-            </a:solidFill>
-            <a:prstDash val="solid"/>
-            <a:round/>
-          </a:ln>
-        </c:spPr>
-        <c:txPr>
-          <a:bodyPr/>
-          <a:lstStyle/>
-          <a:p>
-            <a:pPr>
-              <a:defRPr sz="1200" b="0" i="0" u="none" strike="noStrike">
-                <a:solidFill>
-                  <a:srgbClr val="2E3566"/>
-                </a:solidFill>
-                <a:latin typeface="Malgun Gothic"/>
-              </a:defRPr>
-            </a:pPr>
-            <a:endParaRPr lang="en-US"/>
-          </a:p>
-        </c:txPr>
-        <c:crossAx val="2094734554"/>
-        <c:crosses val="autoZero"/>
-        <c:crossBetween val="between"/>
-      </c:valAx>
-      <c:spPr>
-        <a:noFill/>
-        <a:ln>
-          <a:noFill/>
-        </a:ln>
-        <a:effectLst/>
-      </c:spPr>
-    </c:plotArea>
-    <c:plotVisOnly val="1"/>
-    <c:dispBlanksAs val="span"/>
-  </c:chart>
-  <c:spPr>
-    <a:noFill/>
-    <a:ln>
-      <a:noFill/>
-    </a:ln>
-    <a:effectLst/>
-  </c:spPr>
-  <c:externalData r:id="rId1">
-    <c:autoUpdate val="0"/>
-  </c:externalData>
-</c:chartSpace>
-</file>
-
-<file path=ppt/charts/chart4.xml><?xml version="1.0" encoding="utf-8"?>
-<c:chartSpace xmlns:c="http://schemas.openxmlformats.org/drawingml/2006/chart" xmlns:a="http://schemas.openxmlformats.org/drawingml/2006/main" xmlns:r="http://schemas.openxmlformats.org/officeDocument/2006/relationships">
-  <c:date1904 val="0"/>
-  <c:roundedCorners val="0"/>
-  <c:chart>
-    <c:autoTitleDeleted val="1"/>
-    <c:plotArea>
-      <c:layout/>
-      <c:doughnutChart>
-        <c:varyColors val="1"/>
-        <c:ser>
-          <c:idx val="0"/>
-          <c:order val="0"/>
-          <c:tx>
-            <c:strRef>
-              <c:f>Sheet1!$B$1</c:f>
-              <c:strCache>
-                <c:ptCount val="1"/>
-                <c:pt idx="0">
-                  <c:v>재료비</c:v>
-                </c:pt>
-              </c:strCache>
-            </c:strRef>
-          </c:tx>
-          <c:spPr>
-            <a:solidFill>
-              <a:schemeClr val="accent1"/>
-            </a:solidFill>
-            <a:ln w="9525" cap="flat">
-              <a:solidFill>
-                <a:srgbClr val="F9F9F9"/>
-              </a:solidFill>
-              <a:prstDash val="solid"/>
-              <a:round/>
-            </a:ln>
-            <a:effectLst/>
-          </c:spPr>
-          <c:dPt>
-            <c:idx val="0"/>
-            <c:bubble3D val="0"/>
-            <c:spPr>
-              <a:solidFill>
-                <a:srgbClr val="5B6ABF"/>
-              </a:solidFill>
-              <a:ln w="12700" cap="flat">
-                <a:solidFill>
-                  <a:srgbClr val="FFFFFF"/>
-                </a:solidFill>
-                <a:prstDash val="solid"/>
-                <a:round/>
-              </a:ln>
-              <a:effectLst/>
-            </c:spPr>
-          </c:dPt>
-          <c:dPt>
-            <c:idx val="1"/>
-            <c:bubble3D val="0"/>
-            <c:spPr>
-              <a:solidFill>
-                <a:srgbClr val="F4A259"/>
-              </a:solidFill>
-              <a:ln w="12700" cap="flat">
-                <a:solidFill>
-                  <a:srgbClr val="FFFFFF"/>
-                </a:solidFill>
-                <a:prstDash val="solid"/>
-                <a:round/>
-              </a:ln>
-              <a:effectLst/>
-            </c:spPr>
-          </c:dPt>
-          <c:dPt>
-            <c:idx val="2"/>
-            <c:bubble3D val="0"/>
-            <c:spPr>
-              <a:solidFill>
-                <a:srgbClr val="3E8E7E"/>
-              </a:solidFill>
-              <a:ln w="12700" cap="flat">
-                <a:solidFill>
-                  <a:srgbClr val="FFFFFF"/>
-                </a:solidFill>
-                <a:prstDash val="solid"/>
-                <a:round/>
-              </a:ln>
-              <a:effectLst/>
-            </c:spPr>
-          </c:dPt>
-          <c:dPt>
-            <c:idx val="3"/>
-            <c:bubble3D val="0"/>
-            <c:spPr>
-              <a:solidFill>
-                <a:srgbClr val="E76F51"/>
-              </a:solidFill>
-              <a:ln w="12700" cap="flat">
-                <a:solidFill>
-                  <a:srgbClr val="FFFFFF"/>
-                </a:solidFill>
-                <a:prstDash val="solid"/>
-                <a:round/>
-              </a:ln>
-              <a:effectLst/>
-            </c:spPr>
-          </c:dPt>
-          <c:dPt>
-            <c:idx val="4"/>
-            <c:bubble3D val="0"/>
-            <c:spPr>
-              <a:solidFill>
-                <a:srgbClr val="2E3566"/>
-              </a:solidFill>
-              <a:ln w="12700" cap="flat">
-                <a:solidFill>
-                  <a:srgbClr val="FFFFFF"/>
-                </a:solidFill>
-                <a:prstDash val="solid"/>
-                <a:round/>
-              </a:ln>
-              <a:effectLst/>
-            </c:spPr>
-          </c:dPt>
-          <c:dPt>
-            <c:idx val="5"/>
-            <c:bubble3D val="0"/>
-            <c:spPr>
-              <a:solidFill>
-                <a:srgbClr val="8E9AAF"/>
-              </a:solidFill>
-              <a:ln w="12700" cap="flat">
-                <a:solidFill>
-                  <a:srgbClr val="FFFFFF"/>
-                </a:solidFill>
-                <a:prstDash val="solid"/>
-                <a:round/>
-              </a:ln>
-              <a:effectLst/>
-            </c:spPr>
-          </c:dPt>
-          <c:dPt>
-            <c:idx val="6"/>
-            <c:bubble3D val="0"/>
-            <c:spPr>
-              <a:solidFill>
-                <a:srgbClr val="B8C0E0"/>
-              </a:solidFill>
-              <a:ln w="12700" cap="flat">
-                <a:solidFill>
-                  <a:srgbClr val="FFFFFF"/>
-                </a:solidFill>
-                <a:prstDash val="solid"/>
-                <a:round/>
-              </a:ln>
-              <a:effectLst/>
-            </c:spPr>
-          </c:dPt>
-          <c:dPt>
-            <c:idx val="7"/>
-            <c:bubble3D val="0"/>
-            <c:spPr>
-              <a:solidFill>
-                <a:srgbClr val="1B1F3B"/>
-              </a:solidFill>
-              <a:ln w="12700" cap="flat">
-                <a:solidFill>
-                  <a:srgbClr val="FFFFFF"/>
-                </a:solidFill>
-                <a:prstDash val="solid"/>
-                <a:round/>
-              </a:ln>
-              <a:effectLst/>
-            </c:spPr>
-          </c:dPt>
-          <c:dLbls>
-            <c:dLbl>
-              <c:idx val="0"/>
-              <c:numFmt formatCode="General" sourceLinked="0"/>
-              <c:spPr/>
-              <c:txPr>
-                <a:bodyPr/>
-                <a:lstStyle/>
-                <a:p>
-                  <a:pPr>
-                    <a:defRPr sz="1200" b="0" i="0" u="none" strike="noStrike">
-                      <a:solidFill>
-                        <a:srgbClr val="000000"/>
-                      </a:solidFill>
-                      <a:latin typeface="Arial"/>
-                    </a:defRPr>
-                  </a:pPr>
-                </a:p>
-              </c:txPr>
-              <c:showLegendKey val="0"/>
-              <c:showVal val="0"/>
-              <c:showCatName val="0"/>
-              <c:showSerName val="0"/>
-              <c:showPercent val="0"/>
-              <c:showBubbleSize val="0"/>
-            </c:dLbl>
-            <c:dLbl>
-              <c:idx val="1"/>
-              <c:numFmt formatCode="General" sourceLinked="0"/>
-              <c:spPr/>
-              <c:txPr>
-                <a:bodyPr/>
-                <a:lstStyle/>
-                <a:p>
-                  <a:pPr>
-                    <a:defRPr sz="1200" b="0" i="0" u="none" strike="noStrike">
-                      <a:solidFill>
-                        <a:srgbClr val="000000"/>
-                      </a:solidFill>
-                      <a:latin typeface="Arial"/>
-                    </a:defRPr>
-                  </a:pPr>
-                </a:p>
-              </c:txPr>
-              <c:showLegendKey val="0"/>
-              <c:showVal val="0"/>
-              <c:showCatName val="0"/>
-              <c:showSerName val="0"/>
-              <c:showPercent val="0"/>
-              <c:showBubbleSize val="0"/>
-            </c:dLbl>
-            <c:dLbl>
-              <c:idx val="2"/>
-              <c:numFmt formatCode="General" sourceLinked="0"/>
-              <c:spPr/>
-              <c:txPr>
-                <a:bodyPr/>
-                <a:lstStyle/>
-                <a:p>
-                  <a:pPr>
-                    <a:defRPr sz="1200" b="0" i="0" u="none" strike="noStrike">
-                      <a:solidFill>
-                        <a:srgbClr val="000000"/>
-                      </a:solidFill>
-                      <a:latin typeface="Arial"/>
-                    </a:defRPr>
-                  </a:pPr>
-                </a:p>
-              </c:txPr>
-              <c:showLegendKey val="0"/>
-              <c:showVal val="0"/>
-              <c:showCatName val="0"/>
-              <c:showSerName val="0"/>
-              <c:showPercent val="0"/>
-              <c:showBubbleSize val="0"/>
-            </c:dLbl>
-            <c:dLbl>
-              <c:idx val="3"/>
-              <c:numFmt formatCode="General" sourceLinked="0"/>
-              <c:spPr/>
-              <c:txPr>
-                <a:bodyPr/>
-                <a:lstStyle/>
-                <a:p>
-                  <a:pPr>
-                    <a:defRPr sz="1200" b="0" i="0" u="none" strike="noStrike">
-                      <a:solidFill>
-                        <a:srgbClr val="000000"/>
-                      </a:solidFill>
-                      <a:latin typeface="Arial"/>
-                    </a:defRPr>
-                  </a:pPr>
-                </a:p>
-              </c:txPr>
-              <c:showLegendKey val="0"/>
-              <c:showVal val="0"/>
-              <c:showCatName val="0"/>
-              <c:showSerName val="0"/>
-              <c:showPercent val="0"/>
-              <c:showBubbleSize val="0"/>
-            </c:dLbl>
-            <c:dLbl>
-              <c:idx val="4"/>
-              <c:numFmt formatCode="General" sourceLinked="0"/>
-              <c:spPr/>
-              <c:txPr>
-                <a:bodyPr/>
-                <a:lstStyle/>
-                <a:p>
-                  <a:pPr>
-                    <a:defRPr sz="1200" b="0" i="0" u="none" strike="noStrike">
-                      <a:solidFill>
-                        <a:srgbClr val="000000"/>
-                      </a:solidFill>
-                      <a:latin typeface="Arial"/>
-                    </a:defRPr>
-                  </a:pPr>
-                </a:p>
-              </c:txPr>
-              <c:showLegendKey val="0"/>
-              <c:showVal val="0"/>
-              <c:showCatName val="0"/>
-              <c:showSerName val="0"/>
-              <c:showPercent val="0"/>
-              <c:showBubbleSize val="0"/>
-            </c:dLbl>
-            <c:dLbl>
-              <c:idx val="5"/>
-              <c:numFmt formatCode="General" sourceLinked="0"/>
-              <c:spPr/>
-              <c:txPr>
-                <a:bodyPr/>
-                <a:lstStyle/>
-                <a:p>
-                  <a:pPr>
-                    <a:defRPr sz="1200" b="0" i="0" u="none" strike="noStrike">
-                      <a:solidFill>
-                        <a:srgbClr val="000000"/>
-                      </a:solidFill>
-                      <a:latin typeface="Arial"/>
-                    </a:defRPr>
-                  </a:pPr>
-                </a:p>
-              </c:txPr>
-              <c:showLegendKey val="0"/>
-              <c:showVal val="0"/>
-              <c:showCatName val="0"/>
-              <c:showSerName val="0"/>
-              <c:showPercent val="0"/>
-              <c:showBubbleSize val="0"/>
-            </c:dLbl>
-            <c:dLbl>
-              <c:idx val="6"/>
-              <c:numFmt formatCode="General" sourceLinked="0"/>
-              <c:spPr/>
-              <c:txPr>
-                <a:bodyPr/>
-                <a:lstStyle/>
-                <a:p>
-                  <a:pPr>
-                    <a:defRPr sz="1200" b="0" i="0" u="none" strike="noStrike">
-                      <a:solidFill>
-                        <a:srgbClr val="000000"/>
-                      </a:solidFill>
-                      <a:latin typeface="Arial"/>
-                    </a:defRPr>
-                  </a:pPr>
-                </a:p>
-              </c:txPr>
-              <c:showLegendKey val="0"/>
-              <c:showVal val="0"/>
-              <c:showCatName val="0"/>
-              <c:showSerName val="0"/>
-              <c:showPercent val="0"/>
-              <c:showBubbleSize val="0"/>
-            </c:dLbl>
-            <c:dLbl>
-              <c:idx val="7"/>
-              <c:numFmt formatCode="General" sourceLinked="0"/>
-              <c:spPr/>
-              <c:txPr>
-                <a:bodyPr/>
-                <a:lstStyle/>
-                <a:p>
-                  <a:pPr>
-                    <a:defRPr sz="1200" b="0" i="0" u="none" strike="noStrike">
-                      <a:solidFill>
-                        <a:srgbClr val="000000"/>
-                      </a:solidFill>
-                      <a:latin typeface="Arial"/>
-                    </a:defRPr>
-                  </a:pPr>
-                </a:p>
-              </c:txPr>
-              <c:showLegendKey val="0"/>
-              <c:showVal val="0"/>
-              <c:showCatName val="0"/>
-              <c:showSerName val="0"/>
-              <c:showPercent val="0"/>
-              <c:showBubbleSize val="0"/>
-            </c:dLbl>
-            <c:numFmt formatCode="General" sourceLinked="0"/>
-            <c:txPr>
-              <a:bodyPr/>
-              <a:lstStyle/>
-              <a:p>
-                <a:pPr>
-                  <a:defRPr sz="1800" b="0" i="0" u="none" strike="noStrike">
-                    <a:solidFill>
-                      <a:srgbClr val="000000"/>
-                    </a:solidFill>
-                    <a:latin typeface="Arial"/>
-                  </a:defRPr>
-                </a:pPr>
-              </a:p>
-            </c:txPr>
-            <c:showLegendKey val="0"/>
-            <c:showVal val="0"/>
-            <c:showCatName val="1"/>
-            <c:showSerName val="0"/>
-            <c:showPercent val="1"/>
-            <c:showBubbleSize val="0"/>
-            <c:showLeaderLines val="0"/>
-          </c:dLbls>
-          <c:cat>
-            <c:strRef>
-              <c:f>Sheet1!$A$2:$A$9</c:f>
-              <c:strCache>
-                <c:ptCount val="8"/>
-                <c:pt idx="0">
-                  <c:v>베개 본체 (폼·커버)</c:v>
-                </c:pt>
-                <c:pt idx="1">
-                  <c:v>모터·링크 (서보)</c:v>
-                </c:pt>
-                <c:pt idx="2">
-                  <c:v>배터리·충전회로</c:v>
-                </c:pt>
-                <c:pt idx="3">
-                  <c:v>MCU·블루투스</c:v>
-                </c:pt>
-                <c:pt idx="4">
-                  <c:v>하우징·PCB·부자재</c:v>
-                </c:pt>
-                <c:pt idx="5">
-                  <c:v>포장</c:v>
-                </c:pt>
-                <c:pt idx="6">
-                  <c:v>실리콘 손</c:v>
-                </c:pt>
-                <c:pt idx="7">
-                  <c:v>센서 (압력·IMU)</c:v>
-                </c:pt>
-              </c:strCache>
-            </c:strRef>
-          </c:cat>
-          <c:val>
-            <c:numRef>
-              <c:f>Sheet1!$B$2:$B$9</c:f>
-              <c:numCache>
-                <c:ptCount val="8"/>
-                <c:pt idx="0">
-                  <c:v>7000</c:v>
-                </c:pt>
-                <c:pt idx="1">
-                  <c:v>6000</c:v>
-                </c:pt>
-                <c:pt idx="2">
-                  <c:v>5000</c:v>
-                </c:pt>
-                <c:pt idx="3">
-                  <c:v>4500</c:v>
-                </c:pt>
-                <c:pt idx="4">
-                  <c:v>4000</c:v>
-                </c:pt>
-                <c:pt idx="5">
-                  <c:v>3000</c:v>
-                </c:pt>
-                <c:pt idx="6">
-                  <c:v>2500</c:v>
-                </c:pt>
-                <c:pt idx="7">
-                  <c:v>2000</c:v>
-                </c:pt>
-              </c:numCache>
-            </c:numRef>
-          </c:val>
-        </c:ser>
-        <c:firstSliceAng val="0"/>
-        <c:holeSize val="55"/>
-      </c:doughnutChart>
-      <c:spPr>
-        <a:noFill/>
-        <a:ln>
-          <a:noFill/>
-        </a:ln>
-        <a:effectLst/>
-      </c:spPr>
-    </c:plotArea>
-    <c:legend>
-      <c:legendPos val="b"/>
-      <c:overlay val="0"/>
-      <c:txPr>
-        <a:bodyPr/>
-        <a:lstStyle/>
-        <a:p>
-          <a:pPr>
-            <a:defRPr sz="1200">
-              <a:solidFill>
-                <a:srgbClr val="2E3566"/>
-              </a:solidFill>
-              <a:latin typeface="Malgun Gothic"/>
-              <a:cs typeface="Malgun Gothic"/>
-            </a:defRPr>
-          </a:pPr>
-          <a:endParaRPr lang="en-US"/>
-        </a:p>
-      </c:txPr>
-    </c:legend>
-    <c:plotVisOnly val="1"/>
-    <c:dispBlanksAs val="span"/>
-  </c:chart>
-  <c:spPr>
-    <a:noFill/>
-    <a:ln>
-      <a:noFill/>
-    </a:ln>
-    <a:effectLst/>
-  </c:spPr>
-  <c:externalData r:id="rId1">
-    <c:autoUpdate val="0"/>
-  </c:externalData>
-</c:chartSpace>
-</file>
-
-<file path=ppt/charts/chart5.xml><?xml version="1.0" encoding="utf-8"?>
-<c:chartSpace xmlns:c="http://schemas.openxmlformats.org/drawingml/2006/chart" xmlns:a="http://schemas.openxmlformats.org/drawingml/2006/main" xmlns:r="http://schemas.openxmlformats.org/officeDocument/2006/relationships">
-  <c:date1904 val="0"/>
-  <c:roundedCorners val="0"/>
-  <c:chart>
-    <c:title>
-      <c:tx>
-        <c:rich>
-          <a:bodyPr/>
-          <a:lstStyle/>
-          <a:p>
-            <a:pPr>
-              <a:defRPr sz="1400" b="0" i="0" u="none" strike="noStrike">
-                <a:solidFill>
-                  <a:srgbClr val="1B1F3B"/>
-                </a:solidFill>
-                <a:latin typeface="Malgun Gothic"/>
-              </a:defRPr>
-            </a:pPr>
-            <a:r>
-              <a:rPr sz="1400" b="0" i="0" u="none" strike="noStrike">
-                <a:solidFill>
-                  <a:srgbClr val="1B1F3B"/>
-                </a:solidFill>
-                <a:latin typeface="Malgun Gothic"/>
-              </a:rPr>
-              <a:t>월별 판매 대수 (기본안, 합계 10,000대)</a:t>
-            </a:r>
-          </a:p>
-        </c:rich>
-      </c:tx>
-      <c:layout/>
-      <c:overlay val="0"/>
-    </c:title>
-    <c:autoTitleDeleted val="0"/>
-    <c:plotArea>
-      <c:layout/>
-      <c:barChart>
-        <c:barDir val="col"/>
-        <c:grouping val="clustered"/>
-        <c:varyColors val="0"/>
-        <c:ser>
-          <c:idx val="0"/>
-          <c:order val="0"/>
-          <c:tx>
-            <c:strRef>
-              <c:f>Sheet1!$B$1</c:f>
-              <c:strCache>
-                <c:ptCount val="1"/>
-                <c:pt idx="0">
-                  <c:v>판매 대수</c:v>
-                </c:pt>
-              </c:strCache>
-            </c:strRef>
-          </c:tx>
-          <c:spPr>
-            <a:solidFill>
-              <a:srgbClr val="5B6ABF"/>
-            </a:solidFill>
-            <a:effectLst/>
-          </c:spPr>
-          <c:invertIfNegative val="0"/>
-          <c:dLbls>
-            <c:numFmt formatCode="#,##0" sourceLinked="0"/>
-            <c:txPr>
-              <a:bodyPr/>
-              <a:lstStyle/>
-              <a:p>
-                <a:pPr>
-                  <a:defRPr b="0" i="0" strike="noStrike" sz="1100" u="none">
-                    <a:solidFill>
-                      <a:srgbClr val="1B1F3B"/>
-                    </a:solidFill>
-                    <a:latin typeface="Malgun Gothic"/>
-                  </a:defRPr>
-                </a:pPr>
-              </a:p>
-            </c:txPr>
-            <c:showLegendKey val="0"/>
-            <c:showVal val="1"/>
-            <c:showCatName val="0"/>
-            <c:showSerName val="0"/>
-            <c:showPercent val="0"/>
-            <c:showBubbleSize val="0"/>
-            <c:showLeaderLines val="0"/>
-          </c:dLbls>
-          <c:cat>
-            <c:strRef>
-              <c:f>Sheet1!$A$2:$A$13</c:f>
-              <c:strCache>
-                <c:ptCount val="12"/>
-                <c:pt idx="0">
-                  <c:v>1월</c:v>
-                </c:pt>
-                <c:pt idx="1">
-                  <c:v>2월</c:v>
-                </c:pt>
-                <c:pt idx="2">
-                  <c:v>3월</c:v>
-                </c:pt>
-                <c:pt idx="3">
-                  <c:v>4월</c:v>
-                </c:pt>
-                <c:pt idx="4">
-                  <c:v>5월</c:v>
-                </c:pt>
-                <c:pt idx="5">
-                  <c:v>6월</c:v>
-                </c:pt>
-                <c:pt idx="6">
-                  <c:v>7월</c:v>
-                </c:pt>
-                <c:pt idx="7">
-                  <c:v>8월</c:v>
-                </c:pt>
-                <c:pt idx="8">
-                  <c:v>9월</c:v>
-                </c:pt>
-                <c:pt idx="9">
-                  <c:v>10월</c:v>
-                </c:pt>
-                <c:pt idx="10">
-                  <c:v>11월</c:v>
-                </c:pt>
-                <c:pt idx="11">
-                  <c:v>12월</c:v>
-                </c:pt>
-              </c:strCache>
-            </c:strRef>
-          </c:cat>
-          <c:val>
-            <c:numRef>
-              <c:f>Sheet1!$B$2:$B$13</c:f>
-              <c:numCache>
-                <c:formatCode>General</c:formatCode>
-                <c:ptCount val="12"/>
-                <c:pt idx="0">
-                  <c:v>300</c:v>
-                </c:pt>
-                <c:pt idx="1">
-                  <c:v>400</c:v>
-                </c:pt>
-                <c:pt idx="2">
-                  <c:v>500</c:v>
-                </c:pt>
-                <c:pt idx="3">
-                  <c:v>600</c:v>
-                </c:pt>
-                <c:pt idx="4">
-                  <c:v>700</c:v>
-                </c:pt>
-                <c:pt idx="5">
-                  <c:v>800</c:v>
-                </c:pt>
-                <c:pt idx="6">
-                  <c:v>900</c:v>
-                </c:pt>
-                <c:pt idx="7">
-                  <c:v>1000</c:v>
-                </c:pt>
-                <c:pt idx="8">
-                  <c:v>1100</c:v>
-                </c:pt>
-                <c:pt idx="9">
-                  <c:v>1150</c:v>
-                </c:pt>
-                <c:pt idx="10">
-                  <c:v>1250</c:v>
-                </c:pt>
-                <c:pt idx="11">
-                  <c:v>1300</c:v>
-                </c:pt>
-              </c:numCache>
-            </c:numRef>
-          </c:val>
-        </c:ser>
-        <c:dLbls>
-          <c:numFmt formatCode="#,##0" sourceLinked="0"/>
-          <c:txPr>
-            <a:bodyPr/>
-            <a:lstStyle/>
-            <a:p>
-              <a:pPr>
-                <a:defRPr b="0" i="0" strike="noStrike" sz="1100" u="none">
-                  <a:solidFill>
-                    <a:srgbClr val="1B1F3B"/>
-                  </a:solidFill>
-                  <a:latin typeface="Malgun Gothic"/>
-                </a:defRPr>
-              </a:pPr>
-            </a:p>
-          </c:txPr>
-          <c:showLegendKey val="0"/>
-          <c:showVal val="1"/>
-          <c:showCatName val="0"/>
-          <c:showSerName val="0"/>
-          <c:showPercent val="0"/>
-          <c:showBubbleSize val="0"/>
-          <c:showLeaderLines val="0"/>
-        </c:dLbls>
-        <c:gapWidth val="40"/>
-        <c:overlap val="0"/>
-        <c:axId val="2094734554"/>
-        <c:axId val="2094734552"/>
-        <c:axId val="2094734556"/>
-      </c:barChart>
-      <c:catAx>
-        <c:axId val="2094734554"/>
-        <c:scaling>
-          <c:orientation val="minMax"/>
-        </c:scaling>
-        <c:delete val="0"/>
-        <c:axPos val="b"/>
-        <c:numFmt formatCode="General" sourceLinked="1"/>
-        <c:majorTickMark val="out"/>
-        <c:minorTickMark val="none"/>
-        <c:tickLblPos val="low"/>
-        <c:spPr>
-          <a:ln w="12700" cap="flat">
-            <a:solidFill>
-              <a:srgbClr val="888888"/>
-            </a:solidFill>
-            <a:prstDash val="solid"/>
-            <a:round/>
-          </a:ln>
-        </c:spPr>
-        <c:txPr>
-          <a:bodyPr/>
-          <a:lstStyle/>
-          <a:p>
-            <a:pPr>
-              <a:defRPr sz="1200" b="0" i="0" u="none" strike="noStrike">
-                <a:solidFill>
-                  <a:srgbClr val="2E3566"/>
-                </a:solidFill>
-                <a:latin typeface="Malgun Gothic"/>
-              </a:defRPr>
-            </a:pPr>
-            <a:endParaRPr lang="en-US"/>
-          </a:p>
-        </c:txPr>
-        <c:crossAx val="2094734552"/>
-        <c:crosses val="autoZero"/>
-        <c:auto val="1"/>
-        <c:lblAlgn val="ctr"/>
-        <c:noMultiLvlLbl val="1"/>
-      </c:catAx>
-      <c:valAx>
-        <c:axId val="2094734552"/>
-        <c:scaling>
-          <c:orientation val="minMax"/>
-          <c:max val="1600"/>
-          <c:min val="0"/>
-        </c:scaling>
-        <c:delete val="1"/>
-        <c:axPos val="l"/>
-        <c:numFmt formatCode="General" sourceLinked="0"/>
-        <c:majorTickMark val="out"/>
-        <c:minorTickMark val="none"/>
-        <c:tickLblPos val="nextTo"/>
-        <c:spPr>
-          <a:ln w="12700" cap="flat">
-            <a:solidFill>
-              <a:srgbClr val="888888"/>
-            </a:solidFill>
-            <a:prstDash val="solid"/>
-            <a:round/>
-          </a:ln>
-        </c:spPr>
-        <c:txPr>
-          <a:bodyPr/>
-          <a:lstStyle/>
-          <a:p>
-            <a:pPr>
-              <a:defRPr sz="1200" b="0" i="0" u="none" strike="noStrike">
-                <a:solidFill>
-                  <a:srgbClr val="2E3566"/>
-                </a:solidFill>
-                <a:latin typeface="Malgun Gothic"/>
-              </a:defRPr>
-            </a:pPr>
-            <a:endParaRPr lang="en-US"/>
-          </a:p>
-        </c:txPr>
-        <c:crossAx val="2094734554"/>
-        <c:crosses val="autoZero"/>
-        <c:crossBetween val="between"/>
-      </c:valAx>
-      <c:spPr>
-        <a:noFill/>
-        <a:ln>
-          <a:noFill/>
-        </a:ln>
-        <a:effectLst/>
-      </c:spPr>
-    </c:plotArea>
-    <c:plotVisOnly val="1"/>
-    <c:dispBlanksAs val="span"/>
-  </c:chart>
-  <c:spPr>
-    <a:noFill/>
-    <a:ln>
-      <a:noFill/>
-    </a:ln>
-    <a:effectLst/>
-  </c:spPr>
-  <c:externalData r:id="rId1">
-    <c:autoUpdate val="0"/>
-  </c:externalData>
-</c:chartSpace>
-</file>
-
-<file path=ppt/charts/chart6.xml><?xml version="1.0" encoding="utf-8"?>
-<c:chartSpace xmlns:c="http://schemas.openxmlformats.org/drawingml/2006/chart" xmlns:a="http://schemas.openxmlformats.org/drawingml/2006/main" xmlns:r="http://schemas.openxmlformats.org/officeDocument/2006/relationships">
-  <c:date1904 val="0"/>
-  <c:roundedCorners val="0"/>
-  <c:chart>
-    <c:title>
-      <c:tx>
-        <c:rich>
-          <a:bodyPr/>
-          <a:lstStyle/>
-          <a:p>
-            <a:pPr>
-              <a:defRPr sz="1400" b="0" i="0" u="none" strike="noStrike">
-                <a:solidFill>
-                  <a:srgbClr val="1B1F3B"/>
-                </a:solidFill>
-                <a:latin typeface="Malgun Gothic"/>
-              </a:defRPr>
-            </a:pPr>
-            <a:r>
-              <a:rPr sz="1400" b="0" i="0" u="none" strike="noStrike">
-                <a:solidFill>
-                  <a:srgbClr val="1B1F3B"/>
-                </a:solidFill>
-                <a:latin typeface="Malgun Gothic"/>
-              </a:rPr>
-              <a:t>매출액과 영업이익 (억원)</a:t>
-            </a:r>
-          </a:p>
-        </c:rich>
-      </c:tx>
-      <c:layout/>
-      <c:overlay val="0"/>
-    </c:title>
-    <c:autoTitleDeleted val="0"/>
-    <c:plotArea>
-      <c:layout/>
-      <c:barChart>
-        <c:barDir val="col"/>
-        <c:grouping val="clustered"/>
-        <c:varyColors val="0"/>
-        <c:ser>
-          <c:idx val="0"/>
-          <c:order val="0"/>
-          <c:tx>
-            <c:strRef>
-              <c:f>Sheet1!$B$1</c:f>
-              <c:strCache>
-                <c:ptCount val="1"/>
-                <c:pt idx="0">
-                  <c:v>매출액</c:v>
-                </c:pt>
-              </c:strCache>
-            </c:strRef>
-          </c:tx>
-          <c:spPr>
-            <a:solidFill>
-              <a:srgbClr val="5B6ABF"/>
-            </a:solidFill>
-            <a:effectLst/>
-          </c:spPr>
-          <c:invertIfNegative val="0"/>
-          <c:dLbls>
-            <c:numFmt formatCode="0.0#" sourceLinked="0"/>
-            <c:txPr>
-              <a:bodyPr/>
-              <a:lstStyle/>
-              <a:p>
-                <a:pPr>
-                  <a:defRPr b="1" i="0" strike="noStrike" sz="1200" u="none">
-                    <a:solidFill>
-                      <a:srgbClr val="1B1F3B"/>
-                    </a:solidFill>
-                    <a:latin typeface="Malgun Gothic"/>
-                  </a:defRPr>
-                </a:pPr>
-              </a:p>
-            </c:txPr>
-            <c:showLegendKey val="0"/>
-            <c:showVal val="1"/>
-            <c:showCatName val="0"/>
-            <c:showSerName val="0"/>
-            <c:showPercent val="0"/>
-            <c:showBubbleSize val="0"/>
-            <c:showLeaderLines val="0"/>
-          </c:dLbls>
-          <c:cat>
-            <c:strRef>
-              <c:f>Sheet1!$A$2:$A$4</c:f>
-              <c:strCache>
-                <c:ptCount val="3"/>
-                <c:pt idx="0">
-                  <c:v>1년차</c:v>
-                </c:pt>
-                <c:pt idx="1">
-                  <c:v>2년차</c:v>
-                </c:pt>
-                <c:pt idx="2">
-                  <c:v>3년차</c:v>
-                </c:pt>
-              </c:strCache>
-            </c:strRef>
-          </c:cat>
-          <c:val>
-            <c:numRef>
-              <c:f>Sheet1!$B$2:$B$4</c:f>
-              <c:numCache>
-                <c:formatCode>General</c:formatCode>
-                <c:ptCount val="3"/>
-                <c:pt idx="0">
-                  <c:v>9</c:v>
-                </c:pt>
-                <c:pt idx="1">
-                  <c:v>27</c:v>
-                </c:pt>
-                <c:pt idx="2">
-                  <c:v>54</c:v>
-                </c:pt>
-              </c:numCache>
-            </c:numRef>
-          </c:val>
-        </c:ser>
-        <c:ser>
-          <c:idx val="1"/>
-          <c:order val="1"/>
-          <c:tx>
-            <c:strRef>
-              <c:f>Sheet1!$C$1</c:f>
-              <c:strCache>
-                <c:ptCount val="1"/>
-                <c:pt idx="0">
-                  <c:v>영업이익</c:v>
-                </c:pt>
-              </c:strCache>
-            </c:strRef>
-          </c:tx>
-          <c:spPr>
-            <a:solidFill>
-              <a:srgbClr val="F4A259"/>
-            </a:solidFill>
-            <a:effectLst/>
-          </c:spPr>
-          <c:invertIfNegative val="0"/>
-          <c:dLbls>
-            <c:numFmt formatCode="0.0#" sourceLinked="0"/>
-            <c:txPr>
-              <a:bodyPr/>
-              <a:lstStyle/>
-              <a:p>
-                <a:pPr>
-                  <a:defRPr b="1" i="0" strike="noStrike" sz="1200" u="none">
-                    <a:solidFill>
-                      <a:srgbClr val="1B1F3B"/>
-                    </a:solidFill>
-                    <a:latin typeface="Malgun Gothic"/>
-                  </a:defRPr>
-                </a:pPr>
-              </a:p>
-            </c:txPr>
-            <c:showLegendKey val="0"/>
-            <c:showVal val="1"/>
-            <c:showCatName val="0"/>
-            <c:showSerName val="0"/>
-            <c:showPercent val="0"/>
-            <c:showBubbleSize val="0"/>
-            <c:showLeaderLines val="0"/>
-          </c:dLbls>
-          <c:cat>
-            <c:strRef>
-              <c:f>Sheet1!$A$2:$A$4</c:f>
-              <c:strCache>
-                <c:ptCount val="3"/>
-                <c:pt idx="0">
-                  <c:v>1년차</c:v>
-                </c:pt>
-                <c:pt idx="1">
-                  <c:v>2년차</c:v>
-                </c:pt>
-                <c:pt idx="2">
-                  <c:v>3년차</c:v>
-                </c:pt>
-              </c:strCache>
-            </c:strRef>
-          </c:cat>
-          <c:val>
-            <c:numRef>
-              <c:f>Sheet1!$C$2:$C$4</c:f>
-              <c:numCache>
-                <c:formatCode>General</c:formatCode>
-                <c:ptCount val="3"/>
-                <c:pt idx="0">
-                  <c:v>-1.75</c:v>
-                </c:pt>
-                <c:pt idx="1">
-                  <c:v>1.14</c:v>
-                </c:pt>
-                <c:pt idx="2">
-                  <c:v>6.26</c:v>
-                </c:pt>
-              </c:numCache>
-            </c:numRef>
-          </c:val>
-        </c:ser>
-        <c:dLbls>
-          <c:numFmt formatCode="0.0#" sourceLinked="0"/>
-          <c:txPr>
-            <a:bodyPr/>
-            <a:lstStyle/>
-            <a:p>
-              <a:pPr>
-                <a:defRPr b="1" i="0" strike="noStrike" sz="1200" u="none">
-                  <a:solidFill>
-                    <a:srgbClr val="1B1F3B"/>
-                  </a:solidFill>
-                  <a:latin typeface="Malgun Gothic"/>
-                </a:defRPr>
-              </a:pPr>
-            </a:p>
-          </c:txPr>
-          <c:showLegendKey val="0"/>
-          <c:showVal val="1"/>
-          <c:showCatName val="0"/>
-          <c:showSerName val="0"/>
-          <c:showPercent val="0"/>
-          <c:showBubbleSize val="0"/>
-          <c:showLeaderLines val="0"/>
-        </c:dLbls>
-        <c:gapWidth val="50"/>
-        <c:overlap val="0"/>
-        <c:axId val="2094734554"/>
-        <c:axId val="2094734552"/>
-        <c:axId val="2094734556"/>
-      </c:barChart>
-      <c:catAx>
-        <c:axId val="2094734554"/>
-        <c:scaling>
-          <c:orientation val="minMax"/>
-        </c:scaling>
-        <c:delete val="0"/>
-        <c:axPos val="b"/>
-        <c:numFmt formatCode="General" sourceLinked="1"/>
-        <c:majorTickMark val="out"/>
-        <c:minorTickMark val="none"/>
-        <c:tickLblPos val="low"/>
-        <c:spPr>
-          <a:ln w="12700" cap="flat">
-            <a:solidFill>
-              <a:srgbClr val="888888"/>
-            </a:solidFill>
-            <a:prstDash val="solid"/>
-            <a:round/>
-          </a:ln>
-        </c:spPr>
-        <c:txPr>
-          <a:bodyPr/>
-          <a:lstStyle/>
-          <a:p>
-            <a:pPr>
-              <a:defRPr sz="1200" b="0" i="0" u="none" strike="noStrike">
-                <a:solidFill>
-                  <a:srgbClr val="2E3566"/>
-                </a:solidFill>
-                <a:latin typeface="Malgun Gothic"/>
-              </a:defRPr>
-            </a:pPr>
-            <a:endParaRPr lang="en-US"/>
-          </a:p>
-        </c:txPr>
-        <c:crossAx val="2094734552"/>
-        <c:crosses val="autoZero"/>
-        <c:auto val="1"/>
-        <c:lblAlgn val="ctr"/>
-        <c:noMultiLvlLbl val="1"/>
-      </c:catAx>
-      <c:valAx>
-        <c:axId val="2094734552"/>
-        <c:scaling>
-          <c:orientation val="minMax"/>
-          <c:max val="62"/>
-          <c:min val="-6"/>
-        </c:scaling>
-        <c:delete val="1"/>
-        <c:axPos val="l"/>
-        <c:numFmt formatCode="General" sourceLinked="0"/>
-        <c:majorTickMark val="out"/>
-        <c:minorTickMark val="none"/>
-        <c:tickLblPos val="nextTo"/>
-        <c:spPr>
-          <a:ln w="12700" cap="flat">
-            <a:solidFill>
-              <a:srgbClr val="888888"/>
-            </a:solidFill>
-            <a:prstDash val="solid"/>
-            <a:round/>
-          </a:ln>
-        </c:spPr>
-        <c:txPr>
-          <a:bodyPr/>
-          <a:lstStyle/>
-          <a:p>
-            <a:pPr>
-              <a:defRPr sz="1200" b="0" i="0" u="none" strike="noStrike">
-                <a:solidFill>
-                  <a:srgbClr val="2E3566"/>
-                </a:solidFill>
-                <a:latin typeface="Malgun Gothic"/>
-              </a:defRPr>
-            </a:pPr>
-            <a:endParaRPr lang="en-US"/>
-          </a:p>
-        </c:txPr>
-        <c:crossAx val="2094734554"/>
-        <c:crosses val="autoZero"/>
-        <c:crossBetween val="between"/>
-      </c:valAx>
-      <c:spPr>
-        <a:noFill/>
-        <a:ln>
-          <a:noFill/>
-        </a:ln>
-        <a:effectLst/>
-      </c:spPr>
-    </c:plotArea>
-    <c:legend>
-      <c:legendPos val="b"/>
-      <c:overlay val="0"/>
-      <c:txPr>
-        <a:bodyPr/>
-        <a:lstStyle/>
-        <a:p>
-          <a:pPr>
-            <a:defRPr sz="1200">
-              <a:solidFill>
-                <a:srgbClr val="2E3566"/>
-              </a:solidFill>
-              <a:latin typeface="Malgun Gothic"/>
-              <a:cs typeface="Malgun Gothic"/>
-            </a:defRPr>
-          </a:pPr>
-          <a:endParaRPr lang="en-US"/>
-        </a:p>
-      </c:txPr>
-    </c:legend>
-    <c:plotVisOnly val="1"/>
-    <c:dispBlanksAs val="span"/>
-  </c:chart>
-  <c:spPr>
-    <a:noFill/>
-    <a:ln>
-      <a:noFill/>
-    </a:ln>
-    <a:effectLst/>
-  </c:spPr>
-  <c:externalData r:id="rId1">
-    <c:autoUpdate val="0"/>
-  </c:externalData>
-</c:chartSpace>
-</file>
-
-<file path=ppt/charts/chart7.xml><?xml version="1.0" encoding="utf-8"?>
-<c:chartSpace xmlns:c="http://schemas.openxmlformats.org/drawingml/2006/chart" xmlns:a="http://schemas.openxmlformats.org/drawingml/2006/main" xmlns:r="http://schemas.openxmlformats.org/officeDocument/2006/relationships">
-  <c:date1904 val="0"/>
-  <c:roundedCorners val="0"/>
-  <c:chart>
-    <c:title>
-      <c:tx>
-        <c:rich>
-          <a:bodyPr/>
-          <a:lstStyle/>
-          <a:p>
-            <a:pPr>
-              <a:defRPr sz="1400" b="0" i="0" u="none" strike="noStrike">
-                <a:solidFill>
-                  <a:srgbClr val="1B1F3B"/>
-                </a:solidFill>
-                <a:latin typeface="Malgun Gothic"/>
-              </a:defRPr>
-            </a:pPr>
-            <a:r>
-              <a:rPr sz="1400" b="0" i="0" u="none" strike="noStrike">
-                <a:solidFill>
-                  <a:srgbClr val="1B1F3B"/>
-                </a:solidFill>
-                <a:latin typeface="Malgun Gothic"/>
-              </a:rPr>
-              <a:t>매출 대비 기부 비율</a:t>
-            </a:r>
-          </a:p>
-        </c:rich>
-      </c:tx>
-      <c:layout/>
-      <c:overlay val="0"/>
-    </c:title>
-    <c:autoTitleDeleted val="0"/>
-    <c:plotArea>
-      <c:layout/>
-      <c:barChart>
-        <c:barDir val="col"/>
-        <c:grouping val="clustered"/>
-        <c:varyColors val="0"/>
-        <c:ser>
-          <c:idx val="0"/>
-          <c:order val="0"/>
-          <c:tx>
-            <c:strRef>
-              <c:f>Sheet1!$B$1</c:f>
-              <c:strCache>
-                <c:ptCount val="1"/>
-                <c:pt idx="0">
-                  <c:v>매출 대비 기부 비율(%)</c:v>
-                </c:pt>
-              </c:strCache>
-            </c:strRef>
-          </c:tx>
-          <c:spPr>
-            <a:solidFill>
-              <a:srgbClr val="8E9AAF"/>
-            </a:solidFill>
-            <a:effectLst/>
-          </c:spPr>
-          <c:invertIfNegative val="0"/>
-          <c:dPt>
-            <c:idx val="0"/>
-            <c:invertIfNegative val="0"/>
-            <c:bubble3D val="0"/>
-            <c:spPr>
-              <a:solidFill>
-                <a:srgbClr val="8E9AAF"/>
-              </a:solidFill>
-              <a:effectLst/>
-            </c:spPr>
-          </c:dPt>
-          <c:dPt>
-            <c:idx val="1"/>
-            <c:invertIfNegative val="0"/>
-            <c:bubble3D val="0"/>
-            <c:spPr>
-              <a:solidFill>
-                <a:srgbClr val="F4A259"/>
-              </a:solidFill>
-              <a:effectLst/>
-            </c:spPr>
-          </c:dPt>
-          <c:dPt>
-            <c:idx val="2"/>
-            <c:invertIfNegative val="0"/>
-            <c:bubble3D val="0"/>
-            <c:spPr>
-              <a:solidFill>
-                <a:srgbClr val="8E9AAF"/>
-              </a:solidFill>
-              <a:effectLst/>
-            </c:spPr>
-          </c:dPt>
-          <c:dLbls>
-            <c:numFmt formatCode="0.0&quot;%&quot;" sourceLinked="0"/>
-            <c:txPr>
-              <a:bodyPr/>
-              <a:lstStyle/>
-              <a:p>
-                <a:pPr>
-                  <a:defRPr b="1" i="0" strike="noStrike" sz="1200" u="none">
-                    <a:solidFill>
-                      <a:srgbClr val="1B1F3B"/>
-                    </a:solidFill>
-                    <a:latin typeface="Malgun Gothic"/>
-                  </a:defRPr>
-                </a:pPr>
-              </a:p>
-            </c:txPr>
-            <c:showLegendKey val="0"/>
-            <c:showVal val="1"/>
-            <c:showCatName val="0"/>
-            <c:showSerName val="0"/>
-            <c:showPercent val="0"/>
-            <c:showBubbleSize val="0"/>
-            <c:showLeaderLines val="0"/>
-          </c:dLbls>
-          <c:cat>
-            <c:strRef>
-              <c:f>Sheet1!$A$2:$A$4</c:f>
-              <c:strCache>
-                <c:ptCount val="3"/>
-                <c:pt idx="0">
-                  <c:v>국내 대기업 평균</c:v>
-                </c:pt>
-                <c:pt idx="1">
-                  <c:v>우리 제안</c:v>
-                </c:pt>
-                <c:pt idx="2">
-                  <c:v>Patagonia</c:v>
-                </c:pt>
-              </c:strCache>
-            </c:strRef>
-          </c:cat>
-          <c:val>
-            <c:numRef>
-              <c:f>Sheet1!$B$2:$B$4</c:f>
-              <c:numCache>
-                <c:formatCode>General</c:formatCode>
-                <c:ptCount val="3"/>
-                <c:pt idx="0">
-                  <c:v>0.2</c:v>
-                </c:pt>
-                <c:pt idx="1">
-                  <c:v>0.5</c:v>
-                </c:pt>
-                <c:pt idx="2">
-                  <c:v>1</c:v>
-                </c:pt>
-              </c:numCache>
-            </c:numRef>
-          </c:val>
-        </c:ser>
-        <c:dLbls>
-          <c:numFmt formatCode="0.0&quot;%&quot;" sourceLinked="0"/>
-          <c:txPr>
-            <a:bodyPr/>
-            <a:lstStyle/>
-            <a:p>
-              <a:pPr>
-                <a:defRPr b="1" i="0" strike="noStrike" sz="1200" u="none">
-                  <a:solidFill>
-                    <a:srgbClr val="1B1F3B"/>
-                  </a:solidFill>
-                  <a:latin typeface="Malgun Gothic"/>
-                </a:defRPr>
-              </a:pPr>
-            </a:p>
-          </c:txPr>
-          <c:showLegendKey val="0"/>
-          <c:showVal val="1"/>
-          <c:showCatName val="0"/>
-          <c:showSerName val="0"/>
-          <c:showPercent val="0"/>
-          <c:showBubbleSize val="0"/>
-          <c:showLeaderLines val="0"/>
-        </c:dLbls>
-        <c:gapWidth val="60"/>
-        <c:overlap val="0"/>
-        <c:axId val="2094734554"/>
-        <c:axId val="2094734552"/>
-        <c:axId val="2094734556"/>
-      </c:barChart>
-      <c:catAx>
-        <c:axId val="2094734554"/>
-        <c:scaling>
-          <c:orientation val="minMax"/>
-        </c:scaling>
-        <c:delete val="0"/>
-        <c:axPos val="b"/>
-        <c:numFmt formatCode="General" sourceLinked="1"/>
-        <c:majorTickMark val="out"/>
-        <c:minorTickMark val="none"/>
-        <c:tickLblPos val="low"/>
-        <c:spPr>
-          <a:ln w="12700" cap="flat">
-            <a:solidFill>
-              <a:srgbClr val="888888"/>
-            </a:solidFill>
-            <a:prstDash val="solid"/>
-            <a:round/>
-          </a:ln>
-        </c:spPr>
-        <c:txPr>
-          <a:bodyPr/>
-          <a:lstStyle/>
-          <a:p>
-            <a:pPr>
-              <a:defRPr sz="1200" b="0" i="0" u="none" strike="noStrike">
-                <a:solidFill>
-                  <a:srgbClr val="2E3566"/>
-                </a:solidFill>
-                <a:latin typeface="Malgun Gothic"/>
-              </a:defRPr>
-            </a:pPr>
-            <a:endParaRPr lang="en-US"/>
-          </a:p>
-        </c:txPr>
-        <c:crossAx val="2094734552"/>
-        <c:crosses val="autoZero"/>
-        <c:auto val="1"/>
-        <c:lblAlgn val="ctr"/>
-        <c:noMultiLvlLbl val="1"/>
-      </c:catAx>
-      <c:valAx>
-        <c:axId val="2094734552"/>
-        <c:scaling>
-          <c:orientation val="minMax"/>
-          <c:max val="1.25"/>
-          <c:min val="0"/>
-        </c:scaling>
-        <c:delete val="1"/>
-        <c:axPos val="l"/>
-        <c:numFmt formatCode="General" sourceLinked="0"/>
-        <c:majorTickMark val="out"/>
-        <c:minorTickMark val="none"/>
-        <c:tickLblPos val="nextTo"/>
-        <c:spPr>
-          <a:ln w="12700" cap="flat">
-            <a:solidFill>
-              <a:srgbClr val="888888"/>
-            </a:solidFill>
-            <a:prstDash val="solid"/>
-            <a:round/>
-          </a:ln>
-        </c:spPr>
-        <c:txPr>
-          <a:bodyPr/>
-          <a:lstStyle/>
-          <a:p>
-            <a:pPr>
-              <a:defRPr sz="1200" b="0" i="0" u="none" strike="noStrike">
-                <a:solidFill>
-                  <a:srgbClr val="2E3566"/>
-                </a:solidFill>
-                <a:latin typeface="Malgun Gothic"/>
-              </a:defRPr>
-            </a:pPr>
-            <a:endParaRPr lang="en-US"/>
-          </a:p>
-        </c:txPr>
-        <c:crossAx val="2094734554"/>
-        <c:crosses val="autoZero"/>
-        <c:crossBetween val="between"/>
-      </c:valAx>
-      <c:spPr>
-        <a:noFill/>
-        <a:ln>
-          <a:noFill/>
-        </a:ln>
-        <a:effectLst/>
-      </c:spPr>
-    </c:plotArea>
-    <c:plotVisOnly val="1"/>
-    <c:dispBlanksAs val="span"/>
-  </c:chart>
-  <c:spPr>
-    <a:noFill/>
-    <a:ln>
-      <a:noFill/>
-    </a:ln>
-    <a:effectLst/>
-  </c:spPr>
-  <c:externalData r:id="rId1">
-    <c:autoUpdate val="0"/>
-  </c:externalData>
-</c:chartSpace>
-</file>
-
-<file path=ppt/charts/chart8.xml><?xml version="1.0" encoding="utf-8"?>
-<c:chartSpace xmlns:c="http://schemas.openxmlformats.org/drawingml/2006/chart" xmlns:a="http://schemas.openxmlformats.org/drawingml/2006/main" xmlns:r="http://schemas.openxmlformats.org/officeDocument/2006/relationships">
-  <c:date1904 val="0"/>
-  <c:roundedCorners val="0"/>
-  <c:chart>
-    <c:autoTitleDeleted val="1"/>
-    <c:plotArea>
-      <c:layout/>
-      <c:doughnutChart>
-        <c:varyColors val="1"/>
-        <c:ser>
-          <c:idx val="0"/>
-          <c:order val="0"/>
-          <c:tx>
-            <c:strRef>
-              <c:f>Sheet1!$B$1</c:f>
-              <c:strCache>
-                <c:ptCount val="1"/>
-                <c:pt idx="0">
-                  <c:v>환원 구성</c:v>
-                </c:pt>
-              </c:strCache>
-            </c:strRef>
-          </c:tx>
-          <c:spPr>
-            <a:solidFill>
-              <a:schemeClr val="accent1"/>
-            </a:solidFill>
-            <a:ln w="9525" cap="flat">
-              <a:solidFill>
-                <a:srgbClr val="F9F9F9"/>
-              </a:solidFill>
-              <a:prstDash val="solid"/>
-              <a:round/>
-            </a:ln>
-            <a:effectLst/>
-          </c:spPr>
-          <c:dPt>
-            <c:idx val="0"/>
-            <c:bubble3D val="0"/>
-            <c:spPr>
-              <a:solidFill>
-                <a:srgbClr val="5B6ABF"/>
-              </a:solidFill>
-              <a:ln w="12700" cap="flat">
-                <a:solidFill>
-                  <a:srgbClr val="FFFFFF"/>
-                </a:solidFill>
-                <a:prstDash val="solid"/>
-                <a:round/>
-              </a:ln>
-              <a:effectLst/>
-            </c:spPr>
-          </c:dPt>
-          <c:dPt>
-            <c:idx val="1"/>
-            <c:bubble3D val="0"/>
-            <c:spPr>
-              <a:solidFill>
-                <a:srgbClr val="F4A259"/>
-              </a:solidFill>
-              <a:ln w="12700" cap="flat">
-                <a:solidFill>
-                  <a:srgbClr val="FFFFFF"/>
-                </a:solidFill>
-                <a:prstDash val="solid"/>
-                <a:round/>
-              </a:ln>
-              <a:effectLst/>
-            </c:spPr>
-          </c:dPt>
-          <c:dPt>
-            <c:idx val="2"/>
-            <c:bubble3D val="0"/>
-            <c:spPr>
-              <a:solidFill>
-                <a:srgbClr val="3E8E7E"/>
-              </a:solidFill>
-              <a:ln w="12700" cap="flat">
-                <a:solidFill>
-                  <a:srgbClr val="FFFFFF"/>
-                </a:solidFill>
-                <a:prstDash val="solid"/>
-                <a:round/>
-              </a:ln>
-              <a:effectLst/>
-            </c:spPr>
-          </c:dPt>
-          <c:dPt>
-            <c:idx val="3"/>
-            <c:bubble3D val="0"/>
-            <c:spPr>
-              <a:solidFill>
-                <a:srgbClr val="E76F51"/>
-              </a:solidFill>
-              <a:ln w="12700" cap="flat">
-                <a:solidFill>
-                  <a:srgbClr val="FFFFFF"/>
-                </a:solidFill>
-                <a:prstDash val="solid"/>
-                <a:round/>
-              </a:ln>
-              <a:effectLst/>
-            </c:spPr>
-          </c:dPt>
-          <c:dLbls>
-            <c:dLbl>
-              <c:idx val="0"/>
-              <c:numFmt formatCode="General" sourceLinked="0"/>
-              <c:spPr/>
-              <c:txPr>
-                <a:bodyPr/>
-                <a:lstStyle/>
-                <a:p>
-                  <a:pPr>
-                    <a:defRPr sz="1200" b="0" i="0" u="none" strike="noStrike">
-                      <a:solidFill>
-                        <a:srgbClr val="000000"/>
-                      </a:solidFill>
-                      <a:latin typeface="Arial"/>
-                    </a:defRPr>
-                  </a:pPr>
-                </a:p>
-              </c:txPr>
-              <c:showLegendKey val="0"/>
-              <c:showVal val="0"/>
-              <c:showCatName val="0"/>
-              <c:showSerName val="0"/>
-              <c:showPercent val="0"/>
-              <c:showBubbleSize val="0"/>
-            </c:dLbl>
-            <c:dLbl>
-              <c:idx val="1"/>
-              <c:numFmt formatCode="General" sourceLinked="0"/>
-              <c:spPr/>
-              <c:txPr>
-                <a:bodyPr/>
-                <a:lstStyle/>
-                <a:p>
-                  <a:pPr>
-                    <a:defRPr sz="1200" b="0" i="0" u="none" strike="noStrike">
-                      <a:solidFill>
-                        <a:srgbClr val="000000"/>
-                      </a:solidFill>
-                      <a:latin typeface="Arial"/>
-                    </a:defRPr>
-                  </a:pPr>
-                </a:p>
-              </c:txPr>
-              <c:showLegendKey val="0"/>
-              <c:showVal val="0"/>
-              <c:showCatName val="0"/>
-              <c:showSerName val="0"/>
-              <c:showPercent val="0"/>
-              <c:showBubbleSize val="0"/>
-            </c:dLbl>
-            <c:dLbl>
-              <c:idx val="2"/>
-              <c:numFmt formatCode="General" sourceLinked="0"/>
-              <c:spPr/>
-              <c:txPr>
-                <a:bodyPr/>
-                <a:lstStyle/>
-                <a:p>
-                  <a:pPr>
-                    <a:defRPr sz="1200" b="0" i="0" u="none" strike="noStrike">
-                      <a:solidFill>
-                        <a:srgbClr val="000000"/>
-                      </a:solidFill>
-                      <a:latin typeface="Arial"/>
-                    </a:defRPr>
-                  </a:pPr>
-                </a:p>
-              </c:txPr>
-              <c:showLegendKey val="0"/>
-              <c:showVal val="0"/>
-              <c:showCatName val="0"/>
-              <c:showSerName val="0"/>
-              <c:showPercent val="0"/>
-              <c:showBubbleSize val="0"/>
-            </c:dLbl>
-            <c:dLbl>
-              <c:idx val="3"/>
-              <c:numFmt formatCode="General" sourceLinked="0"/>
-              <c:spPr/>
-              <c:txPr>
-                <a:bodyPr/>
-                <a:lstStyle/>
-                <a:p>
-                  <a:pPr>
-                    <a:defRPr sz="1200" b="0" i="0" u="none" strike="noStrike">
-                      <a:solidFill>
-                        <a:srgbClr val="000000"/>
-                      </a:solidFill>
-                      <a:latin typeface="Arial"/>
-                    </a:defRPr>
-                  </a:pPr>
-                </a:p>
-              </c:txPr>
-              <c:showLegendKey val="0"/>
-              <c:showVal val="0"/>
-              <c:showCatName val="0"/>
-              <c:showSerName val="0"/>
-              <c:showPercent val="0"/>
-              <c:showBubbleSize val="0"/>
-            </c:dLbl>
-            <c:numFmt formatCode="General" sourceLinked="0"/>
-            <c:txPr>
-              <a:bodyPr/>
-              <a:lstStyle/>
-              <a:p>
-                <a:pPr>
-                  <a:defRPr sz="1800" b="0" i="0" u="none" strike="noStrike">
-                    <a:solidFill>
-                      <a:srgbClr val="000000"/>
-                    </a:solidFill>
-                    <a:latin typeface="Arial"/>
-                  </a:defRPr>
-                </a:pPr>
-              </a:p>
-            </c:txPr>
-            <c:showLegendKey val="0"/>
-            <c:showVal val="0"/>
-            <c:showCatName val="1"/>
-            <c:showSerName val="0"/>
-            <c:showPercent val="1"/>
-            <c:showBubbleSize val="0"/>
-            <c:showLeaderLines val="0"/>
-          </c:dLbls>
-          <c:cat>
-            <c:strRef>
-              <c:f>Sheet1!$A$2:$A$5</c:f>
-              <c:strCache>
-                <c:ptCount val="4"/>
-                <c:pt idx="0">
-                  <c:v>제품 기부 40%</c:v>
-                </c:pt>
-                <c:pt idx="1">
-                  <c:v>후원금 30%</c:v>
-                </c:pt>
-                <c:pt idx="2">
-                  <c:v>재능기부 15%</c:v>
-                </c:pt>
-                <c:pt idx="3">
-                  <c:v>봉사 15%</c:v>
-                </c:pt>
-              </c:strCache>
-            </c:strRef>
-          </c:cat>
-          <c:val>
-            <c:numRef>
-              <c:f>Sheet1!$B$2:$B$5</c:f>
-              <c:numCache>
-                <c:ptCount val="4"/>
-                <c:pt idx="0">
-                  <c:v>40</c:v>
-                </c:pt>
-                <c:pt idx="1">
-                  <c:v>30</c:v>
-                </c:pt>
-                <c:pt idx="2">
-                  <c:v>15</c:v>
-                </c:pt>
-                <c:pt idx="3">
-                  <c:v>15</c:v>
-                </c:pt>
-              </c:numCache>
-            </c:numRef>
-          </c:val>
-        </c:ser>
-        <c:firstSliceAng val="0"/>
-        <c:holeSize val="55"/>
-      </c:doughnutChart>
-      <c:spPr>
-        <a:noFill/>
-        <a:ln>
-          <a:noFill/>
-        </a:ln>
-        <a:effectLst/>
-      </c:spPr>
-    </c:plotArea>
-    <c:legend>
-      <c:legendPos val="b"/>
-      <c:overlay val="0"/>
-      <c:txPr>
-        <a:bodyPr/>
-        <a:lstStyle/>
-        <a:p>
-          <a:pPr>
-            <a:defRPr sz="1200">
-              <a:solidFill>
-                <a:srgbClr val="2E3566"/>
-              </a:solidFill>
-              <a:latin typeface="Malgun Gothic"/>
-              <a:cs typeface="Malgun Gothic"/>
-            </a:defRPr>
-          </a:pPr>
-          <a:endParaRPr lang="en-US"/>
-        </a:p>
-      </c:txPr>
-    </c:legend>
-    <c:plotVisOnly val="1"/>
-    <c:dispBlanksAs val="span"/>
-  </c:chart>
-  <c:spPr>
-    <a:noFill/>
-    <a:ln>
-      <a:noFill/>
-    </a:ln>
-    <a:effectLst/>
-  </c:spPr>
-  <c:externalData r:id="rId1">
-    <c:autoUpdate val="0"/>
-  </c:externalData>
-</c:chartSpace>
 </file>
 
 <file path=ppt/notesMasters/notesMaster1.xml><?xml version="1.0" encoding="utf-8"?>
@@ -9242,72 +6141,30 @@
           </a:p>
         </p:txBody>
       </p:sp>
-      <p:graphicFrame>
-        <p:nvGraphicFramePr>
-          <p:cNvPr id="4" name="Chart 0" descr=""/>
-          <p:cNvGraphicFramePr/>
+      <p:pic>
+        <p:nvPicPr>
+          <p:cNvPr id="4" name="차트 4" descr="재료비 차트">    </p:cNvPr>
+          <p:cNvPicPr>
+            <a:picLocks noChangeAspect="1"/>
+          </p:cNvPicPr>
           <p:nvPr/>
-        </p:nvGraphicFramePr>
-        <p:xfrm>
-          <a:off x="548640" y="1371600"/>
-          <a:ext cx="5669280" cy="4754880"/>
-        </p:xfrm>
-        <a:graphic xmlns:a="http://schemas.openxmlformats.org/drawingml/2006/main">
-          <a:graphicData uri="http://schemas.openxmlformats.org/drawingml/2006/chart">
-            <c:chart xmlns:c="http://schemas.openxmlformats.org/drawingml/2006/chart" r:id="rId1"/>
-          </a:graphicData>
-        </a:graphic>
-      </p:graphicFrame>
-      <p:sp>
-        <p:nvSpPr>
-          <p:cNvPr id="5" name="도넛 중앙 텍스트"/>
-          <p:cNvSpPr txBox="1"/>
-          <p:nvPr/>
-        </p:nvSpPr>
-        <p:spPr>
-          <a:xfrm>
-            <a:off x="2240280" y="2743200"/>
-            <a:ext cx="2286000" cy="914400"/>
+        </p:nvPicPr>
+        <p:blipFill>
+          <a:blip r:embed="rId1"/>
+          <a:stretch>
+            <a:fillRect/>
+          </a:stretch>
+        </p:blipFill>
+        <p:spPr>
+          <a:xfrm>
+            <a:off x="548640" y="1371600"/>
+            <a:ext cx="5669280" cy="4754880"/>
           </a:xfrm>
           <a:prstGeom prst="rect">
             <a:avLst/>
           </a:prstGeom>
-          <a:noFill/>
-          <a:ln/>
-        </p:spPr>
-        <p:txBody>
-          <a:bodyPr wrap="square" lIns="0" tIns="0" rIns="0" bIns="0" rtlCol="0" anchor="ctr"/>
-          <a:lstStyle/>
-          <a:p>
-            <a:pPr algn="ctr" indent="0" marL="0">
-              <a:buNone/>
-            </a:pPr>
-            <a:r>
-              <a:rPr lang="en-US" sz="2000" b="1" dirty="0">
-                <a:solidFill>
-                  <a:schemeClr val="tx1"/>
-                </a:solidFill>
-              </a:rPr>
-              <a:t>재료비</a:t>
-            </a:r>
-            <a:endParaRPr lang="en-US" sz="2000" dirty="0"/>
-          </a:p>
-          <a:p>
-            <a:pPr algn="ctr" indent="0" marL="0">
-              <a:buNone/>
-            </a:pPr>
-            <a:r>
-              <a:rPr lang="en-US" sz="2000" b="1" dirty="0">
-                <a:solidFill>
-                  <a:schemeClr val="tx1"/>
-                </a:solidFill>
-              </a:rPr>
-              <a:t>34,000원</a:t>
-            </a:r>
-            <a:endParaRPr lang="en-US" sz="2000" dirty="0"/>
-          </a:p>
-        </p:txBody>
-      </p:sp>
+        </p:spPr>
+      </p:pic>
       <p:graphicFrame>
         <p:nvGraphicFramePr>
           <p:cNvPr id="13" name="부품 표"/>
@@ -11006,7 +7863,7 @@
       </p:graphicFrame>
       <p:sp>
         <p:nvSpPr>
-          <p:cNvPr id="7" name="원가 가정 카드"/>
+          <p:cNvPr id="6" name="원가 가정 카드"/>
           <p:cNvSpPr/>
           <p:nvPr/>
         </p:nvSpPr>
@@ -11033,7 +7890,7 @@
       </p:sp>
       <p:sp>
         <p:nvSpPr>
-          <p:cNvPr id="8" name="원가 가정"/>
+          <p:cNvPr id="7" name="원가 가정"/>
           <p:cNvSpPr txBox="1"/>
           <p:nvPr/>
         </p:nvSpPr>
@@ -11175,22 +8032,30 @@
           </a:p>
         </p:txBody>
       </p:sp>
-      <p:graphicFrame>
-        <p:nvGraphicFramePr>
-          <p:cNvPr id="4" name="Chart 0" descr=""/>
-          <p:cNvGraphicFramePr/>
+      <p:pic>
+        <p:nvPicPr>
+          <p:cNvPr id="4" name="차트 5" descr="월별 판매 대수 (기본안, 합계 10,000대) 차트">    </p:cNvPr>
+          <p:cNvPicPr>
+            <a:picLocks noChangeAspect="1"/>
+          </p:cNvPicPr>
           <p:nvPr/>
-        </p:nvGraphicFramePr>
-        <p:xfrm>
-          <a:off x="548640" y="1371600"/>
-          <a:ext cx="6766560" cy="4297680"/>
-        </p:xfrm>
-        <a:graphic xmlns:a="http://schemas.openxmlformats.org/drawingml/2006/main">
-          <a:graphicData uri="http://schemas.openxmlformats.org/drawingml/2006/chart">
-            <c:chart xmlns:c="http://schemas.openxmlformats.org/drawingml/2006/chart" r:id="rId1"/>
-          </a:graphicData>
-        </a:graphic>
-      </p:graphicFrame>
+        </p:nvPicPr>
+        <p:blipFill>
+          <a:blip r:embed="rId1"/>
+          <a:stretch>
+            <a:fillRect/>
+          </a:stretch>
+        </p:blipFill>
+        <p:spPr>
+          <a:xfrm>
+            <a:off x="548640" y="1371600"/>
+            <a:ext cx="6766560" cy="4297680"/>
+          </a:xfrm>
+          <a:prstGeom prst="rect">
+            <a:avLst/>
+          </a:prstGeom>
+        </p:spPr>
+      </p:pic>
       <p:sp>
         <p:nvSpPr>
           <p:cNvPr id="5" name="시나리오 카드 1"/>
@@ -11740,22 +8605,30 @@
           </a:p>
         </p:txBody>
       </p:sp>
-      <p:graphicFrame>
-        <p:nvGraphicFramePr>
-          <p:cNvPr id="4" name="Chart 0" descr=""/>
-          <p:cNvGraphicFramePr/>
+      <p:pic>
+        <p:nvPicPr>
+          <p:cNvPr id="4" name="차트 6" descr="매출액과 영업이익 (억원) 차트">    </p:cNvPr>
+          <p:cNvPicPr>
+            <a:picLocks noChangeAspect="1"/>
+          </p:cNvPicPr>
           <p:nvPr/>
-        </p:nvGraphicFramePr>
-        <p:xfrm>
-          <a:off x="548640" y="1371600"/>
-          <a:ext cx="6766560" cy="4572000"/>
-        </p:xfrm>
-        <a:graphic xmlns:a="http://schemas.openxmlformats.org/drawingml/2006/main">
-          <a:graphicData uri="http://schemas.openxmlformats.org/drawingml/2006/chart">
-            <c:chart xmlns:c="http://schemas.openxmlformats.org/drawingml/2006/chart" r:id="rId1"/>
-          </a:graphicData>
-        </a:graphic>
-      </p:graphicFrame>
+        </p:nvPicPr>
+        <p:blipFill>
+          <a:blip r:embed="rId1"/>
+          <a:stretch>
+            <a:fillRect/>
+          </a:stretch>
+        </p:blipFill>
+        <p:spPr>
+          <a:xfrm>
+            <a:off x="548640" y="1371600"/>
+            <a:ext cx="6766560" cy="4572000"/>
+          </a:xfrm>
+          <a:prstGeom prst="rect">
+            <a:avLst/>
+          </a:prstGeom>
+        </p:spPr>
+      </p:pic>
       <p:sp>
         <p:nvSpPr>
           <p:cNvPr id="5" name="전망 카드 1"/>
@@ -14778,22 +11651,30 @@
           </a:p>
         </p:txBody>
       </p:sp>
-      <p:graphicFrame>
-        <p:nvGraphicFramePr>
-          <p:cNvPr id="4" name="Chart 0" descr=""/>
-          <p:cNvGraphicFramePr/>
+      <p:pic>
+        <p:nvPicPr>
+          <p:cNvPr id="4" name="차트 7" descr="매출 대비 기부 비율 차트">    </p:cNvPr>
+          <p:cNvPicPr>
+            <a:picLocks noChangeAspect="1"/>
+          </p:cNvPicPr>
           <p:nvPr/>
-        </p:nvGraphicFramePr>
-        <p:xfrm>
-          <a:off x="548640" y="1371600"/>
-          <a:ext cx="5669280" cy="4572000"/>
-        </p:xfrm>
-        <a:graphic xmlns:a="http://schemas.openxmlformats.org/drawingml/2006/main">
-          <a:graphicData uri="http://schemas.openxmlformats.org/drawingml/2006/chart">
-            <c:chart xmlns:c="http://schemas.openxmlformats.org/drawingml/2006/chart" r:id="rId1"/>
-          </a:graphicData>
-        </a:graphic>
-      </p:graphicFrame>
+        </p:nvPicPr>
+        <p:blipFill>
+          <a:blip r:embed="rId1"/>
+          <a:stretch>
+            <a:fillRect/>
+          </a:stretch>
+        </p:blipFill>
+        <p:spPr>
+          <a:xfrm>
+            <a:off x="548640" y="1371600"/>
+            <a:ext cx="5669280" cy="4572000"/>
+          </a:xfrm>
+          <a:prstGeom prst="rect">
+            <a:avLst/>
+          </a:prstGeom>
+        </p:spPr>
+      </p:pic>
       <p:sp>
         <p:nvSpPr>
           <p:cNvPr id="5" name="벤치마크 카드 1"/>
@@ -16069,22 +12950,30 @@
           </a:p>
         </p:txBody>
       </p:sp>
-      <p:graphicFrame>
-        <p:nvGraphicFramePr>
-          <p:cNvPr id="4" name="Chart 0" descr=""/>
-          <p:cNvGraphicFramePr/>
+      <p:pic>
+        <p:nvPicPr>
+          <p:cNvPr id="4" name="차트 8" descr="환원 구성 차트">    </p:cNvPr>
+          <p:cNvPicPr>
+            <a:picLocks noChangeAspect="1"/>
+          </p:cNvPicPr>
           <p:nvPr/>
-        </p:nvGraphicFramePr>
-        <p:xfrm>
-          <a:off x="548640" y="1371600"/>
-          <a:ext cx="4023360" cy="3931920"/>
-        </p:xfrm>
-        <a:graphic xmlns:a="http://schemas.openxmlformats.org/drawingml/2006/main">
-          <a:graphicData uri="http://schemas.openxmlformats.org/drawingml/2006/chart">
-            <c:chart xmlns:c="http://schemas.openxmlformats.org/drawingml/2006/chart" r:id="rId1"/>
-          </a:graphicData>
-        </a:graphic>
-      </p:graphicFrame>
+        </p:nvPicPr>
+        <p:blipFill>
+          <a:blip r:embed="rId1"/>
+          <a:stretch>
+            <a:fillRect/>
+          </a:stretch>
+        </p:blipFill>
+        <p:spPr>
+          <a:xfrm>
+            <a:off x="548640" y="1371600"/>
+            <a:ext cx="4023360" cy="3931920"/>
+          </a:xfrm>
+          <a:prstGeom prst="rect">
+            <a:avLst/>
+          </a:prstGeom>
+        </p:spPr>
+      </p:pic>
       <p:graphicFrame>
         <p:nvGraphicFramePr>
           <p:cNvPr id="20" name="환원 금액 표"/>
@@ -24191,22 +21080,30 @@
           </a:p>
         </p:txBody>
       </p:sp>
-      <p:graphicFrame>
-        <p:nvGraphicFramePr>
-          <p:cNvPr id="4" name="Chart 0" descr=""/>
-          <p:cNvGraphicFramePr/>
+      <p:pic>
+        <p:nvPicPr>
+          <p:cNvPr id="4" name="차트 1" descr="1년 매출 추정 (백만 달러) 차트">    </p:cNvPr>
+          <p:cNvPicPr>
+            <a:picLocks noChangeAspect="1"/>
+          </p:cNvPicPr>
           <p:nvPr/>
-        </p:nvGraphicFramePr>
-        <p:xfrm>
-          <a:off x="548640" y="1463040"/>
-          <a:ext cx="5669280" cy="4389120"/>
-        </p:xfrm>
-        <a:graphic xmlns:a="http://schemas.openxmlformats.org/drawingml/2006/main">
-          <a:graphicData uri="http://schemas.openxmlformats.org/drawingml/2006/chart">
-            <c:chart xmlns:c="http://schemas.openxmlformats.org/drawingml/2006/chart" r:id="rId1"/>
-          </a:graphicData>
-        </a:graphic>
-      </p:graphicFrame>
+        </p:nvPicPr>
+        <p:blipFill>
+          <a:blip r:embed="rId1"/>
+          <a:stretch>
+            <a:fillRect/>
+          </a:stretch>
+        </p:blipFill>
+        <p:spPr>
+          <a:xfrm>
+            <a:off x="548640" y="1463040"/>
+            <a:ext cx="5669280" cy="4389120"/>
+          </a:xfrm>
+          <a:prstGeom prst="rect">
+            <a:avLst/>
+          </a:prstGeom>
+        </p:spPr>
+      </p:pic>
       <p:sp>
         <p:nvSpPr>
           <p:cNvPr id="5" name="산식 카드 1"/>
@@ -24621,22 +21518,30 @@
           </a:p>
         </p:txBody>
       </p:sp>
-      <p:graphicFrame>
-        <p:nvGraphicFramePr>
-          <p:cNvPr id="4" name="Chart 0" descr=""/>
-          <p:cNvGraphicFramePr/>
+      <p:pic>
+        <p:nvPicPr>
+          <p:cNvPr id="4" name="차트 2" descr="비용·이익 구성 (매출 100%) 차트">    </p:cNvPr>
+          <p:cNvPicPr>
+            <a:picLocks noChangeAspect="1"/>
+          </p:cNvPicPr>
           <p:nvPr/>
-        </p:nvGraphicFramePr>
-        <p:xfrm>
-          <a:off x="548640" y="1371600"/>
-          <a:ext cx="5212080" cy="4754880"/>
-        </p:xfrm>
-        <a:graphic xmlns:a="http://schemas.openxmlformats.org/drawingml/2006/main">
-          <a:graphicData uri="http://schemas.openxmlformats.org/drawingml/2006/chart">
-            <c:chart xmlns:c="http://schemas.openxmlformats.org/drawingml/2006/chart" r:id="rId1"/>
-          </a:graphicData>
-        </a:graphic>
-      </p:graphicFrame>
+        </p:nvPicPr>
+        <p:blipFill>
+          <a:blip r:embed="rId1"/>
+          <a:stretch>
+            <a:fillRect/>
+          </a:stretch>
+        </p:blipFill>
+        <p:spPr>
+          <a:xfrm>
+            <a:off x="548640" y="1371600"/>
+            <a:ext cx="5212080" cy="4754880"/>
+          </a:xfrm>
+          <a:prstGeom prst="rect">
+            <a:avLst/>
+          </a:prstGeom>
+        </p:spPr>
+      </p:pic>
       <p:graphicFrame>
         <p:nvGraphicFramePr>
           <p:cNvPr id="9" name="비용 구조 표"/>
@@ -26319,22 +23224,30 @@
           </a:p>
         </p:txBody>
       </p:sp>
-      <p:graphicFrame>
-        <p:nvGraphicFramePr>
-          <p:cNvPr id="4" name="Chart 0" descr=""/>
-          <p:cNvGraphicFramePr/>
+      <p:pic>
+        <p:nvPicPr>
+          <p:cNvPr id="4" name="차트 3" descr="가격 포지션 (달러) 차트">    </p:cNvPr>
+          <p:cNvPicPr>
+            <a:picLocks noChangeAspect="1"/>
+          </p:cNvPicPr>
           <p:nvPr/>
-        </p:nvGraphicFramePr>
-        <p:xfrm>
-          <a:off x="548640" y="1371600"/>
-          <a:ext cx="5669280" cy="4572000"/>
-        </p:xfrm>
-        <a:graphic xmlns:a="http://schemas.openxmlformats.org/drawingml/2006/main">
-          <a:graphicData uri="http://schemas.openxmlformats.org/drawingml/2006/chart">
-            <c:chart xmlns:c="http://schemas.openxmlformats.org/drawingml/2006/chart" r:id="rId1"/>
-          </a:graphicData>
-        </a:graphic>
-      </p:graphicFrame>
+        </p:nvPicPr>
+        <p:blipFill>
+          <a:blip r:embed="rId1"/>
+          <a:stretch>
+            <a:fillRect/>
+          </a:stretch>
+        </p:blipFill>
+        <p:spPr>
+          <a:xfrm>
+            <a:off x="548640" y="1371600"/>
+            <a:ext cx="5669280" cy="4572000"/>
+          </a:xfrm>
+          <a:prstGeom prst="rect">
+            <a:avLst/>
+          </a:prstGeom>
+        </p:spPr>
+      </p:pic>
       <p:sp>
         <p:nvSpPr>
           <p:cNvPr id="5" name="시사점 카드 1"/>

</xml_diff>

<commit_message>
Correct Hatch revenue, add Wadiz fees, certification costs, Korean survey, PL and component pricing from deeper research
Co-Authored-By: Claude Sonnet 5.5 <noreply@anthropic.com>
Claude-Session: https://claude.ai/code/session_01C8esidZTnz37pFUEU5sMqP
</commit_message>
<xml_diff>
--- a/MorningHands_Business_Analysis.pptx
+++ b/MorningHands_Business_Analysis.pptx
@@ -131,17 +131,17 @@
   <p:extLst>
     <p:ext uri="{521415D9-36F7-43E2-AB2F-B90AF26B5E84}">
       <p14:sectionLst xmlns:p14="http://schemas.microsoft.com/office/powerpoint/2010/main">
-        <p14:section name="표지" id="{a1ee0021-7b84-f710-2c62-b21abe37be4f}">
+        <p14:section name="표지" id="{3746e082-9236-9806-9443-b107a929734c}">
           <p14:sldIdLst>
             <p14:sldId id="256"/>
           </p14:sldIdLst>
         </p14:section>
-        <p14:section name="요약" id="{7af9ee38-f127-dada-29e2-3f76b04cc99a}">
+        <p14:section name="요약" id="{f5e262ba-c6bf-bb13-0bc1-ea8174ddd901}">
           <p14:sldIdLst>
             <p14:sldId id="257"/>
           </p14:sldIdLst>
         </p14:section>
-        <p14:section name="1부 경쟁 제품 조사" id="{558fda82-8f9f-65b1-2535-e6e88a4e3e4f}">
+        <p14:section name="1부 경쟁 제품 조사" id="{e704d059-0808-7948-08dd-de1d110f5329}">
           <p14:sldIdLst>
             <p14:sldId id="258"/>
             <p14:sldId id="259"/>
@@ -153,7 +153,7 @@
             <p14:sldId id="265"/>
           </p14:sldIdLst>
         </p14:section>
-        <p14:section name="2부 우리 제품 매출 예상" id="{8c19c26e-cfc9-e4da-d9f7-737b91b3c136}">
+        <p14:section name="2부 우리 제품 매출 예상" id="{a85a1c1e-4743-6586-768f-4c366ffce62a}">
           <p14:sldIdLst>
             <p14:sldId id="266"/>
             <p14:sldId id="267"/>
@@ -164,7 +164,7 @@
             <p14:sldId id="272"/>
           </p14:sldIdLst>
         </p14:section>
-        <p14:section name="3부 사회 환원" id="{44260603-17b4-9ab4-f61e-fa017c84f3d0}">
+        <p14:section name="3부 사회 환원" id="{303d256d-9e78-b2d4-4430-35735cab2bbc}">
           <p14:sldIdLst>
             <p14:sldId id="273"/>
             <p14:sldId id="274"/>
@@ -172,12 +172,12 @@
             <p14:sldId id="276"/>
           </p14:sldIdLst>
         </p14:section>
-        <p14:section name="리스크" id="{8b31dc22-495c-2afc-b7d3-b108bb313117}">
+        <p14:section name="리스크" id="{bc8ca375-4530-3386-4136-fd162cea2cf5}">
           <p14:sldIdLst>
             <p14:sldId id="277"/>
           </p14:sldIdLst>
         </p14:section>
-        <p14:section name="실행 계획" id="{e562410f-d58c-5161-88b5-5d51bee0f999}">
+        <p14:section name="실행 계획" id="{ff57e0ef-b494-2101-b54a-0925a04e308e}">
           <p14:sldIdLst>
             <p14:sldId id="278"/>
             <p14:sldId id="279"/>
@@ -2348,7 +2348,7 @@
           <a:p>
             <a:r>
               <a:rPr lang="en-US" dirty="0"/>
-              <a:t>해외 연구 두 건으로 알람을 미루는 행동이 흔하다는 점은 확인됩니다. 한국 직장인 대상 조사는 찾지 못했습니다.</a:t>
+              <a:t>해외 연구 두 건과 국내 설문 한 건으로 알람을 미루고 늦잠으로 지각하는 일이 흔하다는 점은 확인됩니다. 국내 자료는 2011년 것입니다.</a:t>
             </a:r>
             <a:endParaRPr lang="en-US" dirty="0"/>
           </a:p>
@@ -15171,7 +15171,7 @@
                   <a:schemeClr val="bg1"/>
                 </a:solidFill>
               </a:rPr>
-              <a:t>해석: 같은 1만 대라도 가격을 11.9만원으로 올리면 영업손익이 -1.75억에서 -0.20억으로 개선됩니다. 스마트 베개($199~299)와 비교해 가격 인상 여지가 있으므로, 크라우드펀딩에서 9.9만원·11.9만원을 함께 시험하는 것을 권합니다. 서보 모터는 소량 소매가가 $11~14라 대량 견적 전에는 재료비 +50%까지 대비해야 합니다.</a:t>
+              <a:t>해석: 같은 1만 대라도 가격을 11.9만원으로 올리면 영업손익이 -1.75억에서 -0.20억으로 개선됩니다. 스마트 베개($199~299)와 비교해 가격 인상 여지가 있으므로, 크라우드펀딩에서 9.9만원·11.9만원을 함께 시험하는 것을 권합니다. 서보는 소량 소매가 $11~14, 1,000개 도매 약 $1.47로 편차가 커서 견적 전에는 재료비 +50%까지 대비해야 합니다.</a:t>
             </a:r>
             <a:endParaRPr lang="en-US" sz="1400" dirty="0"/>
           </a:p>
@@ -15884,7 +15884,7 @@
                   <a:schemeClr val="tx2"/>
                 </a:solidFill>
               </a:rPr>
-              <a:t>일반기부금은 소득금액의 10% 한도로 비용 인정, 초과분은 10년 이월. 현물은 장부가 평가 (2차 자료, 세무사 확인 필요)</a:t>
+              <a:t>일반기부금 한도는 (소득금액-이월결손금)의 10%라 적자 구간엔 공제가 안 되고 초과분은 10년 이월. 현물 기부의 부가세는 확인 필요</a:t>
             </a:r>
             <a:endParaRPr lang="en-US" sz="1200" dirty="0"/>
           </a:p>
@@ -16104,7 +16104,7 @@
                   <a:schemeClr val="tx1"/>
                 </a:solidFill>
               </a:rPr>
-              <a:t>$1M~$7M</a:t>
+              <a:t>$4M~140M</a:t>
             </a:r>
             <a:endParaRPr lang="en-US" sz="4000" dirty="0"/>
           </a:p>
@@ -16176,7 +16176,7 @@
                   <a:schemeClr val="tx2"/>
                 </a:solidFill>
               </a:rPr>
-              <a:t>Clocky 연 $0.9~4.2M, Hatch 연 $5~7M(제3자 추정). 재료비와 제작 인건비는 소비자가의 약 30%로 가정했습니다.</a:t>
+              <a:t>Clocky 연 $0.9~4.2M, Hatch 연 약 $140~200M(언론 보도). 재료비와 제작 인건비는 소비자가의 약 30%로 가정했습니다.</a:t>
             </a:r>
             <a:endParaRPr lang="en-US" sz="1400" dirty="0"/>
           </a:p>
@@ -19629,7 +19629,7 @@
                   <a:schemeClr val="tx2"/>
                 </a:solidFill>
               </a:rPr>
-              <a:t>수면 중 접촉으로 어린이·고령자가 다칠 수 있습니다. 힘 제한, 정지 센서, PL 보험(지자체 보험료 지원 10~30%)을 갖춥니다.</a:t>
+              <a:t>수면 중 접촉으로 어린이·고령자가 다칠 수 있습니다. 힘 제한, 정지 센서, PL 단체보험(일반 대비 20~28% 저렴, 지자체 지원)을 갖춥니다.</a:t>
             </a:r>
             <a:endParaRPr lang="en-US" sz="1300" dirty="0"/>
           </a:p>
@@ -19777,7 +19777,7 @@
                   <a:schemeClr val="tx2"/>
                 </a:solidFill>
               </a:rPr>
-              <a:t>내장 배터리는 KC 전기안전확인 대상입니다. 업체 추정 약 700~1,500만원, 4~12주. 전파인증은 별도 견적이 필요합니다.</a:t>
+              <a:t>배터리 KC 700~1,500만원(4~12주), 블루투스 RF·EMC 시험 200~300만원(각 2~3주). 합계 약 1,000~1,800만원(추정).</a:t>
             </a:r>
             <a:endParaRPr lang="en-US" sz="1300" dirty="0"/>
           </a:p>
@@ -22476,7 +22476,7 @@
                             <a:schemeClr val="tx1"/>
                           </a:solidFill>
                         </a:rPr>
-                        <a:t>제3자 추정 $5~7M, 비공개 기업</a:t>
+                        <a:t>언론 보도 $140~200M, 비공개 기업(DB 추정 $6.9M와 상충)</a:t>
                       </a:r>
                       <a:endParaRPr lang="en-US" sz="1300" dirty="0"/>
                     </a:p>
@@ -22534,10 +22534,10 @@
                       <a:r>
                         <a:rPr lang="en-US" sz="1300" b="1" dirty="0">
                           <a:solidFill>
-                            <a:schemeClr val="accent4"/>
+                            <a:schemeClr val="tx1"/>
                           </a:solidFill>
                         </a:rPr>
-                        <a:t>낮음</a:t>
+                        <a:t>중</a:t>
                       </a:r>
                       <a:endParaRPr lang="en-US" sz="1300" dirty="0"/>
                     </a:p>
@@ -22598,7 +22598,7 @@
                             <a:schemeClr val="tx1"/>
                           </a:solidFill>
                         </a:rPr>
-                        <a:t>참고용으로만 사용</a:t>
+                        <a:t>최신 보도 재확인</a:t>
                       </a:r>
                       <a:endParaRPr lang="en-US" sz="1300" dirty="0"/>
                     </a:p>
@@ -23214,7 +23214,7 @@
                             <a:schemeClr val="tx1"/>
                           </a:solidFill>
                         </a:rPr>
-                        <a:t>가정. 서보 소매가 $11~14(소량) 대비 낮게 잡음</a:t>
+                        <a:t>서보 1,000개 약 $1.47, MCU 모듈 약 $1~2는 부합. 배터리 미확인</a:t>
                       </a:r>
                       <a:endParaRPr lang="en-US" sz="1300" dirty="0"/>
                     </a:p>
@@ -23272,10 +23272,10 @@
                       <a:r>
                         <a:rPr lang="en-US" sz="1300" b="1" dirty="0">
                           <a:solidFill>
-                            <a:schemeClr val="accent4"/>
+                            <a:schemeClr val="tx1"/>
                           </a:solidFill>
                         </a:rPr>
-                        <a:t>낮음</a:t>
+                        <a:t>중</a:t>
                       </a:r>
                       <a:endParaRPr lang="en-US" sz="1300" dirty="0"/>
                     </a:p>
@@ -23336,7 +23336,7 @@
                             <a:schemeClr val="tx1"/>
                           </a:solidFill>
                         </a:rPr>
-                        <a:t>OEM·부품사 3곳 대량 견적</a:t>
+                        <a:t>OEM·부품사 3곳 견적</a:t>
                       </a:r>
                       <a:endParaRPr lang="en-US" sz="1300" dirty="0"/>
                     </a:p>
@@ -23460,7 +23460,7 @@
                             <a:schemeClr val="tx1"/>
                           </a:solidFill>
                         </a:rPr>
-                        <a:t>블로그·기사 요율</a:t>
+                        <a:t>와디즈 공식 요금제 확인, 스토어·쿠팡은 블로그</a:t>
                       </a:r>
                       <a:endParaRPr lang="en-US" sz="1300" dirty="0"/>
                     </a:p>
@@ -23582,7 +23582,7 @@
                             <a:schemeClr val="tx1"/>
                           </a:solidFill>
                         </a:rPr>
-                        <a:t>플랫폼 공식 요율 확인</a:t>
+                        <a:t>스토어·쿠팡 공식 요율</a:t>
                       </a:r>
                       <a:endParaRPr lang="en-US" sz="1300" dirty="0"/>
                     </a:p>
@@ -23706,7 +23706,7 @@
                             <a:schemeClr val="tx1"/>
                           </a:solidFill>
                         </a:rPr>
-                        <a:t>배터리 KC 업체 추정 700~1,500만원, 4~12주</a:t>
+                        <a:t>배터리 700~1,500만원, 블루투스 시험 200~300만원(업체 안내)</a:t>
                       </a:r>
                       <a:endParaRPr lang="en-US" sz="1300" dirty="0"/>
                     </a:p>
@@ -23764,10 +23764,10 @@
                       <a:r>
                         <a:rPr lang="en-US" sz="1300" b="1" dirty="0">
                           <a:solidFill>
-                            <a:schemeClr val="accent4"/>
+                            <a:schemeClr val="tx1"/>
                           </a:solidFill>
                         </a:rPr>
-                        <a:t>낮음</a:t>
+                        <a:t>중</a:t>
                       </a:r>
                       <a:endParaRPr lang="en-US" sz="1300" dirty="0"/>
                     </a:p>
@@ -23828,7 +23828,7 @@
                             <a:schemeClr val="tx1"/>
                           </a:solidFill>
                         </a:rPr>
-                        <a:t>시험기관 견적, 전파인증 포함</a:t>
+                        <a:t>시험기관 견적</a:t>
                       </a:r>
                       <a:endParaRPr lang="en-US" sz="1300" dirty="0"/>
                     </a:p>
@@ -23952,7 +23952,7 @@
                             <a:schemeClr val="tx1"/>
                           </a:solidFill>
                         </a:rPr>
-                        <a:t>언론 보도, 2차 세무 자료. 현물의 부가세는 미확인</a:t>
+                        <a:t>10% 한도는 서식 확인, 현물 부가세 미확인</a:t>
                       </a:r>
                       <a:endParaRPr lang="en-US" sz="1300" dirty="0"/>
                     </a:p>
@@ -24134,8 +24134,8 @@
         </p:nvSpPr>
         <p:spPr>
           <a:xfrm>
-            <a:off x="548640" y="5989320"/>
-            <a:ext cx="11091672" cy="365760"/>
+            <a:off x="548640" y="6126480"/>
+            <a:ext cx="11091672" cy="274320"/>
           </a:xfrm>
           <a:prstGeom prst="rect">
             <a:avLst/>
@@ -24151,14 +24151,14 @@
               <a:buNone/>
             </a:pPr>
             <a:r>
-              <a:rPr lang="en-US" sz="1300" dirty="0">
+              <a:rPr lang="en-US" sz="1200" dirty="0">
                 <a:solidFill>
                   <a:schemeClr val="tx2"/>
                 </a:solidFill>
               </a:rPr>
               <a:t>영업이익은 법인세·감가상각 반영 전 수치이며, 현금흐름표는 포함하지 않았습니다.</a:t>
             </a:r>
-            <a:endParaRPr lang="en-US" sz="1300" dirty="0"/>
+            <a:endParaRPr lang="en-US" sz="1200" dirty="0"/>
           </a:p>
         </p:txBody>
       </p:sp>
@@ -24358,7 +24358,7 @@
                   <a:schemeClr val="tx1"/>
                 </a:solidFill>
               </a:rPr>
-              <a:t>판매 채널: 자사몰 35%(수수료 약 6%), 마켓 35%(약 9%), 크라우드펀딩 20%(약 13%), B2B 10%(30%) → 평균 11%. 요율은 블로그·기사 기준</a:t>
+              <a:t>판매 채널: 자사몰 35%(수수료 약 6%), 마켓 35%(약 9%), 크라우드펀딩 20%(약 13%), B2B 10%(30%) → 평균 11%. 와디즈는 요금제 10~19%(VAT 별도), 나머지는 블로그 기준</a:t>
             </a:r>
             <a:endParaRPr lang="en-US" sz="1300" dirty="0"/>
           </a:p>
@@ -24495,12 +24495,12 @@
           <a:p>
             <a:pPr indent="0" marL="0">
               <a:spcAft>
-                <a:spcPts val="400"/>
+                <a:spcPts val="300"/>
               </a:spcAft>
               <a:buNone/>
             </a:pPr>
             <a:r>
-              <a:rPr lang="en-US" sz="1100" u="sng" dirty="0">
+              <a:rPr lang="en-US" sz="1000" u="sng" dirty="0">
                 <a:solidFill>
                   <a:schemeClr val="tx1"/>
                 </a:solidFill>
@@ -24514,17 +24514,17 @@
               </a:rPr>
               <a:t>Wake-up Machine (Laughing Squid)</a:t>
             </a:r>
-            <a:endParaRPr lang="en-US" sz="1100" dirty="0"/>
+            <a:endParaRPr lang="en-US" sz="1000" dirty="0"/>
           </a:p>
           <a:p>
             <a:pPr indent="0" marL="0">
               <a:spcAft>
-                <a:spcPts val="400"/>
+                <a:spcPts val="300"/>
               </a:spcAft>
               <a:buNone/>
             </a:pPr>
             <a:r>
-              <a:rPr lang="en-US" sz="1100" u="sng" dirty="0">
+              <a:rPr lang="en-US" sz="1000" u="sng" dirty="0">
                 <a:solidFill>
                   <a:schemeClr val="tx1"/>
                 </a:solidFill>
@@ -24538,17 +24538,17 @@
               </a:rPr>
               <a:t>Clocky (Wikipedia)</a:t>
             </a:r>
-            <a:endParaRPr lang="en-US" sz="1100" dirty="0"/>
+            <a:endParaRPr lang="en-US" sz="1000" dirty="0"/>
           </a:p>
           <a:p>
             <a:pPr indent="0" marL="0">
               <a:spcAft>
-                <a:spcPts val="400"/>
+                <a:spcPts val="300"/>
               </a:spcAft>
               <a:buNone/>
             </a:pPr>
             <a:r>
-              <a:rPr lang="en-US" sz="1100" u="sng" dirty="0">
+              <a:rPr lang="en-US" sz="1000" u="sng" dirty="0">
                 <a:solidFill>
                   <a:schemeClr val="tx1"/>
                 </a:solidFill>
@@ -24562,17 +24562,17 @@
               </a:rPr>
               <a:t>Clocky 13만 대 (eGFI)</a:t>
             </a:r>
-            <a:endParaRPr lang="en-US" sz="1100" dirty="0"/>
+            <a:endParaRPr lang="en-US" sz="1000" dirty="0"/>
           </a:p>
           <a:p>
             <a:pPr indent="0" marL="0">
               <a:spcAft>
-                <a:spcPts val="400"/>
+                <a:spcPts val="300"/>
               </a:spcAft>
               <a:buNone/>
             </a:pPr>
             <a:r>
-              <a:rPr lang="en-US" sz="1100" u="sng" dirty="0">
+              <a:rPr lang="en-US" sz="1000" u="sng" dirty="0">
                 <a:solidFill>
                   <a:schemeClr val="tx1"/>
                 </a:solidFill>
@@ -24586,17 +24586,17 @@
               </a:rPr>
               <a:t>Clocky 가격 (New Atlas)</a:t>
             </a:r>
-            <a:endParaRPr lang="en-US" sz="1100" dirty="0"/>
+            <a:endParaRPr lang="en-US" sz="1000" dirty="0"/>
           </a:p>
           <a:p>
             <a:pPr indent="0" marL="0">
               <a:spcAft>
-                <a:spcPts val="400"/>
+                <a:spcPts val="300"/>
               </a:spcAft>
               <a:buNone/>
             </a:pPr>
             <a:r>
-              <a:rPr lang="en-US" sz="1100" u="sng" dirty="0">
+              <a:rPr lang="en-US" sz="1000" u="sng" dirty="0">
                 <a:solidFill>
                   <a:schemeClr val="tx1"/>
                 </a:solidFill>
@@ -24610,17 +24610,17 @@
               </a:rPr>
               <a:t>Sonic Alert 침대 진동기</a:t>
             </a:r>
-            <a:endParaRPr lang="en-US" sz="1100" dirty="0"/>
+            <a:endParaRPr lang="en-US" sz="1000" dirty="0"/>
           </a:p>
           <a:p>
             <a:pPr indent="0" marL="0">
               <a:spcAft>
-                <a:spcPts val="400"/>
+                <a:spcPts val="300"/>
               </a:spcAft>
               <a:buNone/>
             </a:pPr>
             <a:r>
-              <a:rPr lang="en-US" sz="1100" u="sng" dirty="0">
+              <a:rPr lang="en-US" sz="1000" u="sng" dirty="0">
                 <a:solidFill>
                   <a:schemeClr val="tx1"/>
                 </a:solidFill>
@@ -24634,17 +24634,17 @@
               </a:rPr>
               <a:t>Hatch 가격 (asinsight)</a:t>
             </a:r>
-            <a:endParaRPr lang="en-US" sz="1100" dirty="0"/>
+            <a:endParaRPr lang="en-US" sz="1000" dirty="0"/>
           </a:p>
           <a:p>
             <a:pPr indent="0" marL="0">
               <a:spcAft>
-                <a:spcPts val="400"/>
+                <a:spcPts val="300"/>
               </a:spcAft>
               <a:buNone/>
             </a:pPr>
             <a:r>
-              <a:rPr lang="en-US" sz="1100" u="sng" dirty="0">
+              <a:rPr lang="en-US" sz="1000" u="sng" dirty="0">
                 <a:solidFill>
                   <a:schemeClr val="tx1"/>
                 </a:solidFill>
@@ -24656,19 +24656,19 @@
                   </a:extLst>
                 </a:hlinkClick>
               </a:rPr>
-              <a:t>Hatch 매출 추정 (Owler)</a:t>
+              <a:t>Hatch 매출 (Modern Retail)</a:t>
             </a:r>
-            <a:endParaRPr lang="en-US" sz="1100" dirty="0"/>
+            <a:endParaRPr lang="en-US" sz="1000" dirty="0"/>
           </a:p>
           <a:p>
             <a:pPr indent="0" marL="0">
               <a:spcAft>
-                <a:spcPts val="400"/>
+                <a:spcPts val="300"/>
               </a:spcAft>
               <a:buNone/>
             </a:pPr>
             <a:r>
-              <a:rPr lang="en-US" sz="1100" u="sng" dirty="0">
+              <a:rPr lang="en-US" sz="1000" u="sng" dirty="0">
                 <a:solidFill>
                   <a:schemeClr val="tx1"/>
                 </a:solidFill>
@@ -24680,19 +24680,19 @@
                   </a:extLst>
                 </a:hlinkClick>
               </a:rPr>
-              <a:t>ZEEQ 베개 (Gearbrain)</a:t>
+              <a:t>Hatch 매출 (IBTimes)</a:t>
             </a:r>
-            <a:endParaRPr lang="en-US" sz="1100" dirty="0"/>
+            <a:endParaRPr lang="en-US" sz="1000" dirty="0"/>
           </a:p>
           <a:p>
             <a:pPr indent="0" marL="0">
               <a:spcAft>
-                <a:spcPts val="400"/>
+                <a:spcPts val="300"/>
               </a:spcAft>
               <a:buNone/>
             </a:pPr>
             <a:r>
-              <a:rPr lang="en-US" sz="1100" u="sng" dirty="0">
+              <a:rPr lang="en-US" sz="1000" u="sng" dirty="0">
                 <a:solidFill>
                   <a:schemeClr val="tx1"/>
                 </a:solidFill>
@@ -24704,19 +24704,19 @@
                   </a:extLst>
                 </a:hlinkClick>
               </a:rPr>
-              <a:t>Sunrise 베개 (MobileSyrup)</a:t>
+              <a:t>Hatch 판매량 (Fast Company)</a:t>
             </a:r>
-            <a:endParaRPr lang="en-US" sz="1100" dirty="0"/>
+            <a:endParaRPr lang="en-US" sz="1000" dirty="0"/>
           </a:p>
           <a:p>
             <a:pPr indent="0" marL="0">
               <a:spcAft>
-                <a:spcPts val="400"/>
+                <a:spcPts val="300"/>
               </a:spcAft>
               <a:buNone/>
             </a:pPr>
             <a:r>
-              <a:rPr lang="en-US" sz="1100" u="sng" dirty="0">
+              <a:rPr lang="en-US" sz="1000" u="sng" dirty="0">
                 <a:solidFill>
                   <a:schemeClr val="tx1"/>
                 </a:solidFill>
@@ -24728,19 +24728,19 @@
                   </a:extLst>
                 </a:hlinkClick>
               </a:rPr>
-              <a:t>스누즈 연구 (Discover)</a:t>
+              <a:t>ZEEQ 베개 (Gearbrain)</a:t>
             </a:r>
-            <a:endParaRPr lang="en-US" sz="1100" dirty="0"/>
+            <a:endParaRPr lang="en-US" sz="1000" dirty="0"/>
           </a:p>
           <a:p>
             <a:pPr indent="0" marL="0">
               <a:spcAft>
-                <a:spcPts val="400"/>
+                <a:spcPts val="300"/>
               </a:spcAft>
               <a:buNone/>
             </a:pPr>
             <a:r>
-              <a:rPr lang="en-US" sz="1100" u="sng" dirty="0">
+              <a:rPr lang="en-US" sz="1000" u="sng" dirty="0">
                 <a:solidFill>
                   <a:schemeClr val="tx1"/>
                 </a:solidFill>
@@ -24752,41 +24752,19 @@
                   </a:extLst>
                 </a:hlinkClick>
               </a:rPr>
-              <a:t>스마트 클락 시장 (TBRC)</a:t>
+              <a:t>Sunrise 베개 (MobileSyrup)</a:t>
             </a:r>
-            <a:endParaRPr lang="en-US" sz="1100" dirty="0"/>
+            <a:endParaRPr lang="en-US" sz="1000" dirty="0"/>
           </a:p>
-        </p:txBody>
-      </p:sp>
-      <p:sp>
-        <p:nvSpPr>
-          <p:cNvPr id="8" name="출처 목록 2"/>
-          <p:cNvSpPr txBox="1"/>
-          <p:nvPr/>
-        </p:nvSpPr>
-        <p:spPr>
-          <a:xfrm>
-            <a:off x="8321040" y="1828800"/>
-            <a:ext cx="3291840" cy="4389120"/>
-          </a:xfrm>
-          <a:prstGeom prst="rect">
-            <a:avLst/>
-          </a:prstGeom>
-          <a:noFill/>
-          <a:ln/>
-        </p:spPr>
-        <p:txBody>
-          <a:bodyPr wrap="square" lIns="0" tIns="0" rIns="0" bIns="0" rtlCol="0" anchor="t"/>
-          <a:lstStyle/>
           <a:p>
             <a:pPr indent="0" marL="0">
               <a:spcAft>
-                <a:spcPts val="400"/>
+                <a:spcPts val="300"/>
               </a:spcAft>
               <a:buNone/>
             </a:pPr>
             <a:r>
-              <a:rPr lang="en-US" sz="1100" u="sng" dirty="0">
+              <a:rPr lang="en-US" sz="1000" u="sng" dirty="0">
                 <a:solidFill>
                   <a:schemeClr val="tx1"/>
                 </a:solidFill>
@@ -24798,19 +24776,19 @@
                   </a:extLst>
                 </a:hlinkClick>
               </a:rPr>
-              <a:t>스마트 베개 시장 (Technavio)</a:t>
+              <a:t>Ruggie 알람 (Ubergizmo)</a:t>
             </a:r>
-            <a:endParaRPr lang="en-US" sz="1100" dirty="0"/>
+            <a:endParaRPr lang="en-US" sz="1000" dirty="0"/>
           </a:p>
           <a:p>
             <a:pPr indent="0" marL="0">
               <a:spcAft>
-                <a:spcPts val="400"/>
+                <a:spcPts val="300"/>
               </a:spcAft>
               <a:buNone/>
             </a:pPr>
             <a:r>
-              <a:rPr lang="en-US" sz="1100" u="sng" dirty="0">
+              <a:rPr lang="en-US" sz="1000" u="sng" dirty="0">
                 <a:solidFill>
                   <a:schemeClr val="tx1"/>
                 </a:solidFill>
@@ -24822,19 +24800,19 @@
                   </a:extLst>
                 </a:hlinkClick>
               </a:rPr>
-              <a:t>국내 수면 산업 (청년일보)</a:t>
+              <a:t>스누즈 연구 (Discover)</a:t>
             </a:r>
-            <a:endParaRPr lang="en-US" sz="1100" dirty="0"/>
+            <a:endParaRPr lang="en-US" sz="1000" dirty="0"/>
           </a:p>
           <a:p>
             <a:pPr indent="0" marL="0">
               <a:spcAft>
-                <a:spcPts val="400"/>
+                <a:spcPts val="300"/>
               </a:spcAft>
               <a:buNone/>
             </a:pPr>
             <a:r>
-              <a:rPr lang="en-US" sz="1100" u="sng" dirty="0">
+              <a:rPr lang="en-US" sz="1000" u="sng" dirty="0">
                 <a:solidFill>
                   <a:schemeClr val="tx1"/>
                 </a:solidFill>
@@ -24846,19 +24824,19 @@
                   </a:extLst>
                 </a:hlinkClick>
               </a:rPr>
-              <a:t>판매 수수료 비교 (glasswallet)</a:t>
+              <a:t>직장인 지각 설문 (경향신문)</a:t>
             </a:r>
-            <a:endParaRPr lang="en-US" sz="1100" dirty="0"/>
+            <a:endParaRPr lang="en-US" sz="1000" dirty="0"/>
           </a:p>
           <a:p>
             <a:pPr indent="0" marL="0">
               <a:spcAft>
-                <a:spcPts val="400"/>
+                <a:spcPts val="300"/>
               </a:spcAft>
               <a:buNone/>
             </a:pPr>
             <a:r>
-              <a:rPr lang="en-US" sz="1100" u="sng" dirty="0">
+              <a:rPr lang="en-US" sz="1000" u="sng" dirty="0">
                 <a:solidFill>
                   <a:schemeClr val="tx1"/>
                 </a:solidFill>
@@ -24870,19 +24848,19 @@
                   </a:extLst>
                 </a:hlinkClick>
               </a:rPr>
-              <a:t>배터리 KC 인증 (Ufine)</a:t>
+              <a:t>스마트 클락 시장 (TBRC)</a:t>
             </a:r>
-            <a:endParaRPr lang="en-US" sz="1100" dirty="0"/>
+            <a:endParaRPr lang="en-US" sz="1000" dirty="0"/>
           </a:p>
           <a:p>
             <a:pPr indent="0" marL="0">
               <a:spcAft>
-                <a:spcPts val="400"/>
+                <a:spcPts val="300"/>
               </a:spcAft>
               <a:buNone/>
             </a:pPr>
             <a:r>
-              <a:rPr lang="en-US" sz="1100" u="sng" dirty="0">
+              <a:rPr lang="en-US" sz="1000" u="sng" dirty="0">
                 <a:solidFill>
                   <a:schemeClr val="tx1"/>
                 </a:solidFill>
@@ -24894,19 +24872,41 @@
                   </a:extLst>
                 </a:hlinkClick>
               </a:rPr>
-              <a:t>PL 단체보험 (이투데이)</a:t>
+              <a:t>스마트 베개 시장 (Technavio)</a:t>
             </a:r>
-            <a:endParaRPr lang="en-US" sz="1100" dirty="0"/>
+            <a:endParaRPr lang="en-US" sz="1000" dirty="0"/>
           </a:p>
+        </p:txBody>
+      </p:sp>
+      <p:sp>
+        <p:nvSpPr>
+          <p:cNvPr id="8" name="출처 목록 2"/>
+          <p:cNvSpPr txBox="1"/>
+          <p:nvPr/>
+        </p:nvSpPr>
+        <p:spPr>
+          <a:xfrm>
+            <a:off x="8321040" y="1828800"/>
+            <a:ext cx="3291840" cy="4389120"/>
+          </a:xfrm>
+          <a:prstGeom prst="rect">
+            <a:avLst/>
+          </a:prstGeom>
+          <a:noFill/>
+          <a:ln/>
+        </p:spPr>
+        <p:txBody>
+          <a:bodyPr wrap="square" lIns="0" tIns="0" rIns="0" bIns="0" rtlCol="0" anchor="t"/>
+          <a:lstStyle/>
           <a:p>
             <a:pPr indent="0" marL="0">
               <a:spcAft>
-                <a:spcPts val="400"/>
+                <a:spcPts val="300"/>
               </a:spcAft>
               <a:buNone/>
             </a:pPr>
             <a:r>
-              <a:rPr lang="en-US" sz="1100" u="sng" dirty="0">
+              <a:rPr lang="en-US" sz="1000" u="sng" dirty="0">
                 <a:solidFill>
                   <a:schemeClr val="tx1"/>
                 </a:solidFill>
@@ -24918,19 +24918,19 @@
                   </a:extLst>
                 </a:hlinkClick>
               </a:rPr>
-              <a:t>사회공헌백서 2024 (미래한국)</a:t>
+              <a:t>국내 수면 산업 (청년일보)</a:t>
             </a:r>
-            <a:endParaRPr lang="en-US" sz="1100" dirty="0"/>
+            <a:endParaRPr lang="en-US" sz="1000" dirty="0"/>
           </a:p>
           <a:p>
             <a:pPr indent="0" marL="0">
               <a:spcAft>
-                <a:spcPts val="400"/>
+                <a:spcPts val="300"/>
               </a:spcAft>
               <a:buNone/>
             </a:pPr>
             <a:r>
-              <a:rPr lang="en-US" sz="1100" u="sng" dirty="0">
+              <a:rPr lang="en-US" sz="1000" u="sng" dirty="0">
                 <a:solidFill>
                   <a:schemeClr val="tx1"/>
                 </a:solidFill>
@@ -24942,19 +24942,19 @@
                   </a:extLst>
                 </a:hlinkClick>
               </a:rPr>
-              <a:t>한경협 사회공헌 (이투데이)</a:t>
+              <a:t>와디즈 수수료 (도움말 센터)</a:t>
             </a:r>
-            <a:endParaRPr lang="en-US" sz="1100" dirty="0"/>
+            <a:endParaRPr lang="en-US" sz="1000" dirty="0"/>
           </a:p>
           <a:p>
             <a:pPr indent="0" marL="0">
               <a:spcAft>
-                <a:spcPts val="400"/>
+                <a:spcPts val="300"/>
               </a:spcAft>
               <a:buNone/>
             </a:pPr>
             <a:r>
-              <a:rPr lang="en-US" sz="1100" u="sng" dirty="0">
+              <a:rPr lang="en-US" sz="1000" u="sng" dirty="0">
                 <a:solidFill>
                   <a:schemeClr val="tx1"/>
                 </a:solidFill>
@@ -24966,19 +24966,19 @@
                   </a:extLst>
                 </a:hlinkClick>
               </a:rPr>
-              <a:t>전경련 구 조사 (이투데이)</a:t>
+              <a:t>판매 수수료 비교 (glasswallet)</a:t>
             </a:r>
-            <a:endParaRPr lang="en-US" sz="1100" dirty="0"/>
+            <a:endParaRPr lang="en-US" sz="1000" dirty="0"/>
           </a:p>
           <a:p>
             <a:pPr indent="0" marL="0">
               <a:spcAft>
-                <a:spcPts val="400"/>
+                <a:spcPts val="300"/>
               </a:spcAft>
               <a:buNone/>
             </a:pPr>
             <a:r>
-              <a:rPr lang="en-US" sz="1100" u="sng" dirty="0">
+              <a:rPr lang="en-US" sz="1000" u="sng" dirty="0">
                 <a:solidFill>
                   <a:schemeClr val="tx1"/>
                 </a:solidFill>
@@ -24990,19 +24990,19 @@
                   </a:extLst>
                 </a:hlinkClick>
               </a:rPr>
-              <a:t>Patagonia 1% for the Planet</a:t>
+              <a:t>서보 도매가 (Alibaba)</a:t>
             </a:r>
-            <a:endParaRPr lang="en-US" sz="1100" dirty="0"/>
+            <a:endParaRPr lang="en-US" sz="1000" dirty="0"/>
           </a:p>
           <a:p>
             <a:pPr indent="0" marL="0">
               <a:spcAft>
-                <a:spcPts val="400"/>
+                <a:spcPts val="300"/>
               </a:spcAft>
               <a:buNone/>
             </a:pPr>
             <a:r>
-              <a:rPr lang="en-US" sz="1100" u="sng" dirty="0">
+              <a:rPr lang="en-US" sz="1000" u="sng" dirty="0">
                 <a:solidFill>
                   <a:schemeClr val="tx1"/>
                 </a:solidFill>
@@ -25014,9 +25014,225 @@
                   </a:extLst>
                 </a:hlinkClick>
               </a:rPr>
-              <a:t>법인 기부금 한도 (2차 자료)</a:t>
+              <a:t>MCU 모듈 가격 (LCSC)</a:t>
             </a:r>
-            <a:endParaRPr lang="en-US" sz="1100" dirty="0"/>
+            <a:endParaRPr lang="en-US" sz="1000" dirty="0"/>
+          </a:p>
+          <a:p>
+            <a:pPr indent="0" marL="0">
+              <a:spcAft>
+                <a:spcPts val="300"/>
+              </a:spcAft>
+              <a:buNone/>
+            </a:pPr>
+            <a:r>
+              <a:rPr lang="en-US" sz="1000" u="sng" dirty="0">
+                <a:solidFill>
+                  <a:schemeClr val="tx1"/>
+                </a:solidFill>
+                <a:hlinkClick r:id="rId22" invalidUrl="" action="" tgtFrame="" tooltip="" history="1" highlightClick="0" endSnd="0">
+                  <a:extLst>
+                    <a:ext uri="{A12FA001-AC4F-418D-AE19-62706E023703}">
+                      <ahyp:hlinkClr xmlns:ahyp="http://schemas.microsoft.com/office/drawing/2018/hyperlinkcolor" val="tx"/>
+                    </a:ext>
+                  </a:extLst>
+                </a:hlinkClick>
+              </a:rPr>
+              <a:t>배터리 KC 인증 (Ufine)</a:t>
+            </a:r>
+            <a:endParaRPr lang="en-US" sz="1000" dirty="0"/>
+          </a:p>
+          <a:p>
+            <a:pPr indent="0" marL="0">
+              <a:spcAft>
+                <a:spcPts val="300"/>
+              </a:spcAft>
+              <a:buNone/>
+            </a:pPr>
+            <a:r>
+              <a:rPr lang="en-US" sz="1000" u="sng" dirty="0">
+                <a:solidFill>
+                  <a:schemeClr val="tx1"/>
+                </a:solidFill>
+                <a:hlinkClick r:id="rId23" invalidUrl="" action="" tgtFrame="" tooltip="" history="1" highlightClick="0" endSnd="0">
+                  <a:extLst>
+                    <a:ext uri="{A12FA001-AC4F-418D-AE19-62706E023703}">
+                      <ahyp:hlinkClr xmlns:ahyp="http://schemas.microsoft.com/office/drawing/2018/hyperlinkcolor" val="tx"/>
+                    </a:ext>
+                  </a:extLst>
+                </a:hlinkClick>
+              </a:rPr>
+              <a:t>블루투스 KC 시험 (KC전기)</a:t>
+            </a:r>
+            <a:endParaRPr lang="en-US" sz="1000" dirty="0"/>
+          </a:p>
+          <a:p>
+            <a:pPr indent="0" marL="0">
+              <a:spcAft>
+                <a:spcPts val="300"/>
+              </a:spcAft>
+              <a:buNone/>
+            </a:pPr>
+            <a:r>
+              <a:rPr lang="en-US" sz="1000" u="sng" dirty="0">
+                <a:solidFill>
+                  <a:schemeClr val="tx1"/>
+                </a:solidFill>
+                <a:hlinkClick r:id="rId24" invalidUrl="" action="" tgtFrame="" tooltip="" history="1" highlightClick="0" endSnd="0">
+                  <a:extLst>
+                    <a:ext uri="{A12FA001-AC4F-418D-AE19-62706E023703}">
+                      <ahyp:hlinkClr xmlns:ahyp="http://schemas.microsoft.com/office/drawing/2018/hyperlinkcolor" val="tx"/>
+                    </a:ext>
+                  </a:extLst>
+                </a:hlinkClick>
+              </a:rPr>
+              <a:t>PL 단체보험 (이투데이)</a:t>
+            </a:r>
+            <a:endParaRPr lang="en-US" sz="1000" dirty="0"/>
+          </a:p>
+          <a:p>
+            <a:pPr indent="0" marL="0">
+              <a:spcAft>
+                <a:spcPts val="300"/>
+              </a:spcAft>
+              <a:buNone/>
+            </a:pPr>
+            <a:r>
+              <a:rPr lang="en-US" sz="1000" u="sng" dirty="0">
+                <a:solidFill>
+                  <a:schemeClr val="tx1"/>
+                </a:solidFill>
+                <a:hlinkClick r:id="rId25" invalidUrl="" action="" tgtFrame="" tooltip="" history="1" highlightClick="0" endSnd="0">
+                  <a:extLst>
+                    <a:ext uri="{A12FA001-AC4F-418D-AE19-62706E023703}">
+                      <ahyp:hlinkClr xmlns:ahyp="http://schemas.microsoft.com/office/drawing/2018/hyperlinkcolor" val="tx"/>
+                    </a:ext>
+                  </a:extLst>
+                </a:hlinkClick>
+              </a:rPr>
+              <a:t>PL 보험료 지원 2026 (더체크)</a:t>
+            </a:r>
+            <a:endParaRPr lang="en-US" sz="1000" dirty="0"/>
+          </a:p>
+          <a:p>
+            <a:pPr indent="0" marL="0">
+              <a:spcAft>
+                <a:spcPts val="300"/>
+              </a:spcAft>
+              <a:buNone/>
+            </a:pPr>
+            <a:r>
+              <a:rPr lang="en-US" sz="1000" u="sng" dirty="0">
+                <a:solidFill>
+                  <a:schemeClr val="tx1"/>
+                </a:solidFill>
+                <a:hlinkClick r:id="rId26" invalidUrl="" action="" tgtFrame="" tooltip="" history="1" highlightClick="0" endSnd="0">
+                  <a:extLst>
+                    <a:ext uri="{A12FA001-AC4F-418D-AE19-62706E023703}">
+                      <ahyp:hlinkClr xmlns:ahyp="http://schemas.microsoft.com/office/drawing/2018/hyperlinkcolor" val="tx"/>
+                    </a:ext>
+                  </a:extLst>
+                </a:hlinkClick>
+              </a:rPr>
+              <a:t>사회공헌백서 2024 (미래한국)</a:t>
+            </a:r>
+            <a:endParaRPr lang="en-US" sz="1000" dirty="0"/>
+          </a:p>
+          <a:p>
+            <a:pPr indent="0" marL="0">
+              <a:spcAft>
+                <a:spcPts val="300"/>
+              </a:spcAft>
+              <a:buNone/>
+            </a:pPr>
+            <a:r>
+              <a:rPr lang="en-US" sz="1000" u="sng" dirty="0">
+                <a:solidFill>
+                  <a:schemeClr val="tx1"/>
+                </a:solidFill>
+                <a:hlinkClick r:id="rId27" invalidUrl="" action="" tgtFrame="" tooltip="" history="1" highlightClick="0" endSnd="0">
+                  <a:extLst>
+                    <a:ext uri="{A12FA001-AC4F-418D-AE19-62706E023703}">
+                      <ahyp:hlinkClr xmlns:ahyp="http://schemas.microsoft.com/office/drawing/2018/hyperlinkcolor" val="tx"/>
+                    </a:ext>
+                  </a:extLst>
+                </a:hlinkClick>
+              </a:rPr>
+              <a:t>한경협 사회공헌 (이투데이)</a:t>
+            </a:r>
+            <a:endParaRPr lang="en-US" sz="1000" dirty="0"/>
+          </a:p>
+          <a:p>
+            <a:pPr indent="0" marL="0">
+              <a:spcAft>
+                <a:spcPts val="300"/>
+              </a:spcAft>
+              <a:buNone/>
+            </a:pPr>
+            <a:r>
+              <a:rPr lang="en-US" sz="1000" u="sng" dirty="0">
+                <a:solidFill>
+                  <a:schemeClr val="tx1"/>
+                </a:solidFill>
+                <a:hlinkClick r:id="rId28" invalidUrl="" action="" tgtFrame="" tooltip="" history="1" highlightClick="0" endSnd="0">
+                  <a:extLst>
+                    <a:ext uri="{A12FA001-AC4F-418D-AE19-62706E023703}">
+                      <ahyp:hlinkClr xmlns:ahyp="http://schemas.microsoft.com/office/drawing/2018/hyperlinkcolor" val="tx"/>
+                    </a:ext>
+                  </a:extLst>
+                </a:hlinkClick>
+              </a:rPr>
+              <a:t>전경련 구 조사 (이투데이)</a:t>
+            </a:r>
+            <a:endParaRPr lang="en-US" sz="1000" dirty="0"/>
+          </a:p>
+          <a:p>
+            <a:pPr indent="0" marL="0">
+              <a:spcAft>
+                <a:spcPts val="300"/>
+              </a:spcAft>
+              <a:buNone/>
+            </a:pPr>
+            <a:r>
+              <a:rPr lang="en-US" sz="1000" u="sng" dirty="0">
+                <a:solidFill>
+                  <a:schemeClr val="tx1"/>
+                </a:solidFill>
+                <a:hlinkClick r:id="rId29" invalidUrl="" action="" tgtFrame="" tooltip="" history="1" highlightClick="0" endSnd="0">
+                  <a:extLst>
+                    <a:ext uri="{A12FA001-AC4F-418D-AE19-62706E023703}">
+                      <ahyp:hlinkClr xmlns:ahyp="http://schemas.microsoft.com/office/drawing/2018/hyperlinkcolor" val="tx"/>
+                    </a:ext>
+                  </a:extLst>
+                </a:hlinkClick>
+              </a:rPr>
+              <a:t>Patagonia 1% for the Planet</a:t>
+            </a:r>
+            <a:endParaRPr lang="en-US" sz="1000" dirty="0"/>
+          </a:p>
+          <a:p>
+            <a:pPr indent="0" marL="0">
+              <a:spcAft>
+                <a:spcPts val="300"/>
+              </a:spcAft>
+              <a:buNone/>
+            </a:pPr>
+            <a:r>
+              <a:rPr lang="en-US" sz="1000" u="sng" dirty="0">
+                <a:solidFill>
+                  <a:schemeClr val="tx1"/>
+                </a:solidFill>
+                <a:hlinkClick r:id="rId30" invalidUrl="" action="" tgtFrame="" tooltip="" history="1" highlightClick="0" endSnd="0">
+                  <a:extLst>
+                    <a:ext uri="{A12FA001-AC4F-418D-AE19-62706E023703}">
+                      <ahyp:hlinkClr xmlns:ahyp="http://schemas.microsoft.com/office/drawing/2018/hyperlinkcolor" val="tx"/>
+                    </a:ext>
+                  </a:extLst>
+                </a:hlinkClick>
+              </a:rPr>
+              <a:t>기부금 세제 (찾기쉬운 생활법령)</a:t>
+            </a:r>
+            <a:endParaRPr lang="en-US" sz="1000" dirty="0"/>
           </a:p>
         </p:txBody>
       </p:sp>
@@ -26313,11 +26529,11 @@
         <p:spPr>
           <a:xfrm>
             <a:off x="548640" y="1463040"/>
-            <a:ext cx="3520440" cy="4206240"/>
+            <a:ext cx="2651760" cy="4389120"/>
           </a:xfrm>
           <a:prstGeom prst="roundRect">
             <a:avLst>
-              <a:gd name="adj" fmla="val 3117"/>
+              <a:gd name="adj" fmla="val 4138"/>
             </a:avLst>
           </a:prstGeom>
           <a:solidFill>
@@ -26339,8 +26555,8 @@
         </p:nvSpPr>
         <p:spPr>
           <a:xfrm>
-            <a:off x="868680" y="1783080"/>
-            <a:ext cx="640080" cy="640080"/>
+            <a:off x="822960" y="1737360"/>
+            <a:ext cx="594360" cy="594360"/>
           </a:xfrm>
           <a:prstGeom prst="ellipse">
             <a:avLst/>
@@ -26372,8 +26588,8 @@
         </p:blipFill>
         <p:spPr>
           <a:xfrm>
-            <a:off x="1028700" y="1943100"/>
-            <a:ext cx="320040" cy="320040"/>
+            <a:off x="971550" y="1885950"/>
+            <a:ext cx="297180" cy="297180"/>
           </a:xfrm>
           <a:prstGeom prst="rect">
             <a:avLst/>
@@ -26388,8 +26604,8 @@
         </p:nvSpPr>
         <p:spPr>
           <a:xfrm>
-            <a:off x="868680" y="2697480"/>
-            <a:ext cx="2926080" cy="914400"/>
+            <a:off x="822960" y="2514600"/>
+            <a:ext cx="2194560" cy="822960"/>
           </a:xfrm>
           <a:prstGeom prst="rect">
             <a:avLst/>
@@ -26405,14 +26621,14 @@
               <a:buNone/>
             </a:pPr>
             <a:r>
-              <a:rPr lang="en-US" sz="4800" b="1" dirty="0">
+              <a:rPr lang="en-US" sz="4000" b="1" dirty="0">
                 <a:solidFill>
                   <a:schemeClr val="tx1"/>
                 </a:solidFill>
               </a:rPr>
               <a:t>69%</a:t>
             </a:r>
-            <a:endParaRPr lang="en-US" sz="4800" dirty="0"/>
+            <a:endParaRPr lang="en-US" sz="4000" dirty="0"/>
           </a:p>
         </p:txBody>
       </p:sp>
@@ -26424,8 +26640,8 @@
         </p:nvSpPr>
         <p:spPr>
           <a:xfrm>
-            <a:off x="868680" y="3703320"/>
-            <a:ext cx="2926080" cy="548640"/>
+            <a:off x="822960" y="3429000"/>
+            <a:ext cx="2194560" cy="640080"/>
           </a:xfrm>
           <a:prstGeom prst="rect">
             <a:avLst/>
@@ -26441,14 +26657,14 @@
               <a:buNone/>
             </a:pPr>
             <a:r>
-              <a:rPr lang="en-US" sz="1500" b="1" dirty="0">
+              <a:rPr lang="en-US" sz="1400" b="1" dirty="0">
                 <a:solidFill>
                   <a:schemeClr val="tx1"/>
                 </a:solidFill>
               </a:rPr>
               <a:t>스웨덴 스톡홀름대 설문(1,732명)</a:t>
             </a:r>
-            <a:endParaRPr lang="en-US" sz="1500" dirty="0"/>
+            <a:endParaRPr lang="en-US" sz="1400" dirty="0"/>
           </a:p>
         </p:txBody>
       </p:sp>
@@ -26460,8 +26676,8 @@
         </p:nvSpPr>
         <p:spPr>
           <a:xfrm>
-            <a:off x="868680" y="4343400"/>
-            <a:ext cx="2926080" cy="1188720"/>
+            <a:off x="822960" y="4160520"/>
+            <a:ext cx="2194560" cy="1554480"/>
           </a:xfrm>
           <a:prstGeom prst="rect">
             <a:avLst/>
@@ -26477,14 +26693,14 @@
               <a:buNone/>
             </a:pPr>
             <a:r>
-              <a:rPr lang="en-US" sz="1400" dirty="0">
+              <a:rPr lang="en-US" sz="1300" dirty="0">
                 <a:solidFill>
                   <a:schemeClr val="tx2"/>
                 </a:solidFill>
               </a:rPr>
               <a:t>습관적으로 스누즈를 쓰거나 알람을 여러 개 맞춘다고 답했고, 평균 22분을 미뤘습니다.</a:t>
             </a:r>
-            <a:endParaRPr lang="en-US" sz="1400" dirty="0"/>
+            <a:endParaRPr lang="en-US" sz="1300" dirty="0"/>
           </a:p>
         </p:txBody>
       </p:sp>
@@ -26496,12 +26712,12 @@
         </p:nvSpPr>
         <p:spPr>
           <a:xfrm>
-            <a:off x="4334256" y="1463040"/>
-            <a:ext cx="3520440" cy="4206240"/>
+            <a:off x="3362249" y="1463040"/>
+            <a:ext cx="2651760" cy="4389120"/>
           </a:xfrm>
           <a:prstGeom prst="roundRect">
             <a:avLst>
-              <a:gd name="adj" fmla="val 3117"/>
+              <a:gd name="adj" fmla="val 4138"/>
             </a:avLst>
           </a:prstGeom>
           <a:solidFill>
@@ -26523,8 +26739,8 @@
         </p:nvSpPr>
         <p:spPr>
           <a:xfrm>
-            <a:off x="4654296" y="1783080"/>
-            <a:ext cx="640080" cy="640080"/>
+            <a:off x="3636569" y="1737360"/>
+            <a:ext cx="594360" cy="594360"/>
           </a:xfrm>
           <a:prstGeom prst="ellipse">
             <a:avLst/>
@@ -26556,8 +26772,8 @@
         </p:blipFill>
         <p:spPr>
           <a:xfrm>
-            <a:off x="4814316" y="1943100"/>
-            <a:ext cx="320040" cy="320040"/>
+            <a:off x="3785159" y="1885950"/>
+            <a:ext cx="297180" cy="297180"/>
           </a:xfrm>
           <a:prstGeom prst="rect">
             <a:avLst/>
@@ -26572,8 +26788,8 @@
         </p:nvSpPr>
         <p:spPr>
           <a:xfrm>
-            <a:off x="4654296" y="2697480"/>
-            <a:ext cx="2926080" cy="914400"/>
+            <a:off x="3636569" y="2514600"/>
+            <a:ext cx="2194560" cy="822960"/>
           </a:xfrm>
           <a:prstGeom prst="rect">
             <a:avLst/>
@@ -26589,14 +26805,14 @@
               <a:buNone/>
             </a:pPr>
             <a:r>
-              <a:rPr lang="en-US" sz="4800" b="1" dirty="0">
+              <a:rPr lang="en-US" sz="4000" b="1" dirty="0">
                 <a:solidFill>
                   <a:schemeClr val="tx1"/>
                 </a:solidFill>
               </a:rPr>
               <a:t>55.7%</a:t>
             </a:r>
-            <a:endParaRPr lang="en-US" sz="4800" dirty="0"/>
+            <a:endParaRPr lang="en-US" sz="4000" dirty="0"/>
           </a:p>
         </p:txBody>
       </p:sp>
@@ -26608,8 +26824,8 @@
         </p:nvSpPr>
         <p:spPr>
           <a:xfrm>
-            <a:off x="4654296" y="3703320"/>
-            <a:ext cx="2926080" cy="548640"/>
+            <a:off x="3636569" y="3429000"/>
+            <a:ext cx="2194560" cy="640080"/>
           </a:xfrm>
           <a:prstGeom prst="rect">
             <a:avLst/>
@@ -26625,14 +26841,14 @@
               <a:buNone/>
             </a:pPr>
             <a:r>
-              <a:rPr lang="en-US" sz="1500" b="1" dirty="0">
+              <a:rPr lang="en-US" sz="1400" b="1" dirty="0">
                 <a:solidFill>
                   <a:schemeClr val="tx1"/>
                 </a:solidFill>
               </a:rPr>
-              <a:t>미국 수면 앱 데이터(약 2.1만 명)</a:t>
+              <a:t>미국 수면 앱(약 2.1만 명)</a:t>
             </a:r>
-            <a:endParaRPr lang="en-US" sz="1500" dirty="0"/>
+            <a:endParaRPr lang="en-US" sz="1400" dirty="0"/>
           </a:p>
         </p:txBody>
       </p:sp>
@@ -26644,8 +26860,8 @@
         </p:nvSpPr>
         <p:spPr>
           <a:xfrm>
-            <a:off x="4654296" y="4343400"/>
-            <a:ext cx="2926080" cy="1188720"/>
+            <a:off x="3636569" y="4160520"/>
+            <a:ext cx="2194560" cy="1554480"/>
           </a:xfrm>
           <a:prstGeom prst="rect">
             <a:avLst/>
@@ -26661,31 +26877,215 @@
               <a:buNone/>
             </a:pPr>
             <a:r>
-              <a:rPr lang="en-US" sz="1400" dirty="0">
+              <a:rPr lang="en-US" sz="1300" dirty="0">
                 <a:solidFill>
                   <a:schemeClr val="tx2"/>
                 </a:solidFill>
               </a:rPr>
               <a:t>알람을 쓴 300만 일 밤 중 절반 이상에서 스누즈를 눌렀고, 평균 10.8분을 미뤘습니다.</a:t>
             </a:r>
+            <a:endParaRPr lang="en-US" sz="1300" dirty="0"/>
+          </a:p>
+        </p:txBody>
+      </p:sp>
+      <p:sp>
+        <p:nvSpPr>
+          <p:cNvPr id="16" name="근거 카드 3"/>
+          <p:cNvSpPr/>
+          <p:nvPr/>
+        </p:nvSpPr>
+        <p:spPr>
+          <a:xfrm>
+            <a:off x="6175858" y="1463040"/>
+            <a:ext cx="2651760" cy="4389120"/>
+          </a:xfrm>
+          <a:prstGeom prst="roundRect">
+            <a:avLst>
+              <a:gd name="adj" fmla="val 4138"/>
+            </a:avLst>
+          </a:prstGeom>
+          <a:solidFill>
+            <a:schemeClr val="bg2"/>
+          </a:solidFill>
+          <a:ln w="6350">
+            <a:solidFill>
+              <a:schemeClr val="bg2"/>
+            </a:solidFill>
+            <a:prstDash val="solid"/>
+          </a:ln>
+        </p:spPr>
+      </p:sp>
+      <p:sp>
+        <p:nvSpPr>
+          <p:cNvPr id="17" name="근거 3 원"/>
+          <p:cNvSpPr/>
+          <p:nvPr/>
+        </p:nvSpPr>
+        <p:spPr>
+          <a:xfrm>
+            <a:off x="6450178" y="1737360"/>
+            <a:ext cx="594360" cy="594360"/>
+          </a:xfrm>
+          <a:prstGeom prst="ellipse">
+            <a:avLst/>
+          </a:prstGeom>
+          <a:solidFill>
+            <a:srgbClr val="5B6ABF"/>
+          </a:solidFill>
+          <a:ln w="6350">
+            <a:solidFill>
+              <a:srgbClr val="5B6ABF"/>
+            </a:solidFill>
+            <a:prstDash val="solid"/>
+          </a:ln>
+        </p:spPr>
+      </p:sp>
+      <p:pic>
+        <p:nvPicPr>
+          <p:cNvPr id="18" name="근거 3 아이콘" descr="근거 3">    </p:cNvPr>
+          <p:cNvPicPr>
+            <a:picLocks noChangeAspect="1"/>
+          </p:cNvPicPr>
+          <p:nvPr/>
+        </p:nvPicPr>
+        <p:blipFill>
+          <a:blip r:embed="rId3"/>
+          <a:stretch>
+            <a:fillRect/>
+          </a:stretch>
+        </p:blipFill>
+        <p:spPr>
+          <a:xfrm>
+            <a:off x="6598768" y="1885950"/>
+            <a:ext cx="297180" cy="297180"/>
+          </a:xfrm>
+          <a:prstGeom prst="rect">
+            <a:avLst/>
+          </a:prstGeom>
+        </p:spPr>
+      </p:pic>
+      <p:sp>
+        <p:nvSpPr>
+          <p:cNvPr id="19" name="근거 숫자 3"/>
+          <p:cNvSpPr txBox="1"/>
+          <p:nvPr/>
+        </p:nvSpPr>
+        <p:spPr>
+          <a:xfrm>
+            <a:off x="6450178" y="2514600"/>
+            <a:ext cx="2194560" cy="822960"/>
+          </a:xfrm>
+          <a:prstGeom prst="rect">
+            <a:avLst/>
+          </a:prstGeom>
+          <a:noFill/>
+          <a:ln/>
+        </p:spPr>
+        <p:txBody>
+          <a:bodyPr wrap="square" lIns="0" tIns="0" rIns="0" bIns="0" rtlCol="0" anchor="ctr"/>
+          <a:lstStyle/>
+          <a:p>
+            <a:pPr indent="0" marL="0">
+              <a:buNone/>
+            </a:pPr>
+            <a:r>
+              <a:rPr lang="en-US" sz="4000" b="1" dirty="0">
+                <a:solidFill>
+                  <a:schemeClr val="tx1"/>
+                </a:solidFill>
+              </a:rPr>
+              <a:t>32.1%</a:t>
+            </a:r>
+            <a:endParaRPr lang="en-US" sz="4000" dirty="0"/>
+          </a:p>
+        </p:txBody>
+      </p:sp>
+      <p:sp>
+        <p:nvSpPr>
+          <p:cNvPr id="20" name="근거 출처 3"/>
+          <p:cNvSpPr txBox="1"/>
+          <p:nvPr/>
+        </p:nvSpPr>
+        <p:spPr>
+          <a:xfrm>
+            <a:off x="6450178" y="3429000"/>
+            <a:ext cx="2194560" cy="640080"/>
+          </a:xfrm>
+          <a:prstGeom prst="rect">
+            <a:avLst/>
+          </a:prstGeom>
+          <a:noFill/>
+          <a:ln/>
+        </p:spPr>
+        <p:txBody>
+          <a:bodyPr wrap="square" lIns="0" tIns="0" rIns="0" bIns="0" rtlCol="0" anchor="t"/>
+          <a:lstStyle/>
+          <a:p>
+            <a:pPr indent="0" marL="0">
+              <a:buNone/>
+            </a:pPr>
+            <a:r>
+              <a:rPr lang="en-US" sz="1400" b="1" dirty="0">
+                <a:solidFill>
+                  <a:schemeClr val="tx1"/>
+                </a:solidFill>
+              </a:rPr>
+              <a:t>인크루트 직장인 설문(2011, 310명)</a:t>
+            </a:r>
             <a:endParaRPr lang="en-US" sz="1400" dirty="0"/>
           </a:p>
         </p:txBody>
       </p:sp>
       <p:sp>
         <p:nvSpPr>
-          <p:cNvPr id="16" name="근거 주의 카드"/>
+          <p:cNvPr id="21" name="근거 설명 3"/>
+          <p:cNvSpPr txBox="1"/>
+          <p:nvPr/>
+        </p:nvSpPr>
+        <p:spPr>
+          <a:xfrm>
+            <a:off x="6450178" y="4160520"/>
+            <a:ext cx="2194560" cy="1554480"/>
+          </a:xfrm>
+          <a:prstGeom prst="rect">
+            <a:avLst/>
+          </a:prstGeom>
+          <a:noFill/>
+          <a:ln/>
+        </p:spPr>
+        <p:txBody>
+          <a:bodyPr wrap="square" lIns="0" tIns="0" rIns="0" bIns="0" rtlCol="0" anchor="t"/>
+          <a:lstStyle/>
+          <a:p>
+            <a:pPr indent="0" marL="0">
+              <a:buNone/>
+            </a:pPr>
+            <a:r>
+              <a:rPr lang="en-US" sz="1300" dirty="0">
+                <a:solidFill>
+                  <a:schemeClr val="tx2"/>
+                </a:solidFill>
+              </a:rPr>
+              <a:t>지각 이유 1위가 늦잠입니다. 35.2%가 자주 지각하고 38.5%가 인사평가 불이익을 겪었습니다.</a:t>
+            </a:r>
+            <a:endParaRPr lang="en-US" sz="1300" dirty="0"/>
+          </a:p>
+        </p:txBody>
+      </p:sp>
+      <p:sp>
+        <p:nvSpPr>
+          <p:cNvPr id="22" name="근거 주의 카드"/>
           <p:cNvSpPr/>
           <p:nvPr/>
         </p:nvSpPr>
         <p:spPr>
           <a:xfrm>
-            <a:off x="8119872" y="1463040"/>
-            <a:ext cx="3520440" cy="4206240"/>
+            <a:off x="8988552" y="1463040"/>
+            <a:ext cx="2651760" cy="4389120"/>
           </a:xfrm>
           <a:prstGeom prst="roundRect">
             <a:avLst>
-              <a:gd name="adj" fmla="val 3117"/>
+              <a:gd name="adj" fmla="val 4138"/>
             </a:avLst>
           </a:prstGeom>
           <a:solidFill>
@@ -26701,14 +27101,14 @@
       </p:sp>
       <p:sp>
         <p:nvSpPr>
-          <p:cNvPr id="17" name="주의 제목"/>
+          <p:cNvPr id="23" name="주의 제목"/>
           <p:cNvSpPr txBox="1"/>
           <p:nvPr/>
         </p:nvSpPr>
         <p:spPr>
           <a:xfrm>
-            <a:off x="8439912" y="1783080"/>
-            <a:ext cx="2926080" cy="457200"/>
+            <a:off x="9262872" y="1783080"/>
+            <a:ext cx="2194560" cy="457200"/>
           </a:xfrm>
           <a:prstGeom prst="rect">
             <a:avLst/>
@@ -26737,14 +27137,14 @@
       </p:sp>
       <p:sp>
         <p:nvSpPr>
-          <p:cNvPr id="18" name="주의 내용"/>
+          <p:cNvPr id="24" name="주의 내용"/>
           <p:cNvSpPr txBox="1"/>
           <p:nvPr/>
         </p:nvSpPr>
         <p:spPr>
           <a:xfrm>
-            <a:off x="8439912" y="2377440"/>
-            <a:ext cx="2926080" cy="3108960"/>
+            <a:off x="9262872" y="2377440"/>
+            <a:ext cx="2194560" cy="3383280"/>
           </a:xfrm>
           <a:prstGeom prst="rect">
             <a:avLst/>
@@ -26760,34 +27160,34 @@
               <a:buNone/>
             </a:pPr>
             <a:r>
-              <a:rPr lang="en-US" sz="1400" dirty="0">
+              <a:rPr lang="en-US" sz="1300" dirty="0">
                 <a:solidFill>
                   <a:schemeClr val="bg1"/>
                 </a:solidFill>
               </a:rPr>
-              <a:t>두 연구 모두 스누즈가 수면에 크게 해롭다는 증거는 약했습니다. 우리 제품의 가치는 건강 개선이 아니라 정시 기상과 지각 방지입니다.</a:t>
+              <a:t>해외 두 연구는 스누즈가 수면에 크게 해롭다는 증거가 약했습니다. 우리 제품의 가치는 건강 개선이 아니라 정시 기상과 지각 방지입니다.</a:t>
             </a:r>
-            <a:endParaRPr lang="en-US" sz="1400" dirty="0"/>
+            <a:endParaRPr lang="en-US" sz="1300" dirty="0"/>
           </a:p>
           <a:p>
             <a:pPr indent="0" marL="0">
               <a:buNone/>
             </a:pPr>
-            <a:endParaRPr lang="en-US" sz="1400" dirty="0"/>
+            <a:endParaRPr lang="en-US" sz="1300" dirty="0"/>
           </a:p>
           <a:p>
             <a:pPr indent="0" marL="0">
               <a:buNone/>
             </a:pPr>
             <a:r>
-              <a:rPr lang="en-US" sz="1400" dirty="0">
+              <a:rPr lang="en-US" sz="1300" dirty="0">
                 <a:solidFill>
                   <a:schemeClr val="bg1"/>
                 </a:solidFill>
               </a:rPr>
-              <a:t>한국 직장인 대상 설문은 찾지 못해 직접 조사가 필요합니다.</a:t>
+              <a:t>한국 자료는 오래되고 표본이 작아 최신 설문을 직접 해야 합니다.</a:t>
             </a:r>
-            <a:endParaRPr lang="en-US" sz="1400" dirty="0"/>
+            <a:endParaRPr lang="en-US" sz="1300" dirty="0"/>
           </a:p>
         </p:txBody>
       </p:sp>
@@ -28047,7 +28447,7 @@
                             <a:schemeClr val="tx1"/>
                           </a:solidFill>
                         </a:rPr>
-                        <a:t>회사 연 매출 $5~7M 추정(제3자, 비공개)</a:t>
+                        <a:t>회사 연 매출 약 $140~200M(언론 보도), 누적 50만 대 이상</a:t>
                       </a:r>
                       <a:endParaRPr lang="en-US" sz="1300" dirty="0"/>
                     </a:p>
@@ -28826,14 +29226,14 @@
               <a:buNone/>
             </a:pPr>
             <a:r>
-              <a:rPr lang="en-US" sz="1500" b="1" dirty="0">
+              <a:rPr lang="en-US" sz="1400" b="1" dirty="0">
                 <a:solidFill>
                   <a:schemeClr val="tx1"/>
                 </a:solidFill>
               </a:rPr>
-              <a:t>“베개에서 손이 나오는” 동일 상용 제품은 확인되지 않았습니다. 다만 센서형 스마트 베개가 이미 있어, 차별점을 ‘물리적 터치’로 증명하는 것이 핵심입니다. 유사 특허 조사도 필요합니다.</a:t>
+              <a:t>동일 상용 제품은 확인되지 않았습니다. ZEEQ(약 $24만)와 Ruggie(약 $22만)가 Kickstarter 목표를 크게 넘겨 기상 제품 수요는 있었지만, 센서형 베개와의 차별점을 ‘물리적 터치’로 증명해야 합니다. 특허 조사도 필요합니다.</a:t>
             </a:r>
-            <a:endParaRPr lang="en-US" sz="1500" dirty="0"/>
+            <a:endParaRPr lang="en-US" sz="1400" dirty="0"/>
           </a:p>
         </p:txBody>
       </p:sp>
@@ -29527,7 +29927,7 @@
                   <a:schemeClr val="tx2"/>
                 </a:solidFill>
               </a:rPr>
-              <a:t>시장조사 업체의 전망치는 정의와 기준 연도가 달라 서로 비교할 수 없으며, 성장률이 부풀려져 있을 수 있습니다.</a:t>
+              <a:t>시장조사 업체의 전망치는 정의와 기준 연도가 달라 서로 비교할 수 없습니다. 국내 베개 시장 규모 자료는 찾지 못했고, 세계 일반 베개 평균가는 약 $11.3입니다(Technavio, 2024).</a:t>
             </a:r>
             <a:endParaRPr lang="en-US" sz="1300" dirty="0"/>
           </a:p>
@@ -29893,7 +30293,7 @@
                   <a:schemeClr val="tx1"/>
                 </a:solidFill>
               </a:rPr>
-              <a:t>$5M ~ $7M</a:t>
+              <a:t>$140M ~ $200M</a:t>
             </a:r>
             <a:endParaRPr lang="en-US" sz="2600" dirty="0"/>
           </a:p>
@@ -29929,7 +30329,7 @@
                   <a:schemeClr val="tx2"/>
                 </a:solidFill>
               </a:rPr>
-              <a:t>약 70억~98억원. 비공개 기업의 제3자 추정치이며 여러 제품을 합친 회사 전체 매출입니다.</a:t>
+              <a:t>약 1,960억~2,800억원. 2023년 약 $140M(Modern Retail), 이후 연 $200M(Inc 계열 보도). 비공개 기업의 회사 전체 매출입니다.</a:t>
             </a:r>
             <a:endParaRPr lang="en-US" sz="1400" dirty="0"/>
           </a:p>
@@ -29965,7 +30365,7 @@
                   <a:schemeClr val="tx2"/>
                 </a:solidFill>
               </a:rPr>
-              <a:t>Sonic Alert는 판매량이 공개되지 않아 매출을 추정하지 않았습니다. 환율 1,400원/$ 가정.</a:t>
+              <a:t>Hatch는 회사 전체(아기 제품 포함) 매출이며 비공개 기업입니다. Sonic Alert는 판매량 비공개로 제외. 환율 1,400원/$ 가정.</a:t>
             </a:r>
             <a:endParaRPr lang="en-US" sz="1200" dirty="0"/>
           </a:p>
@@ -30267,7 +30667,7 @@
                             <a:schemeClr val="bg1"/>
                           </a:solidFill>
                         </a:rPr>
-                        <a:t>Hatch형 ($6.0M)</a:t>
+                        <a:t>Hatch형 ($140M)</a:t>
                       </a:r>
                       <a:endParaRPr lang="en-US" sz="1300" dirty="0"/>
                     </a:p>
@@ -30452,7 +30852,7 @@
                             <a:schemeClr val="tx1"/>
                           </a:solidFill>
                         </a:rPr>
-                        <a:t>22% · $1.32M</a:t>
+                        <a:t>22% · $30.80M</a:t>
                       </a:r>
                       <a:endParaRPr lang="en-US" sz="1300" dirty="0"/>
                     </a:p>
@@ -30637,7 +31037,7 @@
                             <a:schemeClr val="tx1"/>
                           </a:solidFill>
                         </a:rPr>
-                        <a:t>4% · $0.24M</a:t>
+                        <a:t>4% · $5.60M</a:t>
                       </a:r>
                       <a:endParaRPr lang="en-US" sz="1300" dirty="0"/>
                     </a:p>
@@ -30822,7 +31222,7 @@
                             <a:schemeClr val="tx1"/>
                           </a:solidFill>
                         </a:rPr>
-                        <a:t>5% · $0.30M</a:t>
+                        <a:t>5% · $7.00M</a:t>
                       </a:r>
                       <a:endParaRPr lang="en-US" sz="1300" dirty="0"/>
                     </a:p>
@@ -31007,7 +31407,7 @@
                             <a:schemeClr val="tx1"/>
                           </a:solidFill>
                         </a:rPr>
-                        <a:t>15% · $0.90M</a:t>
+                        <a:t>15% · $21.00M</a:t>
                       </a:r>
                       <a:endParaRPr lang="en-US" sz="1300" dirty="0"/>
                     </a:p>
@@ -31192,7 +31592,7 @@
                             <a:schemeClr val="tx1"/>
                           </a:solidFill>
                         </a:rPr>
-                        <a:t>20% · $1.20M</a:t>
+                        <a:t>20% · $28.00M</a:t>
                       </a:r>
                       <a:endParaRPr lang="en-US" sz="1300" dirty="0"/>
                     </a:p>
@@ -31377,7 +31777,7 @@
                             <a:schemeClr val="tx1"/>
                           </a:solidFill>
                         </a:rPr>
-                        <a:t>24% · $1.44M</a:t>
+                        <a:t>24% · $33.60M</a:t>
                       </a:r>
                       <a:endParaRPr lang="en-US" sz="1300" dirty="0"/>
                     </a:p>
@@ -31562,7 +31962,7 @@
                             <a:schemeClr val="tx1"/>
                           </a:solidFill>
                         </a:rPr>
-                        <a:t>10% · $0.60M</a:t>
+                        <a:t>10% · $14.00M</a:t>
                       </a:r>
                       <a:endParaRPr lang="en-US" sz="1300" dirty="0"/>
                     </a:p>

</xml_diff>

<commit_message>
Incorporate verified fee/tax/CSR data, remove unverified claims, self-review fixes
Co-Authored-By: Claude Sonnet 5.5 <noreply@anthropic.com>
Claude-Session: https://claude.ai/code/session_01C8esidZTnz37pFUEU5sMqP
</commit_message>
<xml_diff>
--- a/MorningHands_Business_Analysis.pptx
+++ b/MorningHands_Business_Analysis.pptx
@@ -131,17 +131,17 @@
   <p:extLst>
     <p:ext uri="{521415D9-36F7-43E2-AB2F-B90AF26B5E84}">
       <p14:sectionLst xmlns:p14="http://schemas.microsoft.com/office/powerpoint/2010/main">
-        <p14:section name="표지" id="{3746e082-9236-9806-9443-b107a929734c}">
+        <p14:section name="표지" id="{ff7f5edb-ba6d-a4aa-b5ae-652473b475aa}">
           <p14:sldIdLst>
             <p14:sldId id="256"/>
           </p14:sldIdLst>
         </p14:section>
-        <p14:section name="요약" id="{f5e262ba-c6bf-bb13-0bc1-ea8174ddd901}">
+        <p14:section name="요약" id="{b78b4365-d07e-d855-393e-12999f01cdfe}">
           <p14:sldIdLst>
             <p14:sldId id="257"/>
           </p14:sldIdLst>
         </p14:section>
-        <p14:section name="1부 경쟁 제품 조사" id="{e704d059-0808-7948-08dd-de1d110f5329}">
+        <p14:section name="1부 경쟁 제품 조사" id="{f8476676-d0fd-8141-00ed-49d5bc4390d4}">
           <p14:sldIdLst>
             <p14:sldId id="258"/>
             <p14:sldId id="259"/>
@@ -153,7 +153,7 @@
             <p14:sldId id="265"/>
           </p14:sldIdLst>
         </p14:section>
-        <p14:section name="2부 우리 제품 매출 예상" id="{a85a1c1e-4743-6586-768f-4c366ffce62a}">
+        <p14:section name="2부 우리 제품 매출 예상" id="{da9a3c03-5869-9e91-a957-d65082413ac7}">
           <p14:sldIdLst>
             <p14:sldId id="266"/>
             <p14:sldId id="267"/>
@@ -164,7 +164,7 @@
             <p14:sldId id="272"/>
           </p14:sldIdLst>
         </p14:section>
-        <p14:section name="3부 사회 환원" id="{303d256d-9e78-b2d4-4430-35735cab2bbc}">
+        <p14:section name="3부 사회 환원" id="{6e2cdf35-b971-df0a-376f-21beac11c4b2}">
           <p14:sldIdLst>
             <p14:sldId id="273"/>
             <p14:sldId id="274"/>
@@ -172,12 +172,12 @@
             <p14:sldId id="276"/>
           </p14:sldIdLst>
         </p14:section>
-        <p14:section name="리스크" id="{bc8ca375-4530-3386-4136-fd162cea2cf5}">
+        <p14:section name="리스크" id="{d39cd6af-b8a9-6abb-add1-57bc1cc753a7}">
           <p14:sldIdLst>
             <p14:sldId id="277"/>
           </p14:sldIdLst>
         </p14:section>
-        <p14:section name="실행 계획" id="{ff57e0ef-b494-2101-b54a-0925a04e308e}">
+        <p14:section name="실행 계획" id="{07da6449-6785-19aa-9e92-ee7889c3cc48}">
           <p14:sldIdLst>
             <p14:sldId id="278"/>
             <p14:sldId id="279"/>
@@ -1468,7 +1468,7 @@
           <a:p>
             <a:r>
               <a:rPr lang="en-US" dirty="0"/>
-              <a:t>국내 대기업은 매출의 약 0.1~0.2%를 사회공헌에 씁니다(조사별 상이). Patagonia는 1985년부터 매출의 1%를 냅니다.</a:t>
+              <a:t>국내 100대 기업은 매출의 약 0.12%를 사회공헌에 씁니다(2023년, 90개사 공개 기준). Patagonia는 1985년부터 매출의 1%를 냅니다.</a:t>
             </a:r>
             <a:endParaRPr lang="en-US" dirty="0"/>
           </a:p>
@@ -1732,7 +1732,7 @@
           <a:p>
             <a:r>
               <a:rPr lang="en-US" dirty="0"/>
-              <a:t>현물은 제조원가(장부가)로 계산하므로 같은 금액으로 더 많은 제품을 전달할 수 있습니다.</a:t>
+              <a:t>제품 기부는 내부적으로 제조원가 기준으로 환산해 계산하므로, 같은 예산으로 더 많은 제품을 전달할 수 있습니다.</a:t>
             </a:r>
             <a:endParaRPr lang="en-US" dirty="0"/>
           </a:p>
@@ -2084,7 +2084,7 @@
           <a:p>
             <a:r>
               <a:rPr lang="en-US" dirty="0"/>
-              <a:t>출처와 가정을 정리한 슬라이드입니다. 비용 구조 비중과 Hatch 판매량은 추정·미검증 수치입니다.</a:t>
+              <a:t>출처와 가정을 정리한 슬라이드입니다. 경쟁 제품 비용 비중과 Clocky 매출은 추정이며, 우리 쪽 수치는 가정입니다.</a:t>
             </a:r>
             <a:endParaRPr lang="en-US" dirty="0"/>
           </a:p>
@@ -2260,7 +2260,7 @@
           <a:p>
             <a:r>
               <a:rPr lang="en-US" dirty="0"/>
-              <a:t>늦잠의 원인은 소리 알람을 끄고 다시 잠드는 것. 우리는 소리 대신 촉각으로 깨웁니다.</a:t>
+              <a:t>알람을 끄고 다시 잠드는 일이 늦잠으로 이어질 수 있습니다. 우리는 소리 대신 촉각으로 깨웁니다.</a:t>
             </a:r>
             <a:endParaRPr lang="en-US" dirty="0"/>
           </a:p>
@@ -2436,7 +2436,7 @@
           <a:p>
             <a:r>
               <a:rPr lang="en-US" dirty="0"/>
-              <a:t>동일한 상용 제품은 확인되지 않았고, 깨우는 방식이 비슷한 제품을 비교했습니다. Hatch 매출은 제3자 추정입니다.</a:t>
+              <a:t>동일한 상용 제품은 확인되지 않았고, 깨우는 방식이 비슷한 제품을 비교했습니다. Hatch 매출은 언론 보도 수치입니다.</a:t>
             </a:r>
             <a:endParaRPr lang="en-US" dirty="0"/>
           </a:p>
@@ -3842,7 +3842,7 @@
                   <a:schemeClr val="tx1"/>
                 </a:solidFill>
               </a:rPr>
-              <a:t>제조원가는 소비자가의 1/3 선</a:t>
+              <a:t>우리 원가율이 가정보다 높다</a:t>
             </a:r>
             <a:endParaRPr lang="en-US" sz="1500" dirty="0"/>
           </a:p>
@@ -3878,7 +3878,7 @@
                   <a:schemeClr val="tx2"/>
                 </a:solidFill>
               </a:rPr>
-              <a:t>재료비와 제작 인건비가 소비자가의 약 30%일 때 마케팅과 개발비를 감당할 수 있습니다.</a:t>
+              <a:t>경쟁 제품은 재료비+인건비를 소비자가의 약 30%로 가정했는데, 우리는 약 40%입니다. 가격 인상이나 원가 절감이 필요합니다.</a:t>
             </a:r>
             <a:endParaRPr lang="en-US" sz="1300" dirty="0"/>
           </a:p>
@@ -4026,7 +4026,7 @@
                   <a:schemeClr val="tx2"/>
                 </a:solidFill>
               </a:rPr>
-              <a:t>자사몰과 크라우드펀딩 비중을 높여 판매 수수료를 평균 11%로 낮춥니다.</a:t>
+              <a:t>자사몰과 크라우드펀딩 비중을 높여 판매 수수료를 평균 11%로 낮추는 것을 가정했습니다.</a:t>
             </a:r>
             <a:endParaRPr lang="en-US" sz="1300" dirty="0"/>
           </a:p>
@@ -12340,7 +12340,7 @@
                   <a:schemeClr val="bg1"/>
                 </a:solidFill>
               </a:rPr>
-              <a:t>초기 필요 자금 약 4~5억원(추정): 1년차 적자 1.75억원과 초도 재고 운전자금</a:t>
+              <a:t>초기 필요 자금 약 4억원(추정): 1년차 적자 1.75억원 + 초도 재고 5,000대(약 2.3억원)</a:t>
             </a:r>
             <a:endParaRPr lang="en-US" sz="1400" dirty="0"/>
           </a:p>
@@ -15171,7 +15171,7 @@
                   <a:schemeClr val="bg1"/>
                 </a:solidFill>
               </a:rPr>
-              <a:t>해석: 같은 1만 대라도 가격을 11.9만원으로 올리면 영업손익이 -1.75억에서 -0.20억으로 개선됩니다. 스마트 베개($199~299)와 비교해 가격 인상 여지가 있으므로, 크라우드펀딩에서 9.9만원·11.9만원을 함께 시험하는 것을 권합니다. 서보는 소량 소매가 $11~14, 1,000개 도매 약 $1.47로 편차가 커서 견적 전에는 재료비 +50%까지 대비해야 합니다.</a:t>
+              <a:t>해석: 같은 1만 대라도 가격을 11.9만원으로 올리면 영업손익이 -1.75억에서 -0.20억으로 개선됩니다. 스마트 베개($199~299)와 비교해 가격 인상 여지가 있으므로, 크라우드펀딩에서 9.9만원·11.9만원을 함께 시험하는 것을 권합니다. 서보는 소량 소매가 $11~14, 도매 목록가 약 $1.47로 편차가 커서 견적 전에는 재료비 +50%까지 대비해야 합니다.</a:t>
             </a:r>
             <a:endParaRPr lang="en-US" sz="1400" dirty="0"/>
           </a:p>
@@ -15588,7 +15588,7 @@
                   <a:schemeClr val="tx2"/>
                 </a:solidFill>
               </a:rPr>
-              <a:t>매출 대비 약 0.1~0.2% (2023년 100대 기업 0.12%, 소비재 업종 0.52%). 세전이익 대비 3~4%는 2009~2015년 자료</a:t>
+              <a:t>2023년 100대 기업(90개사 공개) 매출 대비 0.12%. 필수소비재 0.52%, 금융 0.2% (2024 사회공헌백서)</a:t>
             </a:r>
             <a:endParaRPr lang="en-US" sz="1200" dirty="0"/>
           </a:p>
@@ -15884,7 +15884,7 @@
                   <a:schemeClr val="tx2"/>
                 </a:solidFill>
               </a:rPr>
-              <a:t>일반기부금 한도는 (소득금액-이월결손금)의 10%라 적자 구간엔 공제가 안 되고 초과분은 10년 이월. 현물 기부의 부가세는 확인 필요</a:t>
+              <a:t>기부금은 한도 내에서만 비용으로 인정하고 초과분은 10년 이월(법인세법 제24조). 한도율과 현물 기부의 부가세는 세무사 확인</a:t>
             </a:r>
             <a:endParaRPr lang="en-US" sz="1200" dirty="0"/>
           </a:p>
@@ -16176,7 +16176,7 @@
                   <a:schemeClr val="tx2"/>
                 </a:solidFill>
               </a:rPr>
-              <a:t>Clocky 연 $0.9~4.2M, Hatch 연 약 $140~200M(언론 보도). 재료비와 제작 인건비는 소비자가의 약 30%로 가정했습니다.</a:t>
+              <a:t>Clocky 연 평균 약 $4M(추정), Hatch 연 약 $140~200M(언론 보도). 재료비와 제작 인건비는 소비자가의 약 30%로 가정했습니다.</a:t>
             </a:r>
             <a:endParaRPr lang="en-US" sz="1400" dirty="0"/>
           </a:p>
@@ -16544,7 +16544,7 @@
                   <a:schemeClr val="tx2"/>
                 </a:solidFill>
               </a:rPr>
-              <a:t>국내 대기업 평균(0.1~0.2%)의 2.5배 이상. 영업이익률 10% 이상이면 1%로 상향합니다.</a:t>
+              <a:t>국내 100대 기업 평균(0.12%)의 약 4배, 필수소비재 업종(0.52%)과 비슷합니다. 영업이익률 10% 이상이면 1%로 상향합니다.</a:t>
             </a:r>
             <a:endParaRPr lang="en-US" sz="1400" dirty="0"/>
           </a:p>
@@ -17007,7 +17007,7 @@
                   <a:schemeClr val="tx2"/>
                 </a:solidFill>
               </a:rPr>
-              <a:t>국내 대기업 평균(0.1~0.2%)의 2.5배 이상이고 소비재 업종 평균(0.52%)과 비슷해 브랜드 약속으로 의미가 있습니다.</a:t>
+              <a:t>100대 기업 평균(0.12%)의 약 4배이고 필수소비재 업종 평균(0.52%)과 비슷해 브랜드 약속으로 의미가 있습니다.</a:t>
             </a:r>
             <a:endParaRPr lang="en-US" sz="1400" dirty="0"/>
           </a:p>
@@ -17155,7 +17155,7 @@
                   <a:schemeClr val="tx2"/>
                 </a:solidFill>
               </a:rPr>
-              <a:t>3년차 영업이익의 약 4.3%로 국내 평균(세전이익의 3~4%, 구 조사)과 비슷합니다.</a:t>
+              <a:t>3년차 영업이익의 약 4.3%입니다. 1년차는 적자라 이익 대비 비율이 의미 없어 매출 기준으로 정했습니다.</a:t>
             </a:r>
             <a:endParaRPr lang="en-US" sz="1400" dirty="0"/>
           </a:p>
@@ -19629,7 +19629,7 @@
                   <a:schemeClr val="tx2"/>
                 </a:solidFill>
               </a:rPr>
-              <a:t>수면 중 접촉으로 어린이·고령자가 다칠 수 있습니다. 힘 제한, 정지 센서, PL 단체보험(일반 대비 20~28% 저렴, 지자체 지원)을 갖춥니다.</a:t>
+              <a:t>수면 중 접촉으로 어린이·고령자가 다칠 수 있습니다. 힘 제한, 정지 센서, 제조물책임(PL) 보험을 갖춥니다. 지자체 보험료 지원 사업도 확인합니다.</a:t>
             </a:r>
             <a:endParaRPr lang="en-US" sz="1300" dirty="0"/>
           </a:p>
@@ -19777,7 +19777,7 @@
                   <a:schemeClr val="tx2"/>
                 </a:solidFill>
               </a:rPr>
-              <a:t>배터리 KC 700~1,500만원(4~12주), 블루투스 RF·EMC 시험 200~300만원(각 2~3주). 합계 약 1,000~1,800만원(추정).</a:t>
+              <a:t>배터리 KC 700~1,500만원(4~12주), 블루투스 RF·EMC 시험 200~300만원(각 2~3주). 합계 약 900~1,800만원(견적 필요).</a:t>
             </a:r>
             <a:endParaRPr lang="en-US" sz="1300" dirty="0"/>
           </a:p>
@@ -20369,7 +20369,7 @@
                   <a:schemeClr val="tx2"/>
                 </a:solidFill>
               </a:rPr>
-              <a:t>초기 약 4~5억원이 필요합니다. 선판매 입금과 재고 운전자금을 분리해 관리합니다.</a:t>
+              <a:t>초기 약 4억원 이상이 필요합니다(추정). 선판매 입금과 재고 운전자금을 분리해 관리합니다.</a:t>
             </a:r>
             <a:endParaRPr lang="en-US" sz="1300" dirty="0"/>
           </a:p>
@@ -21908,7 +21908,7 @@
                   </a:tcPr>
                 </a:tc>
               </a:tr>
-              <a:tr h="457200">
+              <a:tr h="420624">
                 <a:tc>
                   <a:txBody>
                     <a:bodyPr/>
@@ -21984,7 +21984,7 @@
                             <a:schemeClr val="tx1"/>
                           </a:solidFill>
                         </a:rPr>
-                        <a:t>소매 페이지, 2007년 기사</a:t>
+                        <a:t>소매 페이지, 언론 보도</a:t>
                       </a:r>
                       <a:endParaRPr lang="en-US" sz="1300" dirty="0"/>
                     </a:p>
@@ -22154,7 +22154,7 @@
                   </a:tcPr>
                 </a:tc>
               </a:tr>
-              <a:tr h="457200">
+              <a:tr h="420624">
                 <a:tc>
                   <a:txBody>
                     <a:bodyPr/>
@@ -22230,7 +22230,7 @@
                             <a:schemeClr val="tx1"/>
                           </a:solidFill>
                         </a:rPr>
-                        <a:t>인터뷰 50만 대, 3년 13만 대, 2년 3.5만 대</a:t>
+                        <a:t>창업자 인터뷰 보도, 판매 시점 불명확</a:t>
                       </a:r>
                       <a:endParaRPr lang="en-US" sz="1300" dirty="0"/>
                     </a:p>
@@ -22352,7 +22352,7 @@
                             <a:schemeClr val="tx1"/>
                           </a:solidFill>
                         </a:rPr>
-                        <a:t>업체·보도 추가 확인</a:t>
+                        <a:t>상한 추정으로만 사용</a:t>
                       </a:r>
                       <a:endParaRPr lang="en-US" sz="1300" dirty="0"/>
                     </a:p>
@@ -22400,7 +22400,7 @@
                   </a:tcPr>
                 </a:tc>
               </a:tr>
-              <a:tr h="457200">
+              <a:tr h="420624">
                 <a:tc>
                   <a:txBody>
                     <a:bodyPr/>
@@ -22476,7 +22476,7 @@
                             <a:schemeClr val="tx1"/>
                           </a:solidFill>
                         </a:rPr>
-                        <a:t>언론 보도 $140~200M, 비공개 기업(DB 추정 $6.9M와 상충)</a:t>
+                        <a:t>언론 보도 $140~200M, 비공개 기업</a:t>
                       </a:r>
                       <a:endParaRPr lang="en-US" sz="1300" dirty="0"/>
                     </a:p>
@@ -22646,7 +22646,7 @@
                   </a:tcPr>
                 </a:tc>
               </a:tr>
-              <a:tr h="457200">
+              <a:tr h="420624">
                 <a:tc>
                   <a:txBody>
                     <a:bodyPr/>
@@ -22844,7 +22844,7 @@
                             <a:schemeClr val="tx1"/>
                           </a:solidFill>
                         </a:rPr>
-                        <a:t>기상 제품 시장 별도 조사</a:t>
+                        <a:t>참고용으로만 사용</a:t>
                       </a:r>
                       <a:endParaRPr lang="en-US" sz="1300" dirty="0"/>
                     </a:p>
@@ -22892,7 +22892,7 @@
                   </a:tcPr>
                 </a:tc>
               </a:tr>
-              <a:tr h="457200">
+              <a:tr h="420624">
                 <a:tc>
                   <a:txBody>
                     <a:bodyPr/>
@@ -22907,7 +22907,7 @@
                             <a:schemeClr val="tx1"/>
                           </a:solidFill>
                         </a:rPr>
-                        <a:t>비용 구조 비중</a:t>
+                        <a:t>경쟁 제품 비용 비중</a:t>
                       </a:r>
                       <a:endParaRPr lang="en-US" sz="1300" dirty="0"/>
                     </a:p>
@@ -23138,7 +23138,7 @@
                   </a:tcPr>
                 </a:tc>
               </a:tr>
-              <a:tr h="457200">
+              <a:tr h="420624">
                 <a:tc>
                   <a:txBody>
                     <a:bodyPr/>
@@ -23214,7 +23214,7 @@
                             <a:schemeClr val="tx1"/>
                           </a:solidFill>
                         </a:rPr>
-                        <a:t>서보 1,000개 약 $1.47, MCU 모듈 약 $1~2는 부합. 배터리 미확인</a:t>
+                        <a:t>서보·MCU는 도매 목록가, 나머지 가정</a:t>
                       </a:r>
                       <a:endParaRPr lang="en-US" sz="1300" dirty="0"/>
                     </a:p>
@@ -23384,7 +23384,7 @@
                   </a:tcPr>
                 </a:tc>
               </a:tr>
-              <a:tr h="457200">
+              <a:tr h="420624">
                 <a:tc>
                   <a:txBody>
                     <a:bodyPr/>
@@ -23460,7 +23460,7 @@
                             <a:schemeClr val="tx1"/>
                           </a:solidFill>
                         </a:rPr>
-                        <a:t>와디즈 공식 요금제 확인, 스토어·쿠팡은 블로그</a:t>
+                        <a:t>와디즈 공식 요금제(2026.2), 스토어·쿠팡은 비교 자료</a:t>
                       </a:r>
                       <a:endParaRPr lang="en-US" sz="1300" dirty="0"/>
                     </a:p>
@@ -23630,7 +23630,7 @@
                   </a:tcPr>
                 </a:tc>
               </a:tr>
-              <a:tr h="457200">
+              <a:tr h="420624">
                 <a:tc>
                   <a:txBody>
                     <a:bodyPr/>
@@ -23706,7 +23706,7 @@
                             <a:schemeClr val="tx1"/>
                           </a:solidFill>
                         </a:rPr>
-                        <a:t>배터리 700~1,500만원, 블루투스 시험 200~300만원(업체 안내)</a:t>
+                        <a:t>배터리·블루투스 시험 업체 안내</a:t>
                       </a:r>
                       <a:endParaRPr lang="en-US" sz="1300" dirty="0"/>
                     </a:p>
@@ -23876,7 +23876,7 @@
                   </a:tcPr>
                 </a:tc>
               </a:tr>
-              <a:tr h="0">
+              <a:tr h="420624">
                 <a:tc>
                   <a:txBody>
                     <a:bodyPr/>
@@ -23891,7 +23891,7 @@
                             <a:schemeClr val="tx1"/>
                           </a:solidFill>
                         </a:rPr>
-                        <a:t>기부 벤치마크·세법</a:t>
+                        <a:t>기업 기부 비율</a:t>
                       </a:r>
                       <a:endParaRPr lang="en-US" sz="1300" dirty="0"/>
                     </a:p>
@@ -23952,7 +23952,7 @@
                             <a:schemeClr val="tx1"/>
                           </a:solidFill>
                         </a:rPr>
-                        <a:t>10% 한도는 서식 확인, 현물 부가세 미확인</a:t>
+                        <a:t>2024 사회공헌백서 보도(2023년, 90개사)</a:t>
                       </a:r>
                       <a:endParaRPr lang="en-US" sz="1300" dirty="0"/>
                     </a:p>
@@ -24074,7 +24074,253 @@
                             <a:schemeClr val="tx1"/>
                           </a:solidFill>
                         </a:rPr>
-                        <a:t>세무사 확인</a:t>
+                        <a:t>백서 원문 확인</a:t>
+                      </a:r>
+                      <a:endParaRPr lang="en-US" sz="1300" dirty="0"/>
+                    </a:p>
+                  </a:txBody>
+                  <a:tcPr marL="91440" marR="91440" marT="45720" marB="45720" anchor="ctr">
+                    <a:lnL w="9525" cap="flat" cmpd="sng" algn="ctr">
+                      <a:solidFill>
+                        <a:srgbClr val="DDE1EE"/>
+                      </a:solidFill>
+                      <a:prstDash val="solid"/>
+                      <a:round/>
+                      <a:headEnd type="none" w="med" len="med"/>
+                      <a:tailEnd type="none" w="med" len="med"/>
+                    </a:lnL>
+                    <a:lnR w="9525" cap="flat" cmpd="sng" algn="ctr">
+                      <a:solidFill>
+                        <a:srgbClr val="DDE1EE"/>
+                      </a:solidFill>
+                      <a:prstDash val="solid"/>
+                      <a:round/>
+                      <a:headEnd type="none" w="med" len="med"/>
+                      <a:tailEnd type="none" w="med" len="med"/>
+                    </a:lnR>
+                    <a:lnT w="9525" cap="flat" cmpd="sng" algn="ctr">
+                      <a:solidFill>
+                        <a:srgbClr val="DDE1EE"/>
+                      </a:solidFill>
+                      <a:prstDash val="solid"/>
+                      <a:round/>
+                      <a:headEnd type="none" w="med" len="med"/>
+                      <a:tailEnd type="none" w="med" len="med"/>
+                    </a:lnT>
+                    <a:lnB w="9525" cap="flat" cmpd="sng" algn="ctr">
+                      <a:solidFill>
+                        <a:srgbClr val="DDE1EE"/>
+                      </a:solidFill>
+                      <a:prstDash val="solid"/>
+                      <a:round/>
+                      <a:headEnd type="none" w="med" len="med"/>
+                      <a:tailEnd type="none" w="med" len="med"/>
+                    </a:lnB>
+                    <a:solidFill>
+                      <a:schemeClr val="bg1"/>
+                    </a:solidFill>
+                  </a:tcPr>
+                </a:tc>
+              </a:tr>
+              <a:tr h="420624">
+                <a:tc>
+                  <a:txBody>
+                    <a:bodyPr/>
+                    <a:lstStyle/>
+                    <a:p>
+                      <a:pPr indent="0" marL="0">
+                        <a:buNone/>
+                      </a:pPr>
+                      <a:r>
+                        <a:rPr lang="en-US" sz="1300" b="1" dirty="0">
+                          <a:solidFill>
+                            <a:schemeClr val="tx1"/>
+                          </a:solidFill>
+                        </a:rPr>
+                        <a:t>세법</a:t>
+                      </a:r>
+                      <a:endParaRPr lang="en-US" sz="1300" dirty="0"/>
+                    </a:p>
+                  </a:txBody>
+                  <a:tcPr marL="91440" marR="91440" marT="45720" marB="45720" anchor="ctr">
+                    <a:lnL w="9525" cap="flat" cmpd="sng" algn="ctr">
+                      <a:solidFill>
+                        <a:srgbClr val="DDE1EE"/>
+                      </a:solidFill>
+                      <a:prstDash val="solid"/>
+                      <a:round/>
+                      <a:headEnd type="none" w="med" len="med"/>
+                      <a:tailEnd type="none" w="med" len="med"/>
+                    </a:lnL>
+                    <a:lnR w="9525" cap="flat" cmpd="sng" algn="ctr">
+                      <a:solidFill>
+                        <a:srgbClr val="DDE1EE"/>
+                      </a:solidFill>
+                      <a:prstDash val="solid"/>
+                      <a:round/>
+                      <a:headEnd type="none" w="med" len="med"/>
+                      <a:tailEnd type="none" w="med" len="med"/>
+                    </a:lnR>
+                    <a:lnT w="9525" cap="flat" cmpd="sng" algn="ctr">
+                      <a:solidFill>
+                        <a:srgbClr val="DDE1EE"/>
+                      </a:solidFill>
+                      <a:prstDash val="solid"/>
+                      <a:round/>
+                      <a:headEnd type="none" w="med" len="med"/>
+                      <a:tailEnd type="none" w="med" len="med"/>
+                    </a:lnT>
+                    <a:lnB w="9525" cap="flat" cmpd="sng" algn="ctr">
+                      <a:solidFill>
+                        <a:srgbClr val="DDE1EE"/>
+                      </a:solidFill>
+                      <a:prstDash val="solid"/>
+                      <a:round/>
+                      <a:headEnd type="none" w="med" len="med"/>
+                      <a:tailEnd type="none" w="med" len="med"/>
+                    </a:lnB>
+                    <a:solidFill>
+                      <a:schemeClr val="bg1"/>
+                    </a:solidFill>
+                  </a:tcPr>
+                </a:tc>
+                <a:tc>
+                  <a:txBody>
+                    <a:bodyPr/>
+                    <a:lstStyle/>
+                    <a:p>
+                      <a:pPr indent="0" marL="0">
+                        <a:buNone/>
+                      </a:pPr>
+                      <a:r>
+                        <a:rPr lang="en-US" sz="1300" dirty="0">
+                          <a:solidFill>
+                            <a:schemeClr val="tx1"/>
+                          </a:solidFill>
+                        </a:rPr>
+                        <a:t>제24조 원문: 한도 내 인정, 10년 이월</a:t>
+                      </a:r>
+                      <a:endParaRPr lang="en-US" sz="1300" dirty="0"/>
+                    </a:p>
+                  </a:txBody>
+                  <a:tcPr marL="91440" marR="91440" marT="45720" marB="45720" anchor="ctr">
+                    <a:lnL w="9525" cap="flat" cmpd="sng" algn="ctr">
+                      <a:solidFill>
+                        <a:srgbClr val="DDE1EE"/>
+                      </a:solidFill>
+                      <a:prstDash val="solid"/>
+                      <a:round/>
+                      <a:headEnd type="none" w="med" len="med"/>
+                      <a:tailEnd type="none" w="med" len="med"/>
+                    </a:lnL>
+                    <a:lnR w="9525" cap="flat" cmpd="sng" algn="ctr">
+                      <a:solidFill>
+                        <a:srgbClr val="DDE1EE"/>
+                      </a:solidFill>
+                      <a:prstDash val="solid"/>
+                      <a:round/>
+                      <a:headEnd type="none" w="med" len="med"/>
+                      <a:tailEnd type="none" w="med" len="med"/>
+                    </a:lnR>
+                    <a:lnT w="9525" cap="flat" cmpd="sng" algn="ctr">
+                      <a:solidFill>
+                        <a:srgbClr val="DDE1EE"/>
+                      </a:solidFill>
+                      <a:prstDash val="solid"/>
+                      <a:round/>
+                      <a:headEnd type="none" w="med" len="med"/>
+                      <a:tailEnd type="none" w="med" len="med"/>
+                    </a:lnT>
+                    <a:lnB w="9525" cap="flat" cmpd="sng" algn="ctr">
+                      <a:solidFill>
+                        <a:srgbClr val="DDE1EE"/>
+                      </a:solidFill>
+                      <a:prstDash val="solid"/>
+                      <a:round/>
+                      <a:headEnd type="none" w="med" len="med"/>
+                      <a:tailEnd type="none" w="med" len="med"/>
+                    </a:lnB>
+                    <a:solidFill>
+                      <a:schemeClr val="bg1"/>
+                    </a:solidFill>
+                  </a:tcPr>
+                </a:tc>
+                <a:tc>
+                  <a:txBody>
+                    <a:bodyPr/>
+                    <a:lstStyle/>
+                    <a:p>
+                      <a:pPr algn="ctr" indent="0" marL="0">
+                        <a:buNone/>
+                      </a:pPr>
+                      <a:r>
+                        <a:rPr lang="en-US" sz="1300" b="1" dirty="0">
+                          <a:solidFill>
+                            <a:schemeClr val="tx1"/>
+                          </a:solidFill>
+                        </a:rPr>
+                        <a:t>높음</a:t>
+                      </a:r>
+                      <a:endParaRPr lang="en-US" sz="1300" dirty="0"/>
+                    </a:p>
+                  </a:txBody>
+                  <a:tcPr marL="91440" marR="91440" marT="45720" marB="45720" anchor="ctr">
+                    <a:lnL w="9525" cap="flat" cmpd="sng" algn="ctr">
+                      <a:solidFill>
+                        <a:srgbClr val="DDE1EE"/>
+                      </a:solidFill>
+                      <a:prstDash val="solid"/>
+                      <a:round/>
+                      <a:headEnd type="none" w="med" len="med"/>
+                      <a:tailEnd type="none" w="med" len="med"/>
+                    </a:lnL>
+                    <a:lnR w="9525" cap="flat" cmpd="sng" algn="ctr">
+                      <a:solidFill>
+                        <a:srgbClr val="DDE1EE"/>
+                      </a:solidFill>
+                      <a:prstDash val="solid"/>
+                      <a:round/>
+                      <a:headEnd type="none" w="med" len="med"/>
+                      <a:tailEnd type="none" w="med" len="med"/>
+                    </a:lnR>
+                    <a:lnT w="9525" cap="flat" cmpd="sng" algn="ctr">
+                      <a:solidFill>
+                        <a:srgbClr val="DDE1EE"/>
+                      </a:solidFill>
+                      <a:prstDash val="solid"/>
+                      <a:round/>
+                      <a:headEnd type="none" w="med" len="med"/>
+                      <a:tailEnd type="none" w="med" len="med"/>
+                    </a:lnT>
+                    <a:lnB w="9525" cap="flat" cmpd="sng" algn="ctr">
+                      <a:solidFill>
+                        <a:srgbClr val="DDE1EE"/>
+                      </a:solidFill>
+                      <a:prstDash val="solid"/>
+                      <a:round/>
+                      <a:headEnd type="none" w="med" len="med"/>
+                      <a:tailEnd type="none" w="med" len="med"/>
+                    </a:lnB>
+                    <a:solidFill>
+                      <a:schemeClr val="bg1"/>
+                    </a:solidFill>
+                  </a:tcPr>
+                </a:tc>
+                <a:tc>
+                  <a:txBody>
+                    <a:bodyPr/>
+                    <a:lstStyle/>
+                    <a:p>
+                      <a:pPr indent="0" marL="0">
+                        <a:buNone/>
+                      </a:pPr>
+                      <a:r>
+                        <a:rPr lang="en-US" sz="1300" dirty="0">
+                          <a:solidFill>
+                            <a:schemeClr val="tx1"/>
+                          </a:solidFill>
+                        </a:rPr>
+                        <a:t>한도율·현물 부가세는 세무사</a:t>
                       </a:r>
                       <a:endParaRPr lang="en-US" sz="1300" dirty="0"/>
                     </a:p>
@@ -24358,7 +24604,7 @@
                   <a:schemeClr val="tx1"/>
                 </a:solidFill>
               </a:rPr>
-              <a:t>판매 채널: 자사몰 35%(수수료 약 6%), 마켓 35%(약 9%), 크라우드펀딩 20%(약 13%), B2B 10%(30%) → 평균 11%. 와디즈는 요금제 10~19%(VAT 별도), 나머지는 블로그 기준</a:t>
+              <a:t>판매 채널(가정): 자사몰 35%(수수료 약 6%), 마켓 35%(약 8%), 크라우드펀딩 20%(15%), B2B 10%(30% 가정) → 평균 약 11%. 와디즈는 2026.2 공식 요금(12%+3%, VAT 별도)</a:t>
             </a:r>
             <a:endParaRPr lang="en-US" sz="1300" dirty="0"/>
           </a:p>
@@ -24412,7 +24658,7 @@
                   <a:schemeClr val="tx1"/>
                 </a:solidFill>
               </a:rPr>
-              <a:t>세법·기부 한도는 2차 자료, 신고 전 세무사 확인 필요</a:t>
+              <a:t>세법은 법인세법 제24조 원문 확인(한도율·현물 부가세는 세무사 확인 필요)</a:t>
             </a:r>
             <a:endParaRPr lang="en-US" sz="1300" dirty="0"/>
           </a:p>
@@ -24430,7 +24676,7 @@
                   <a:schemeClr val="tx1"/>
                 </a:solidFill>
               </a:rPr>
-              <a:t>0.12%(2023년 100대 기업)는 사회공헌백서를 인용한 언론 보도 기준</a:t>
+              <a:t>0.12%·0.52%는 2024 사회공헌백서(2023년, 100대 기업 중 90개사 공개)를 보도한 기사 기준</a:t>
             </a:r>
             <a:endParaRPr lang="en-US" sz="1300" dirty="0"/>
           </a:p>
@@ -24560,7 +24806,7 @@
                   </a:extLst>
                 </a:hlinkClick>
               </a:rPr>
-              <a:t>Clocky 13만 대 (eGFI)</a:t>
+              <a:t>Clocky 가격 (New Atlas)</a:t>
             </a:r>
             <a:endParaRPr lang="en-US" sz="1000" dirty="0"/>
           </a:p>
@@ -24584,7 +24830,7 @@
                   </a:extLst>
                 </a:hlinkClick>
               </a:rPr>
-              <a:t>Clocky 가격 (New Atlas)</a:t>
+              <a:t>Sonic Alert 침대 진동기</a:t>
             </a:r>
             <a:endParaRPr lang="en-US" sz="1000" dirty="0"/>
           </a:p>
@@ -24608,7 +24854,7 @@
                   </a:extLst>
                 </a:hlinkClick>
               </a:rPr>
-              <a:t>Sonic Alert 침대 진동기</a:t>
+              <a:t>Hatch 가격 (asinsight)</a:t>
             </a:r>
             <a:endParaRPr lang="en-US" sz="1000" dirty="0"/>
           </a:p>
@@ -24632,7 +24878,7 @@
                   </a:extLst>
                 </a:hlinkClick>
               </a:rPr>
-              <a:t>Hatch 가격 (asinsight)</a:t>
+              <a:t>Hatch 매출 (Modern Retail)</a:t>
             </a:r>
             <a:endParaRPr lang="en-US" sz="1000" dirty="0"/>
           </a:p>
@@ -24656,7 +24902,7 @@
                   </a:extLst>
                 </a:hlinkClick>
               </a:rPr>
-              <a:t>Hatch 매출 (Modern Retail)</a:t>
+              <a:t>Hatch 매출 (IBTimes)</a:t>
             </a:r>
             <a:endParaRPr lang="en-US" sz="1000" dirty="0"/>
           </a:p>
@@ -24680,7 +24926,7 @@
                   </a:extLst>
                 </a:hlinkClick>
               </a:rPr>
-              <a:t>Hatch 매출 (IBTimes)</a:t>
+              <a:t>ZEEQ 베개 (Gearbrain)</a:t>
             </a:r>
             <a:endParaRPr lang="en-US" sz="1000" dirty="0"/>
           </a:p>
@@ -24704,7 +24950,7 @@
                   </a:extLst>
                 </a:hlinkClick>
               </a:rPr>
-              <a:t>Hatch 판매량 (Fast Company)</a:t>
+              <a:t>Sunrise 베개 (MobileSyrup)</a:t>
             </a:r>
             <a:endParaRPr lang="en-US" sz="1000" dirty="0"/>
           </a:p>
@@ -24728,7 +24974,7 @@
                   </a:extLst>
                 </a:hlinkClick>
               </a:rPr>
-              <a:t>ZEEQ 베개 (Gearbrain)</a:t>
+              <a:t>Ruggie 알람 (Ubergizmo)</a:t>
             </a:r>
             <a:endParaRPr lang="en-US" sz="1000" dirty="0"/>
           </a:p>
@@ -24752,7 +24998,7 @@
                   </a:extLst>
                 </a:hlinkClick>
               </a:rPr>
-              <a:t>Sunrise 베개 (MobileSyrup)</a:t>
+              <a:t>스누즈 연구 (Discover)</a:t>
             </a:r>
             <a:endParaRPr lang="en-US" sz="1000" dirty="0"/>
           </a:p>
@@ -24776,10 +25022,32 @@
                   </a:extLst>
                 </a:hlinkClick>
               </a:rPr>
-              <a:t>Ruggie 알람 (Ubergizmo)</a:t>
+              <a:t>직장인 지각 설문 (경향신문)</a:t>
             </a:r>
             <a:endParaRPr lang="en-US" sz="1000" dirty="0"/>
           </a:p>
+        </p:txBody>
+      </p:sp>
+      <p:sp>
+        <p:nvSpPr>
+          <p:cNvPr id="8" name="출처 목록 2"/>
+          <p:cNvSpPr txBox="1"/>
+          <p:nvPr/>
+        </p:nvSpPr>
+        <p:spPr>
+          <a:xfrm>
+            <a:off x="8321040" y="1828800"/>
+            <a:ext cx="3291840" cy="4389120"/>
+          </a:xfrm>
+          <a:prstGeom prst="rect">
+            <a:avLst/>
+          </a:prstGeom>
+          <a:noFill/>
+          <a:ln/>
+        </p:spPr>
+        <p:txBody>
+          <a:bodyPr wrap="square" lIns="0" tIns="0" rIns="0" bIns="0" rtlCol="0" anchor="t"/>
+          <a:lstStyle/>
           <a:p>
             <a:pPr indent="0" marL="0">
               <a:spcAft>
@@ -24800,7 +25068,7 @@
                   </a:extLst>
                 </a:hlinkClick>
               </a:rPr>
-              <a:t>스누즈 연구 (Discover)</a:t>
+              <a:t>스마트 클락 시장 (TBRC)</a:t>
             </a:r>
             <a:endParaRPr lang="en-US" sz="1000" dirty="0"/>
           </a:p>
@@ -24824,7 +25092,7 @@
                   </a:extLst>
                 </a:hlinkClick>
               </a:rPr>
-              <a:t>직장인 지각 설문 (경향신문)</a:t>
+              <a:t>스마트 베개 시장 (Technavio)</a:t>
             </a:r>
             <a:endParaRPr lang="en-US" sz="1000" dirty="0"/>
           </a:p>
@@ -24848,7 +25116,7 @@
                   </a:extLst>
                 </a:hlinkClick>
               </a:rPr>
-              <a:t>스마트 클락 시장 (TBRC)</a:t>
+              <a:t>와디즈 수수료 (도움말 센터)</a:t>
             </a:r>
             <a:endParaRPr lang="en-US" sz="1000" dirty="0"/>
           </a:p>
@@ -24872,32 +25140,10 @@
                   </a:extLst>
                 </a:hlinkClick>
               </a:rPr>
-              <a:t>스마트 베개 시장 (Technavio)</a:t>
+              <a:t>스토어·쿠팡 수수료 (glasswallet)</a:t>
             </a:r>
             <a:endParaRPr lang="en-US" sz="1000" dirty="0"/>
           </a:p>
-        </p:txBody>
-      </p:sp>
-      <p:sp>
-        <p:nvSpPr>
-          <p:cNvPr id="8" name="출처 목록 2"/>
-          <p:cNvSpPr txBox="1"/>
-          <p:nvPr/>
-        </p:nvSpPr>
-        <p:spPr>
-          <a:xfrm>
-            <a:off x="8321040" y="1828800"/>
-            <a:ext cx="3291840" cy="4389120"/>
-          </a:xfrm>
-          <a:prstGeom prst="rect">
-            <a:avLst/>
-          </a:prstGeom>
-          <a:noFill/>
-          <a:ln/>
-        </p:spPr>
-        <p:txBody>
-          <a:bodyPr wrap="square" lIns="0" tIns="0" rIns="0" bIns="0" rtlCol="0" anchor="t"/>
-          <a:lstStyle/>
           <a:p>
             <a:pPr indent="0" marL="0">
               <a:spcAft>
@@ -24918,7 +25164,7 @@
                   </a:extLst>
                 </a:hlinkClick>
               </a:rPr>
-              <a:t>국내 수면 산업 (청년일보)</a:t>
+              <a:t>서보 도매 목록가 (Alibaba)</a:t>
             </a:r>
             <a:endParaRPr lang="en-US" sz="1000" dirty="0"/>
           </a:p>
@@ -24942,7 +25188,7 @@
                   </a:extLst>
                 </a:hlinkClick>
               </a:rPr>
-              <a:t>와디즈 수수료 (도움말 센터)</a:t>
+              <a:t>MCU 모듈 가격 (LCSC)</a:t>
             </a:r>
             <a:endParaRPr lang="en-US" sz="1000" dirty="0"/>
           </a:p>
@@ -24966,7 +25212,7 @@
                   </a:extLst>
                 </a:hlinkClick>
               </a:rPr>
-              <a:t>판매 수수료 비교 (glasswallet)</a:t>
+              <a:t>배터리 KC 인증 (Ufine)</a:t>
             </a:r>
             <a:endParaRPr lang="en-US" sz="1000" dirty="0"/>
           </a:p>
@@ -24990,7 +25236,7 @@
                   </a:extLst>
                 </a:hlinkClick>
               </a:rPr>
-              <a:t>서보 도매가 (Alibaba)</a:t>
+              <a:t>블루투스 KC 시험 (KC전기)</a:t>
             </a:r>
             <a:endParaRPr lang="en-US" sz="1000" dirty="0"/>
           </a:p>
@@ -25014,7 +25260,7 @@
                   </a:extLst>
                 </a:hlinkClick>
               </a:rPr>
-              <a:t>MCU 모듈 가격 (LCSC)</a:t>
+              <a:t>사회공헌백서 2024 (미래한국)</a:t>
             </a:r>
             <a:endParaRPr lang="en-US" sz="1000" dirty="0"/>
           </a:p>
@@ -25038,7 +25284,7 @@
                   </a:extLst>
                 </a:hlinkClick>
               </a:rPr>
-              <a:t>배터리 KC 인증 (Ufine)</a:t>
+              <a:t>Patagonia 1% for the Planet</a:t>
             </a:r>
             <a:endParaRPr lang="en-US" sz="1000" dirty="0"/>
           </a:p>
@@ -25062,175 +25308,7 @@
                   </a:extLst>
                 </a:hlinkClick>
               </a:rPr>
-              <a:t>블루투스 KC 시험 (KC전기)</a:t>
-            </a:r>
-            <a:endParaRPr lang="en-US" sz="1000" dirty="0"/>
-          </a:p>
-          <a:p>
-            <a:pPr indent="0" marL="0">
-              <a:spcAft>
-                <a:spcPts val="300"/>
-              </a:spcAft>
-              <a:buNone/>
-            </a:pPr>
-            <a:r>
-              <a:rPr lang="en-US" sz="1000" u="sng" dirty="0">
-                <a:solidFill>
-                  <a:schemeClr val="tx1"/>
-                </a:solidFill>
-                <a:hlinkClick r:id="rId24" invalidUrl="" action="" tgtFrame="" tooltip="" history="1" highlightClick="0" endSnd="0">
-                  <a:extLst>
-                    <a:ext uri="{A12FA001-AC4F-418D-AE19-62706E023703}">
-                      <ahyp:hlinkClr xmlns:ahyp="http://schemas.microsoft.com/office/drawing/2018/hyperlinkcolor" val="tx"/>
-                    </a:ext>
-                  </a:extLst>
-                </a:hlinkClick>
-              </a:rPr>
-              <a:t>PL 단체보험 (이투데이)</a:t>
-            </a:r>
-            <a:endParaRPr lang="en-US" sz="1000" dirty="0"/>
-          </a:p>
-          <a:p>
-            <a:pPr indent="0" marL="0">
-              <a:spcAft>
-                <a:spcPts val="300"/>
-              </a:spcAft>
-              <a:buNone/>
-            </a:pPr>
-            <a:r>
-              <a:rPr lang="en-US" sz="1000" u="sng" dirty="0">
-                <a:solidFill>
-                  <a:schemeClr val="tx1"/>
-                </a:solidFill>
-                <a:hlinkClick r:id="rId25" invalidUrl="" action="" tgtFrame="" tooltip="" history="1" highlightClick="0" endSnd="0">
-                  <a:extLst>
-                    <a:ext uri="{A12FA001-AC4F-418D-AE19-62706E023703}">
-                      <ahyp:hlinkClr xmlns:ahyp="http://schemas.microsoft.com/office/drawing/2018/hyperlinkcolor" val="tx"/>
-                    </a:ext>
-                  </a:extLst>
-                </a:hlinkClick>
-              </a:rPr>
-              <a:t>PL 보험료 지원 2026 (더체크)</a:t>
-            </a:r>
-            <a:endParaRPr lang="en-US" sz="1000" dirty="0"/>
-          </a:p>
-          <a:p>
-            <a:pPr indent="0" marL="0">
-              <a:spcAft>
-                <a:spcPts val="300"/>
-              </a:spcAft>
-              <a:buNone/>
-            </a:pPr>
-            <a:r>
-              <a:rPr lang="en-US" sz="1000" u="sng" dirty="0">
-                <a:solidFill>
-                  <a:schemeClr val="tx1"/>
-                </a:solidFill>
-                <a:hlinkClick r:id="rId26" invalidUrl="" action="" tgtFrame="" tooltip="" history="1" highlightClick="0" endSnd="0">
-                  <a:extLst>
-                    <a:ext uri="{A12FA001-AC4F-418D-AE19-62706E023703}">
-                      <ahyp:hlinkClr xmlns:ahyp="http://schemas.microsoft.com/office/drawing/2018/hyperlinkcolor" val="tx"/>
-                    </a:ext>
-                  </a:extLst>
-                </a:hlinkClick>
-              </a:rPr>
-              <a:t>사회공헌백서 2024 (미래한국)</a:t>
-            </a:r>
-            <a:endParaRPr lang="en-US" sz="1000" dirty="0"/>
-          </a:p>
-          <a:p>
-            <a:pPr indent="0" marL="0">
-              <a:spcAft>
-                <a:spcPts val="300"/>
-              </a:spcAft>
-              <a:buNone/>
-            </a:pPr>
-            <a:r>
-              <a:rPr lang="en-US" sz="1000" u="sng" dirty="0">
-                <a:solidFill>
-                  <a:schemeClr val="tx1"/>
-                </a:solidFill>
-                <a:hlinkClick r:id="rId27" invalidUrl="" action="" tgtFrame="" tooltip="" history="1" highlightClick="0" endSnd="0">
-                  <a:extLst>
-                    <a:ext uri="{A12FA001-AC4F-418D-AE19-62706E023703}">
-                      <ahyp:hlinkClr xmlns:ahyp="http://schemas.microsoft.com/office/drawing/2018/hyperlinkcolor" val="tx"/>
-                    </a:ext>
-                  </a:extLst>
-                </a:hlinkClick>
-              </a:rPr>
-              <a:t>한경협 사회공헌 (이투데이)</a:t>
-            </a:r>
-            <a:endParaRPr lang="en-US" sz="1000" dirty="0"/>
-          </a:p>
-          <a:p>
-            <a:pPr indent="0" marL="0">
-              <a:spcAft>
-                <a:spcPts val="300"/>
-              </a:spcAft>
-              <a:buNone/>
-            </a:pPr>
-            <a:r>
-              <a:rPr lang="en-US" sz="1000" u="sng" dirty="0">
-                <a:solidFill>
-                  <a:schemeClr val="tx1"/>
-                </a:solidFill>
-                <a:hlinkClick r:id="rId28" invalidUrl="" action="" tgtFrame="" tooltip="" history="1" highlightClick="0" endSnd="0">
-                  <a:extLst>
-                    <a:ext uri="{A12FA001-AC4F-418D-AE19-62706E023703}">
-                      <ahyp:hlinkClr xmlns:ahyp="http://schemas.microsoft.com/office/drawing/2018/hyperlinkcolor" val="tx"/>
-                    </a:ext>
-                  </a:extLst>
-                </a:hlinkClick>
-              </a:rPr>
-              <a:t>전경련 구 조사 (이투데이)</a:t>
-            </a:r>
-            <a:endParaRPr lang="en-US" sz="1000" dirty="0"/>
-          </a:p>
-          <a:p>
-            <a:pPr indent="0" marL="0">
-              <a:spcAft>
-                <a:spcPts val="300"/>
-              </a:spcAft>
-              <a:buNone/>
-            </a:pPr>
-            <a:r>
-              <a:rPr lang="en-US" sz="1000" u="sng" dirty="0">
-                <a:solidFill>
-                  <a:schemeClr val="tx1"/>
-                </a:solidFill>
-                <a:hlinkClick r:id="rId29" invalidUrl="" action="" tgtFrame="" tooltip="" history="1" highlightClick="0" endSnd="0">
-                  <a:extLst>
-                    <a:ext uri="{A12FA001-AC4F-418D-AE19-62706E023703}">
-                      <ahyp:hlinkClr xmlns:ahyp="http://schemas.microsoft.com/office/drawing/2018/hyperlinkcolor" val="tx"/>
-                    </a:ext>
-                  </a:extLst>
-                </a:hlinkClick>
-              </a:rPr>
-              <a:t>Patagonia 1% for the Planet</a:t>
-            </a:r>
-            <a:endParaRPr lang="en-US" sz="1000" dirty="0"/>
-          </a:p>
-          <a:p>
-            <a:pPr indent="0" marL="0">
-              <a:spcAft>
-                <a:spcPts val="300"/>
-              </a:spcAft>
-              <a:buNone/>
-            </a:pPr>
-            <a:r>
-              <a:rPr lang="en-US" sz="1000" u="sng" dirty="0">
-                <a:solidFill>
-                  <a:schemeClr val="tx1"/>
-                </a:solidFill>
-                <a:hlinkClick r:id="rId30" invalidUrl="" action="" tgtFrame="" tooltip="" history="1" highlightClick="0" endSnd="0">
-                  <a:extLst>
-                    <a:ext uri="{A12FA001-AC4F-418D-AE19-62706E023703}">
-                      <ahyp:hlinkClr xmlns:ahyp="http://schemas.microsoft.com/office/drawing/2018/hyperlinkcolor" val="tx"/>
-                    </a:ext>
-                  </a:extLst>
-                </a:hlinkClick>
-              </a:rPr>
-              <a:t>기부금 세제 (찾기쉬운 생활법령)</a:t>
+              <a:t>법인세법 제24조 (국가법령정보센터)</a:t>
             </a:r>
             <a:endParaRPr lang="en-US" sz="1000" dirty="0"/>
           </a:p>
@@ -27833,7 +27911,7 @@
                             <a:schemeClr val="tx1"/>
                           </a:solidFill>
                         </a:rPr>
-                        <a:t>누적 50만 대(2012 인터뷰), 초기 2년 3.5만 대(사례 자료)</a:t>
+                        <a:t>누적 50만 대 이상(2012 창업자 인터뷰 보도)</a:t>
                       </a:r>
                       <a:endParaRPr lang="en-US" sz="1300" dirty="0"/>
                     </a:p>
@@ -28693,7 +28771,7 @@
                             <a:schemeClr val="tx1"/>
                           </a:solidFill>
                         </a:rPr>
-                        <a:t>ZEEQ 예정가 $299, Sunrise $199</a:t>
+                        <a:t>ZEEQ 예정가 $299, Sunrise $199(리뷰 보도)</a:t>
                       </a:r>
                       <a:endParaRPr lang="en-US" sz="1300" dirty="0"/>
                     </a:p>
@@ -29819,7 +29897,7 @@
                   <a:schemeClr val="tx1"/>
                 </a:solidFill>
               </a:rPr>
-              <a:t>약 5조원</a:t>
+              <a:t>$140~200M</a:t>
             </a:r>
             <a:endParaRPr lang="en-US" sz="2100" dirty="0"/>
           </a:p>
@@ -29855,7 +29933,7 @@
                   <a:schemeClr val="tx1"/>
                 </a:solidFill>
               </a:rPr>
-              <a:t>국내 수면 산업 (2025 추정)</a:t>
+              <a:t>Hatch 연 매출</a:t>
             </a:r>
             <a:endParaRPr lang="en-US" sz="1600" dirty="0"/>
           </a:p>
@@ -29891,7 +29969,7 @@
                   <a:schemeClr val="tx2"/>
                 </a:solidFill>
               </a:rPr>
-              <a:t>한국수면산업협회 인용 추정치(2011년 4,800억원). 산정 기준이 불분명합니다.</a:t>
+              <a:t>비공개 기업의 언론 보도 수치(Modern Retail 약 $140M, 더 최근 보도 약 $200M). 회사 전체 매출입니다.</a:t>
             </a:r>
             <a:endParaRPr lang="en-US" sz="1400" dirty="0"/>
           </a:p>
@@ -29927,7 +30005,7 @@
                   <a:schemeClr val="tx2"/>
                 </a:solidFill>
               </a:rPr>
-              <a:t>시장조사 업체의 전망치는 정의와 기준 연도가 달라 서로 비교할 수 없습니다. 국내 베개 시장 규모 자료는 찾지 못했고, 세계 일반 베개 평균가는 약 $11.3입니다(Technavio, 2024).</a:t>
+              <a:t>시장조사 업체의 전망치는 정의와 기준 연도가 달라 서로 비교할 수 없으며 참고용입니다. 국내 베개·수면 시장 규모는 신뢰할 자료를 찾지 못해 제외했습니다.</a:t>
             </a:r>
             <a:endParaRPr lang="en-US" sz="1300" dirty="0"/>
           </a:p>
@@ -30158,7 +30236,7 @@
                   <a:schemeClr val="tx1"/>
                 </a:solidFill>
               </a:rPr>
-              <a:t>$0.9M ~ $4.2M</a:t>
+              <a:t>연 평균 약 $4M (추정)</a:t>
             </a:r>
             <a:endParaRPr lang="en-US" sz="2600" dirty="0"/>
           </a:p>
@@ -30194,7 +30272,7 @@
                   <a:schemeClr val="tx2"/>
                 </a:solidFill>
               </a:rPr>
-              <a:t>약 13억~59억원. 2년 3.5만 대 → 연 $0.9M, 3년 13만 대 → 연 $2.2M, 누적 50만 대 ÷ 약 6년 → 연 $4.2M. 출처 간 편차가 큽니다.</a:t>
+              <a:t>약 59억원. 누적 50만 대 이상(2012 창업자 인터뷰 보도) ÷ 약 6년(2006~07년 출시 후) × 출시가 $50. 소매가 기준 상한 추정입니다.</a:t>
             </a:r>
             <a:endParaRPr lang="en-US" sz="1400" dirty="0"/>
           </a:p>
@@ -30329,7 +30407,7 @@
                   <a:schemeClr val="tx2"/>
                 </a:solidFill>
               </a:rPr>
-              <a:t>약 1,960억~2,800억원. 2023년 약 $140M(Modern Retail), 이후 연 $200M(Inc 계열 보도). 비공개 기업의 회사 전체 매출입니다.</a:t>
+              <a:t>약 1,960억~2,800억원. Modern Retail 보도 약 $140M, 더 최근 Inc 계열 보도 약 $200M. 비공개 기업의 회사 전체 매출입니다.</a:t>
             </a:r>
             <a:endParaRPr lang="en-US" sz="1400" dirty="0"/>
           </a:p>
@@ -32071,7 +32149,7 @@
                   <a:schemeClr val="tx2"/>
                 </a:solidFill>
               </a:rPr>
-              <a:t>공개 재무자료가 없어 비중은 가정입니다. 참고: Kindle 2 분해 시 재료·제조비 ≈ 소비자가의 51%, 아마존 전자제품 수수료 8%, 전자제품 반품률 8~12%.</a:t>
+              <a:t>공개 재무자료가 없어 비중은 가정입니다. 참고: Kindle 2 분해 시 재료·제조비는 소비자가의 약 51%(iSuppli, 2009).</a:t>
             </a:r>
             <a:endParaRPr lang="en-US" sz="1200" dirty="0"/>
           </a:p>

</xml_diff>

<commit_message>
Clarify Hatch revenue is company-wide and sources conflict; remove unverified unit claim
Co-Authored-By: Claude Sonnet 5.5 <noreply@anthropic.com>
Claude-Session: https://claude.ai/code/session_01C8esidZTnz37pFUEU5sMqP
</commit_message>
<xml_diff>
--- a/MorningHands_Business_Analysis.pptx
+++ b/MorningHands_Business_Analysis.pptx
@@ -131,17 +131,17 @@
   <p:extLst>
     <p:ext uri="{521415D9-36F7-43E2-AB2F-B90AF26B5E84}">
       <p14:sectionLst xmlns:p14="http://schemas.microsoft.com/office/powerpoint/2010/main">
-        <p14:section name="표지" id="{ff7f5edb-ba6d-a4aa-b5ae-652473b475aa}">
+        <p14:section name="표지" id="{46aea3e6-f5d5-b399-3ce7-0dcc820cc9a2}">
           <p14:sldIdLst>
             <p14:sldId id="256"/>
           </p14:sldIdLst>
         </p14:section>
-        <p14:section name="요약" id="{b78b4365-d07e-d855-393e-12999f01cdfe}">
+        <p14:section name="요약" id="{f502b445-0bf7-3f1e-c274-e087991ea403}">
           <p14:sldIdLst>
             <p14:sldId id="257"/>
           </p14:sldIdLst>
         </p14:section>
-        <p14:section name="1부 경쟁 제품 조사" id="{f8476676-d0fd-8141-00ed-49d5bc4390d4}">
+        <p14:section name="1부 경쟁 제품 조사" id="{b299b710-6508-0e31-bcce-cc11022222a3}">
           <p14:sldIdLst>
             <p14:sldId id="258"/>
             <p14:sldId id="259"/>
@@ -153,7 +153,7 @@
             <p14:sldId id="265"/>
           </p14:sldIdLst>
         </p14:section>
-        <p14:section name="2부 우리 제품 매출 예상" id="{da9a3c03-5869-9e91-a957-d65082413ac7}">
+        <p14:section name="2부 우리 제품 매출 예상" id="{88d72778-56f1-817c-361c-d5611233d216}">
           <p14:sldIdLst>
             <p14:sldId id="266"/>
             <p14:sldId id="267"/>
@@ -164,7 +164,7 @@
             <p14:sldId id="272"/>
           </p14:sldIdLst>
         </p14:section>
-        <p14:section name="3부 사회 환원" id="{6e2cdf35-b971-df0a-376f-21beac11c4b2}">
+        <p14:section name="3부 사회 환원" id="{cc7d5991-2551-eeff-0087-7b5a36ab895f}">
           <p14:sldIdLst>
             <p14:sldId id="273"/>
             <p14:sldId id="274"/>
@@ -172,12 +172,12 @@
             <p14:sldId id="276"/>
           </p14:sldIdLst>
         </p14:section>
-        <p14:section name="리스크" id="{d39cd6af-b8a9-6abb-add1-57bc1cc753a7}">
+        <p14:section name="리스크" id="{551916d2-e812-3831-bc67-f442ebfa7de9}">
           <p14:sldIdLst>
             <p14:sldId id="277"/>
           </p14:sldIdLst>
         </p14:section>
-        <p14:section name="실행 계획" id="{07da6449-6785-19aa-9e92-ee7889c3cc48}">
+        <p14:section name="실행 계획" id="{8611fa74-54cb-c79a-0f6d-5eaf082942c7}">
           <p14:sldIdLst>
             <p14:sldId id="278"/>
             <p14:sldId id="279"/>
@@ -2436,7 +2436,7 @@
           <a:p>
             <a:r>
               <a:rPr lang="en-US" dirty="0"/>
-              <a:t>동일한 상용 제품은 확인되지 않았고, 깨우는 방식이 비슷한 제품을 비교했습니다. Hatch 매출은 언론 보도 수치입니다.</a:t>
+              <a:t>동일한 상용 제품은 확인되지 않았고, 깨우는 방식이 비슷한 제품을 비교했습니다. Hatch 매출은 회사 전체 기준 보도 수치입니다.</a:t>
             </a:r>
             <a:endParaRPr lang="en-US" dirty="0"/>
           </a:p>
@@ -16176,7 +16176,7 @@
                   <a:schemeClr val="tx2"/>
                 </a:solidFill>
               </a:rPr>
-              <a:t>Clocky 연 평균 약 $4M(추정), Hatch 연 약 $140~200M(언론 보도). 재료비와 제작 인건비는 소비자가의 약 30%로 가정했습니다.</a:t>
+              <a:t>Clocky 연 평균 약 $4M(추정), Hatch 회사 전체 연 약 $140~200M(보도마다 다름). 재료비와 제작 인건비는 소비자가의 약 30%로 가정했습니다.</a:t>
             </a:r>
             <a:endParaRPr lang="en-US" sz="1400" dirty="0"/>
           </a:p>
@@ -22476,7 +22476,7 @@
                             <a:schemeClr val="tx1"/>
                           </a:solidFill>
                         </a:rPr>
-                        <a:t>언론 보도 $140~200M, 비공개 기업</a:t>
+                        <a:t>회사 전체 매출 보도 $140~200M, 보도 간 불일치</a:t>
                       </a:r>
                       <a:endParaRPr lang="en-US" sz="1300" dirty="0"/>
                     </a:p>
@@ -22534,10 +22534,10 @@
                       <a:r>
                         <a:rPr lang="en-US" sz="1300" b="1" dirty="0">
                           <a:solidFill>
-                            <a:schemeClr val="tx1"/>
+                            <a:schemeClr val="accent4"/>
                           </a:solidFill>
                         </a:rPr>
-                        <a:t>중</a:t>
+                        <a:t>낮음</a:t>
                       </a:r>
                       <a:endParaRPr lang="en-US" sz="1300" dirty="0"/>
                     </a:p>
@@ -22598,7 +22598,7 @@
                             <a:schemeClr val="tx1"/>
                           </a:solidFill>
                         </a:rPr>
-                        <a:t>최신 보도 재확인</a:t>
+                        <a:t>참고용으로만 사용</a:t>
                       </a:r>
                       <a:endParaRPr lang="en-US" sz="1300" dirty="0"/>
                     </a:p>
@@ -28525,7 +28525,7 @@
                             <a:schemeClr val="tx1"/>
                           </a:solidFill>
                         </a:rPr>
-                        <a:t>회사 연 매출 약 $140~200M(언론 보도), 누적 50만 대 이상</a:t>
+                        <a:t>회사 전체 연 매출 $140~200M 보도(보도마다 다름)</a:t>
                       </a:r>
                       <a:endParaRPr lang="en-US" sz="1300" dirty="0"/>
                     </a:p>
@@ -29933,7 +29933,7 @@
                   <a:schemeClr val="tx1"/>
                 </a:solidFill>
               </a:rPr>
-              <a:t>Hatch 연 매출</a:t>
+              <a:t>Hatch 회사 전체 매출</a:t>
             </a:r>
             <a:endParaRPr lang="en-US" sz="1600" dirty="0"/>
           </a:p>
@@ -29969,7 +29969,7 @@
                   <a:schemeClr val="tx2"/>
                 </a:solidFill>
               </a:rPr>
-              <a:t>비공개 기업의 언론 보도 수치(Modern Retail 약 $140M, 더 최근 보도 약 $200M). 회사 전체 매출입니다.</a:t>
+              <a:t>보도마다 다름(Modern Retail 약 $140M, Inc 계열 약 $200M). 아기 제품 포함, 수면 시계만의 매출은 미확인.</a:t>
             </a:r>
             <a:endParaRPr lang="en-US" sz="1400" dirty="0"/>
           </a:p>
@@ -30407,7 +30407,7 @@
                   <a:schemeClr val="tx2"/>
                 </a:solidFill>
               </a:rPr>
-              <a:t>약 1,960억~2,800억원. Modern Retail 보도 약 $140M, 더 최근 Inc 계열 보도 약 $200M. 비공개 기업의 회사 전체 매출입니다.</a:t>
+              <a:t>약 1,960억~2,800억원. 보도마다 다르고 아기 제품을 포함한 회사 전체 매출입니다. 수면 시계만의 매출은 미확인.</a:t>
             </a:r>
             <a:endParaRPr lang="en-US" sz="1400" dirty="0"/>
           </a:p>
@@ -30745,7 +30745,7 @@
                             <a:schemeClr val="bg1"/>
                           </a:solidFill>
                         </a:rPr>
-                        <a:t>Hatch형 ($140M)</a:t>
+                        <a:t>Hatch형 (회사 전체, 약 $140M)</a:t>
                       </a:r>
                       <a:endParaRPr lang="en-US" sz="1300" dirty="0"/>
                     </a:p>

</xml_diff>

<commit_message>
Verify Hatch revenue years and corporate donation limit from primary sources; update decks
Co-Authored-By: Claude Sonnet 5.5 <noreply@anthropic.com>
Claude-Session: https://claude.ai/code/session_01C8esidZTnz37pFUEU5sMqP
</commit_message>
<xml_diff>
--- a/MorningHands_Business_Analysis.pptx
+++ b/MorningHands_Business_Analysis.pptx
@@ -131,17 +131,17 @@
   <p:extLst>
     <p:ext uri="{521415D9-36F7-43E2-AB2F-B90AF26B5E84}">
       <p14:sectionLst xmlns:p14="http://schemas.microsoft.com/office/powerpoint/2010/main">
-        <p14:section name="표지" id="{46aea3e6-f5d5-b399-3ce7-0dcc820cc9a2}">
+        <p14:section name="표지" id="{7d7a32e1-aea4-a7cc-4652-e1d5801b6d7c}">
           <p14:sldIdLst>
             <p14:sldId id="256"/>
           </p14:sldIdLst>
         </p14:section>
-        <p14:section name="요약" id="{f502b445-0bf7-3f1e-c274-e087991ea403}">
+        <p14:section name="요약" id="{482d0ca6-e92e-eff9-93c3-206e0a2bdb62}">
           <p14:sldIdLst>
             <p14:sldId id="257"/>
           </p14:sldIdLst>
         </p14:section>
-        <p14:section name="1부 경쟁 제품 조사" id="{b299b710-6508-0e31-bcce-cc11022222a3}">
+        <p14:section name="1부 경쟁 제품 조사" id="{ba302969-fd6a-0aa4-8b49-e851df376cc1}">
           <p14:sldIdLst>
             <p14:sldId id="258"/>
             <p14:sldId id="259"/>
@@ -153,7 +153,7 @@
             <p14:sldId id="265"/>
           </p14:sldIdLst>
         </p14:section>
-        <p14:section name="2부 우리 제품 매출 예상" id="{88d72778-56f1-817c-361c-d5611233d216}">
+        <p14:section name="2부 우리 제품 매출 예상" id="{c66de1d8-a65e-06ea-50d8-ea7d0ff49a77}">
           <p14:sldIdLst>
             <p14:sldId id="266"/>
             <p14:sldId id="267"/>
@@ -164,7 +164,7 @@
             <p14:sldId id="272"/>
           </p14:sldIdLst>
         </p14:section>
-        <p14:section name="3부 사회 환원" id="{cc7d5991-2551-eeff-0087-7b5a36ab895f}">
+        <p14:section name="3부 사회 환원" id="{fea315d6-824b-2b1e-8df9-99b94c5e7c65}">
           <p14:sldIdLst>
             <p14:sldId id="273"/>
             <p14:sldId id="274"/>
@@ -172,12 +172,12 @@
             <p14:sldId id="276"/>
           </p14:sldIdLst>
         </p14:section>
-        <p14:section name="리스크" id="{551916d2-e812-3831-bc67-f442ebfa7de9}">
+        <p14:section name="리스크" id="{d5168f24-a92e-4e25-76ab-d7df3452a5e0}">
           <p14:sldIdLst>
             <p14:sldId id="277"/>
           </p14:sldIdLst>
         </p14:section>
-        <p14:section name="실행 계획" id="{8611fa74-54cb-c79a-0f6d-5eaf082942c7}">
+        <p14:section name="실행 계획" id="{f099f7e4-7ae9-c3aa-b7ab-effe04946cfb}">
           <p14:sldIdLst>
             <p14:sldId id="278"/>
             <p14:sldId id="279"/>
@@ -15884,7 +15884,7 @@
                   <a:schemeClr val="tx2"/>
                 </a:solidFill>
               </a:rPr>
-              <a:t>기부금은 한도 내에서만 비용으로 인정하고 초과분은 10년 이월(법인세법 제24조). 한도율과 현물 기부의 부가세는 세무사 확인</a:t>
+              <a:t>일반기부금 한도는 (소득금액−결손금 등)의 10%(사회적기업 30%), 초과분은 10년 이월(법인세법 제24조). 현물 기부의 부가세는 확인 필요</a:t>
             </a:r>
             <a:endParaRPr lang="en-US" sz="1200" dirty="0"/>
           </a:p>
@@ -16176,7 +16176,7 @@
                   <a:schemeClr val="tx2"/>
                 </a:solidFill>
               </a:rPr>
-              <a:t>Clocky 연 평균 약 $4M(추정), Hatch 회사 전체 연 약 $140~200M(보도마다 다름). 재료비와 제작 인건비는 소비자가의 약 30%로 가정했습니다.</a:t>
+              <a:t>Clocky 연 평균 약 $4M(추정), Hatch 회사 전체 연 약 $140~200M(언론 보도). 재료비와 제작 인건비는 소비자가의 약 30%로 가정했습니다.</a:t>
             </a:r>
             <a:endParaRPr lang="en-US" sz="1400" dirty="0"/>
           </a:p>
@@ -22476,7 +22476,7 @@
                             <a:schemeClr val="tx1"/>
                           </a:solidFill>
                         </a:rPr>
-                        <a:t>회사 전체 매출 보도 $140~200M, 보도 간 불일치</a:t>
+                        <a:t>언론 보도 2건(2023년 $140M, 최근 $200M), 비공개 기업</a:t>
                       </a:r>
                       <a:endParaRPr lang="en-US" sz="1300" dirty="0"/>
                     </a:p>
@@ -22534,10 +22534,10 @@
                       <a:r>
                         <a:rPr lang="en-US" sz="1300" b="1" dirty="0">
                           <a:solidFill>
-                            <a:schemeClr val="accent4"/>
+                            <a:schemeClr val="tx1"/>
                           </a:solidFill>
                         </a:rPr>
-                        <a:t>낮음</a:t>
+                        <a:t>중</a:t>
                       </a:r>
                       <a:endParaRPr lang="en-US" sz="1300" dirty="0"/>
                     </a:p>
@@ -22598,7 +22598,7 @@
                             <a:schemeClr val="tx1"/>
                           </a:solidFill>
                         </a:rPr>
-                        <a:t>참고용으로만 사용</a:t>
+                        <a:t>수면 시계 단독 매출은 미확인</a:t>
                       </a:r>
                       <a:endParaRPr lang="en-US" sz="1300" dirty="0"/>
                     </a:p>
@@ -24198,7 +24198,7 @@
                             <a:schemeClr val="tx1"/>
                           </a:solidFill>
                         </a:rPr>
-                        <a:t>제24조 원문: 한도 내 인정, 10년 이월</a:t>
+                        <a:t>제24조 원문(2026.1.1 시행): 한도 10%, 10년 이월</a:t>
                       </a:r>
                       <a:endParaRPr lang="en-US" sz="1300" dirty="0"/>
                     </a:p>
@@ -24320,7 +24320,7 @@
                             <a:schemeClr val="tx1"/>
                           </a:solidFill>
                         </a:rPr>
-                        <a:t>한도율·현물 부가세는 세무사</a:t>
+                        <a:t>현물 부가세는 세무사 확인</a:t>
                       </a:r>
                       <a:endParaRPr lang="en-US" sz="1300" dirty="0"/>
                     </a:p>
@@ -24380,8 +24380,8 @@
         </p:nvSpPr>
         <p:spPr>
           <a:xfrm>
-            <a:off x="548640" y="6126480"/>
-            <a:ext cx="11091672" cy="274320"/>
+            <a:off x="548640" y="6199632"/>
+            <a:ext cx="11091672" cy="228600"/>
           </a:xfrm>
           <a:prstGeom prst="rect">
             <a:avLst/>
@@ -24397,14 +24397,14 @@
               <a:buNone/>
             </a:pPr>
             <a:r>
-              <a:rPr lang="en-US" sz="1200" dirty="0">
+              <a:rPr lang="en-US" sz="1100" dirty="0">
                 <a:solidFill>
                   <a:schemeClr val="tx2"/>
                 </a:solidFill>
               </a:rPr>
               <a:t>영업이익은 법인세·감가상각 반영 전 수치이며, 현금흐름표는 포함하지 않았습니다.</a:t>
             </a:r>
-            <a:endParaRPr lang="en-US" sz="1200" dirty="0"/>
+            <a:endParaRPr lang="en-US" sz="1100" dirty="0"/>
           </a:p>
         </p:txBody>
       </p:sp>
@@ -24658,7 +24658,7 @@
                   <a:schemeClr val="tx1"/>
                 </a:solidFill>
               </a:rPr>
-              <a:t>세법은 법인세법 제24조 원문 확인(한도율·현물 부가세는 세무사 확인 필요)</a:t>
+              <a:t>세법은 법인세법 제24조 원문 확인(2026.1.1 시행). 현물 기부의 부가세는 세무사 확인 필요</a:t>
             </a:r>
             <a:endParaRPr lang="en-US" sz="1300" dirty="0"/>
           </a:p>
@@ -28525,7 +28525,7 @@
                             <a:schemeClr val="tx1"/>
                           </a:solidFill>
                         </a:rPr>
-                        <a:t>회사 전체 연 매출 $140~200M 보도(보도마다 다름)</a:t>
+                        <a:t>회사 전체 매출 2023년 약 $140M → 최근 연 약 $200M 보도</a:t>
                       </a:r>
                       <a:endParaRPr lang="en-US" sz="1300" dirty="0"/>
                     </a:p>
@@ -29969,7 +29969,7 @@
                   <a:schemeClr val="tx2"/>
                 </a:solidFill>
               </a:rPr>
-              <a:t>보도마다 다름(Modern Retail 약 $140M, Inc 계열 약 $200M). 아기 제품 포함, 수면 시계만의 매출은 미확인.</a:t>
+              <a:t>2023년 약 $140M(Modern Retail), 최근 연 약 $200M(Inc 인용 IBTimes). 아기 제품 포함, 수면 시계만의 매출은 미확인.</a:t>
             </a:r>
             <a:endParaRPr lang="en-US" sz="1400" dirty="0"/>
           </a:p>
@@ -30407,7 +30407,7 @@
                   <a:schemeClr val="tx2"/>
                 </a:solidFill>
               </a:rPr>
-              <a:t>약 1,960억~2,800억원. 보도마다 다르고 아기 제품을 포함한 회사 전체 매출입니다. 수면 시계만의 매출은 미확인.</a:t>
+              <a:t>약 1,960억~2,800억원. 2023년 약 $140M(Modern Retail, 2024.5) → 최근 연 약 $200M(IBTimes, 2026.5). 아기 제품 포함, 수면 시계만의 매출은 미확인.</a:t>
             </a:r>
             <a:endParaRPr lang="en-US" sz="1400" dirty="0"/>
           </a:p>

</xml_diff>

<commit_message>
Update reliability table with Wikipedia and Shark Tank blog findings
Co-Authored-By: Claude Sonnet 5.5 <noreply@anthropic.com>
Claude-Session: https://claude.ai/code/session_01C8esidZTnz37pFUEU5sMqP
</commit_message>
<xml_diff>
--- a/MorningHands_Business_Analysis.pptx
+++ b/MorningHands_Business_Analysis.pptx
@@ -131,17 +131,17 @@
   <p:extLst>
     <p:ext uri="{521415D9-36F7-43E2-AB2F-B90AF26B5E84}">
       <p14:sectionLst xmlns:p14="http://schemas.microsoft.com/office/powerpoint/2010/main">
-        <p14:section name="표지" id="{7d7a32e1-aea4-a7cc-4652-e1d5801b6d7c}">
+        <p14:section name="표지" id="{f4a239ba-2ffa-786b-832f-57ed792005ef}">
           <p14:sldIdLst>
             <p14:sldId id="256"/>
           </p14:sldIdLst>
         </p14:section>
-        <p14:section name="요약" id="{482d0ca6-e92e-eff9-93c3-206e0a2bdb62}">
+        <p14:section name="요약" id="{ce965c95-d2ca-5bee-47f7-7978200f1a10}">
           <p14:sldIdLst>
             <p14:sldId id="257"/>
           </p14:sldIdLst>
         </p14:section>
-        <p14:section name="1부 경쟁 제품 조사" id="{ba302969-fd6a-0aa4-8b49-e851df376cc1}">
+        <p14:section name="1부 경쟁 제품 조사" id="{e86c04cd-266a-e5ec-3e7b-d34a3b9286ce}">
           <p14:sldIdLst>
             <p14:sldId id="258"/>
             <p14:sldId id="259"/>
@@ -153,7 +153,7 @@
             <p14:sldId id="265"/>
           </p14:sldIdLst>
         </p14:section>
-        <p14:section name="2부 우리 제품 매출 예상" id="{c66de1d8-a65e-06ea-50d8-ea7d0ff49a77}">
+        <p14:section name="2부 우리 제품 매출 예상" id="{4a011b48-905c-e1a1-2e51-a52051817367}">
           <p14:sldIdLst>
             <p14:sldId id="266"/>
             <p14:sldId id="267"/>
@@ -164,7 +164,7 @@
             <p14:sldId id="272"/>
           </p14:sldIdLst>
         </p14:section>
-        <p14:section name="3부 사회 환원" id="{fea315d6-824b-2b1e-8df9-99b94c5e7c65}">
+        <p14:section name="3부 사회 환원" id="{7d5bf116-9037-3ed3-58ee-4ae54bd93a8f}">
           <p14:sldIdLst>
             <p14:sldId id="273"/>
             <p14:sldId id="274"/>
@@ -172,12 +172,12 @@
             <p14:sldId id="276"/>
           </p14:sldIdLst>
         </p14:section>
-        <p14:section name="리스크" id="{d5168f24-a92e-4e25-76ab-d7df3452a5e0}">
+        <p14:section name="리스크" id="{cd97f32b-cc8d-583a-a834-eae96557f845}">
           <p14:sldIdLst>
             <p14:sldId id="277"/>
           </p14:sldIdLst>
         </p14:section>
-        <p14:section name="실행 계획" id="{f099f7e4-7ae9-c3aa-b7ab-effe04946cfb}">
+        <p14:section name="실행 계획" id="{0b3170e2-162a-33ae-552e-f3d67f8247a5}">
           <p14:sldIdLst>
             <p14:sldId id="278"/>
             <p14:sldId id="279"/>
@@ -22230,7 +22230,7 @@
                             <a:schemeClr val="tx1"/>
                           </a:solidFill>
                         </a:rPr>
-                        <a:t>창업자 인터뷰 보도, 판매 시점 불명확</a:t>
+                        <a:t>위키백과: 2012.10 인터뷰 50만 대 이상</a:t>
                       </a:r>
                       <a:endParaRPr lang="en-US" sz="1300" dirty="0"/>
                     </a:p>
@@ -22476,7 +22476,7 @@
                             <a:schemeClr val="tx1"/>
                           </a:solidFill>
                         </a:rPr>
-                        <a:t>언론 보도 2건(2023년 $140M, 최근 $200M), 비공개 기업</a:t>
+                        <a:t>언론 2건($140M·$200M), 블로그($6.9M)와 상충</a:t>
                       </a:r>
                       <a:endParaRPr lang="en-US" sz="1300" dirty="0"/>
                     </a:p>
@@ -23460,7 +23460,7 @@
                             <a:schemeClr val="tx1"/>
                           </a:solidFill>
                         </a:rPr>
-                        <a:t>와디즈 공식 요금제(2026.2), 스토어·쿠팡은 비교 자료</a:t>
+                        <a:t>와디즈 공식 요금제, 스토어·쿠팡은 비교 자료</a:t>
                       </a:r>
                       <a:endParaRPr lang="en-US" sz="1300" dirty="0"/>
                     </a:p>

</xml_diff>